<commit_message>
Update Python 4P venv slides
</commit_message>
<xml_diff>
--- a/python_course_4p/1_venv_package/1_venv_package.pptx
+++ b/python_course_4p/1_venv_package/1_venv_package.pptx
@@ -5,7 +5,7 @@
     <p:sldMasterId id="2147483648" r:id="rId1"/>
   </p:sldMasterIdLst>
   <p:notesMasterIdLst>
-    <p:notesMasterId r:id="rId42"/>
+    <p:notesMasterId r:id="rId43"/>
   </p:notesMasterIdLst>
   <p:sldIdLst>
     <p:sldId id="256" r:id="rId2"/>
@@ -40,14 +40,15 @@
     <p:sldId id="374" r:id="rId31"/>
     <p:sldId id="362" r:id="rId32"/>
     <p:sldId id="375" r:id="rId33"/>
-    <p:sldId id="359" r:id="rId34"/>
-    <p:sldId id="266" r:id="rId35"/>
-    <p:sldId id="299" r:id="rId36"/>
-    <p:sldId id="278" r:id="rId37"/>
-    <p:sldId id="279" r:id="rId38"/>
-    <p:sldId id="281" r:id="rId39"/>
-    <p:sldId id="282" r:id="rId40"/>
-    <p:sldId id="351" r:id="rId41"/>
+    <p:sldId id="376" r:id="rId34"/>
+    <p:sldId id="359" r:id="rId35"/>
+    <p:sldId id="266" r:id="rId36"/>
+    <p:sldId id="299" r:id="rId37"/>
+    <p:sldId id="278" r:id="rId38"/>
+    <p:sldId id="279" r:id="rId39"/>
+    <p:sldId id="281" r:id="rId40"/>
+    <p:sldId id="282" r:id="rId41"/>
+    <p:sldId id="351" r:id="rId42"/>
   </p:sldIdLst>
   <p:sldSz cx="12192000" cy="6858000"/>
   <p:notesSz cx="6858000" cy="9144000"/>
@@ -236,7 +237,7 @@
           <a:p>
             <a:fld id="{3BADDCAA-88FC-44D4-A91A-DD0530AB88E0}" type="datetimeFigureOut">
               <a:rPr lang="en-NL" smtClean="0"/>
-              <a:t>16/09/2026</a:t>
+              <a:t>17/09/2026</a:t>
             </a:fld>
             <a:endParaRPr lang="en-NL"/>
           </a:p>
@@ -667,7 +668,31 @@
           <a:bodyPr/>
           <a:lstStyle/>
           <a:p>
-            <a:endParaRPr lang="en-NL" dirty="0"/>
+            <a:r>
+              <a:rPr lang="en-US" dirty="0"/>
+              <a:t>Demo: package </a:t>
+            </a:r>
+            <a:r>
+              <a:rPr lang="en-US" dirty="0" err="1"/>
+              <a:t>opzetten</a:t>
+            </a:r>
+            <a:r>
+              <a:rPr lang="en-US" dirty="0"/>
+              <a:t> </a:t>
+            </a:r>
+            <a:r>
+              <a:rPr lang="en-US" dirty="0" err="1"/>
+              <a:t>en</a:t>
+            </a:r>
+            <a:r>
+              <a:rPr lang="en-US" dirty="0"/>
+              <a:t> </a:t>
+            </a:r>
+            <a:r>
+              <a:rPr lang="en-US"/>
+              <a:t>gebruiken</a:t>
+            </a:r>
+            <a:endParaRPr lang="en-NL"/>
           </a:p>
         </p:txBody>
       </p:sp>
@@ -688,7 +713,91 @@
           <a:p>
             <a:fld id="{4BAF0DEA-1372-46C0-8FC9-2869E9CCF7DA}" type="slidenum">
               <a:rPr lang="en-NL" smtClean="0"/>
-              <a:t>37</a:t>
+              <a:t>33</a:t>
+            </a:fld>
+            <a:endParaRPr lang="en-NL"/>
+          </a:p>
+        </p:txBody>
+      </p:sp>
+    </p:spTree>
+    <p:extLst>
+      <p:ext uri="{BB962C8B-B14F-4D97-AF65-F5344CB8AC3E}">
+        <p14:creationId xmlns:p14="http://schemas.microsoft.com/office/powerpoint/2010/main" val="3502637254"/>
+      </p:ext>
+    </p:extLst>
+  </p:cSld>
+  <p:clrMapOvr>
+    <a:masterClrMapping/>
+  </p:clrMapOvr>
+</p:notes>
+</file>
+
+<file path=ppt/notesSlides/notesSlide3.xml><?xml version="1.0" encoding="utf-8"?>
+<p:notes xmlns:a="http://schemas.openxmlformats.org/drawingml/2006/main" xmlns:r="http://schemas.openxmlformats.org/officeDocument/2006/relationships" xmlns:p="http://schemas.openxmlformats.org/presentationml/2006/main">
+  <p:cSld>
+    <p:spTree>
+      <p:nvGrpSpPr>
+        <p:cNvPr id="1" name=""/>
+        <p:cNvGrpSpPr/>
+        <p:nvPr/>
+      </p:nvGrpSpPr>
+      <p:grpSpPr>
+        <a:xfrm>
+          <a:off x="0" y="0"/>
+          <a:ext cx="0" cy="0"/>
+          <a:chOff x="0" y="0"/>
+          <a:chExt cx="0" cy="0"/>
+        </a:xfrm>
+      </p:grpSpPr>
+      <p:sp>
+        <p:nvSpPr>
+          <p:cNvPr id="2" name="Slide Image Placeholder 1"/>
+          <p:cNvSpPr>
+            <a:spLocks noGrp="1" noRot="1" noChangeAspect="1"/>
+          </p:cNvSpPr>
+          <p:nvPr>
+            <p:ph type="sldImg"/>
+          </p:nvPr>
+        </p:nvSpPr>
+        <p:spPr/>
+      </p:sp>
+      <p:sp>
+        <p:nvSpPr>
+          <p:cNvPr id="3" name="Notes Placeholder 2"/>
+          <p:cNvSpPr>
+            <a:spLocks noGrp="1"/>
+          </p:cNvSpPr>
+          <p:nvPr>
+            <p:ph type="body" idx="1"/>
+          </p:nvPr>
+        </p:nvSpPr>
+        <p:spPr/>
+        <p:txBody>
+          <a:bodyPr/>
+          <a:lstStyle/>
+          <a:p>
+            <a:endParaRPr lang="en-NL" dirty="0"/>
+          </a:p>
+        </p:txBody>
+      </p:sp>
+      <p:sp>
+        <p:nvSpPr>
+          <p:cNvPr id="4" name="Slide Number Placeholder 3"/>
+          <p:cNvSpPr>
+            <a:spLocks noGrp="1"/>
+          </p:cNvSpPr>
+          <p:nvPr>
+            <p:ph type="sldNum" sz="quarter" idx="5"/>
+          </p:nvPr>
+        </p:nvSpPr>
+        <p:spPr/>
+        <p:txBody>
+          <a:bodyPr/>
+          <a:lstStyle/>
+          <a:p>
+            <a:fld id="{4BAF0DEA-1372-46C0-8FC9-2869E9CCF7DA}" type="slidenum">
+              <a:rPr lang="en-NL" smtClean="0"/>
+              <a:t>38</a:t>
             </a:fld>
             <a:endParaRPr lang="en-NL"/>
           </a:p>
@@ -856,7 +965,7 @@
           <a:p>
             <a:fld id="{0EBB069A-003F-4FC0-8534-236B0C5C7B5F}" type="datetimeFigureOut">
               <a:rPr lang="en-NL" smtClean="0"/>
-              <a:t>16/09/2026</a:t>
+              <a:t>17/09/2026</a:t>
             </a:fld>
             <a:endParaRPr lang="en-NL"/>
           </a:p>
@@ -1056,7 +1165,7 @@
           <a:p>
             <a:fld id="{0EBB069A-003F-4FC0-8534-236B0C5C7B5F}" type="datetimeFigureOut">
               <a:rPr lang="en-NL" smtClean="0"/>
-              <a:t>16/09/2026</a:t>
+              <a:t>17/09/2026</a:t>
             </a:fld>
             <a:endParaRPr lang="en-NL"/>
           </a:p>
@@ -1266,7 +1375,7 @@
           <a:p>
             <a:fld id="{0EBB069A-003F-4FC0-8534-236B0C5C7B5F}" type="datetimeFigureOut">
               <a:rPr lang="en-NL" smtClean="0"/>
-              <a:t>16/09/2026</a:t>
+              <a:t>17/09/2026</a:t>
             </a:fld>
             <a:endParaRPr lang="en-NL"/>
           </a:p>
@@ -1466,7 +1575,7 @@
           <a:p>
             <a:fld id="{0EBB069A-003F-4FC0-8534-236B0C5C7B5F}" type="datetimeFigureOut">
               <a:rPr lang="en-NL" smtClean="0"/>
-              <a:t>16/09/2026</a:t>
+              <a:t>17/09/2026</a:t>
             </a:fld>
             <a:endParaRPr lang="en-NL"/>
           </a:p>
@@ -1742,7 +1851,7 @@
           <a:p>
             <a:fld id="{0EBB069A-003F-4FC0-8534-236B0C5C7B5F}" type="datetimeFigureOut">
               <a:rPr lang="en-NL" smtClean="0"/>
-              <a:t>16/09/2026</a:t>
+              <a:t>17/09/2026</a:t>
             </a:fld>
             <a:endParaRPr lang="en-NL"/>
           </a:p>
@@ -2010,7 +2119,7 @@
           <a:p>
             <a:fld id="{0EBB069A-003F-4FC0-8534-236B0C5C7B5F}" type="datetimeFigureOut">
               <a:rPr lang="en-NL" smtClean="0"/>
-              <a:t>16/09/2026</a:t>
+              <a:t>17/09/2026</a:t>
             </a:fld>
             <a:endParaRPr lang="en-NL"/>
           </a:p>
@@ -2425,7 +2534,7 @@
           <a:p>
             <a:fld id="{0EBB069A-003F-4FC0-8534-236B0C5C7B5F}" type="datetimeFigureOut">
               <a:rPr lang="en-NL" smtClean="0"/>
-              <a:t>16/09/2026</a:t>
+              <a:t>17/09/2026</a:t>
             </a:fld>
             <a:endParaRPr lang="en-NL"/>
           </a:p>
@@ -2567,7 +2676,7 @@
           <a:p>
             <a:fld id="{0EBB069A-003F-4FC0-8534-236B0C5C7B5F}" type="datetimeFigureOut">
               <a:rPr lang="en-NL" smtClean="0"/>
-              <a:t>16/09/2026</a:t>
+              <a:t>17/09/2026</a:t>
             </a:fld>
             <a:endParaRPr lang="en-NL"/>
           </a:p>
@@ -2680,7 +2789,7 @@
           <a:p>
             <a:fld id="{0EBB069A-003F-4FC0-8534-236B0C5C7B5F}" type="datetimeFigureOut">
               <a:rPr lang="en-NL" smtClean="0"/>
-              <a:t>16/09/2026</a:t>
+              <a:t>17/09/2026</a:t>
             </a:fld>
             <a:endParaRPr lang="en-NL"/>
           </a:p>
@@ -2993,7 +3102,7 @@
           <a:p>
             <a:fld id="{0EBB069A-003F-4FC0-8534-236B0C5C7B5F}" type="datetimeFigureOut">
               <a:rPr lang="en-NL" smtClean="0"/>
-              <a:t>16/09/2026</a:t>
+              <a:t>17/09/2026</a:t>
             </a:fld>
             <a:endParaRPr lang="en-NL"/>
           </a:p>
@@ -3282,7 +3391,7 @@
           <a:p>
             <a:fld id="{0EBB069A-003F-4FC0-8534-236B0C5C7B5F}" type="datetimeFigureOut">
               <a:rPr lang="en-NL" smtClean="0"/>
-              <a:t>16/09/2026</a:t>
+              <a:t>17/09/2026</a:t>
             </a:fld>
             <a:endParaRPr lang="en-NL"/>
           </a:p>
@@ -3525,7 +3634,7 @@
           <a:p>
             <a:fld id="{0EBB069A-003F-4FC0-8534-236B0C5C7B5F}" type="datetimeFigureOut">
               <a:rPr lang="en-NL" smtClean="0"/>
-              <a:t>16/09/2026</a:t>
+              <a:t>17/09/2026</a:t>
             </a:fld>
             <a:endParaRPr lang="en-NL"/>
           </a:p>
@@ -15901,6 +16010,770 @@
         <p:cNvPr id="1" name="">
           <a:extLst>
             <a:ext uri="{FF2B5EF4-FFF2-40B4-BE49-F238E27FC236}">
+              <a16:creationId xmlns:a16="http://schemas.microsoft.com/office/drawing/2014/main" id="{C1A333C6-DCA1-8A0C-E60A-B8BD19419799}"/>
+            </a:ext>
+          </a:extLst>
+        </p:cNvPr>
+        <p:cNvGrpSpPr/>
+        <p:nvPr/>
+      </p:nvGrpSpPr>
+      <p:grpSpPr>
+        <a:xfrm>
+          <a:off x="0" y="0"/>
+          <a:ext cx="0" cy="0"/>
+          <a:chOff x="0" y="0"/>
+          <a:chExt cx="0" cy="0"/>
+        </a:xfrm>
+      </p:grpSpPr>
+      <p:sp>
+        <p:nvSpPr>
+          <p:cNvPr id="2" name="Title 1">
+            <a:extLst>
+              <a:ext uri="{FF2B5EF4-FFF2-40B4-BE49-F238E27FC236}">
+                <a16:creationId xmlns:a16="http://schemas.microsoft.com/office/drawing/2014/main" id="{7388D127-3F81-7035-1B77-43AEF9616C91}"/>
+              </a:ext>
+            </a:extLst>
+          </p:cNvPr>
+          <p:cNvSpPr>
+            <a:spLocks noGrp="1"/>
+          </p:cNvSpPr>
+          <p:nvPr>
+            <p:ph type="title"/>
+          </p:nvPr>
+        </p:nvSpPr>
+        <p:spPr>
+          <a:xfrm>
+            <a:off x="838200" y="365126"/>
+            <a:ext cx="10515600" cy="718608"/>
+          </a:xfrm>
+        </p:spPr>
+        <p:txBody>
+          <a:bodyPr>
+            <a:normAutofit/>
+          </a:bodyPr>
+          <a:lstStyle/>
+          <a:p>
+            <a:r>
+              <a:rPr lang="nl-NL" sz="3600" noProof="0" dirty="0"/>
+              <a:t>Package ontwikkelen</a:t>
+            </a:r>
+          </a:p>
+        </p:txBody>
+      </p:sp>
+      <p:sp>
+        <p:nvSpPr>
+          <p:cNvPr id="3" name="Content Placeholder 2">
+            <a:extLst>
+              <a:ext uri="{FF2B5EF4-FFF2-40B4-BE49-F238E27FC236}">
+                <a16:creationId xmlns:a16="http://schemas.microsoft.com/office/drawing/2014/main" id="{98034A06-9540-1B7F-EEF5-789870E4E9C7}"/>
+              </a:ext>
+            </a:extLst>
+          </p:cNvPr>
+          <p:cNvSpPr>
+            <a:spLocks noGrp="1"/>
+          </p:cNvSpPr>
+          <p:nvPr>
+            <p:ph idx="1"/>
+          </p:nvPr>
+        </p:nvSpPr>
+        <p:spPr>
+          <a:xfrm>
+            <a:off x="838198" y="1456267"/>
+            <a:ext cx="4715935" cy="4720696"/>
+          </a:xfrm>
+        </p:spPr>
+        <p:txBody>
+          <a:bodyPr>
+            <a:normAutofit/>
+          </a:bodyPr>
+          <a:lstStyle/>
+          <a:p>
+            <a:pPr marL="0" indent="0">
+              <a:buNone/>
+            </a:pPr>
+            <a:r>
+              <a:rPr lang="nl-NL" sz="2000" dirty="0"/>
+              <a:t>Bedoeling van een package is gebruik in een *ander* project.</a:t>
+            </a:r>
+          </a:p>
+          <a:p>
+            <a:pPr marL="0" indent="0">
+              <a:buNone/>
+            </a:pPr>
+            <a:endParaRPr lang="nl-NL" sz="2000" dirty="0"/>
+          </a:p>
+          <a:p>
+            <a:pPr marL="0" indent="0">
+              <a:buNone/>
+            </a:pPr>
+            <a:r>
+              <a:rPr lang="nl-NL" sz="2000" dirty="0"/>
+              <a:t>Draai de code niet in de werk directory van het package.</a:t>
+            </a:r>
+          </a:p>
+          <a:p>
+            <a:pPr marL="0" indent="0">
+              <a:buNone/>
+            </a:pPr>
+            <a:endParaRPr lang="nl-NL" sz="2000" dirty="0"/>
+          </a:p>
+          <a:p>
+            <a:pPr marL="0" indent="0">
+              <a:buNone/>
+            </a:pPr>
+            <a:r>
+              <a:rPr lang="nl-NL" sz="2000" dirty="0"/>
+              <a:t>Maak een andere virtuele omgeving aan en installeer het package daarin.</a:t>
+            </a:r>
+          </a:p>
+          <a:p>
+            <a:pPr marL="0" indent="0">
+              <a:buNone/>
+            </a:pPr>
+            <a:endParaRPr lang="nl-NL" sz="2000" dirty="0"/>
+          </a:p>
+          <a:p>
+            <a:pPr marL="0" indent="0">
+              <a:buNone/>
+            </a:pPr>
+            <a:r>
+              <a:rPr lang="nl-NL" sz="2000" dirty="0"/>
+              <a:t>Tip: gebruik een </a:t>
+            </a:r>
+            <a:r>
+              <a:rPr lang="nl-NL" sz="2000" dirty="0" err="1"/>
+              <a:t>editable</a:t>
+            </a:r>
+            <a:r>
+              <a:rPr lang="nl-NL" sz="2000" dirty="0"/>
+              <a:t> installatie.</a:t>
+            </a:r>
+          </a:p>
+          <a:p>
+            <a:pPr marL="0" indent="0">
+              <a:buNone/>
+            </a:pPr>
+            <a:endParaRPr lang="nl-NL" sz="2000" dirty="0"/>
+          </a:p>
+        </p:txBody>
+      </p:sp>
+      <p:sp>
+        <p:nvSpPr>
+          <p:cNvPr id="5" name="Content Placeholder 2">
+            <a:extLst>
+              <a:ext uri="{FF2B5EF4-FFF2-40B4-BE49-F238E27FC236}">
+                <a16:creationId xmlns:a16="http://schemas.microsoft.com/office/drawing/2014/main" id="{09A15334-44ED-7A65-1691-16DC79785FE4}"/>
+              </a:ext>
+            </a:extLst>
+          </p:cNvPr>
+          <p:cNvSpPr txBox="1">
+            <a:spLocks/>
+          </p:cNvSpPr>
+          <p:nvPr/>
+        </p:nvSpPr>
+        <p:spPr>
+          <a:xfrm>
+            <a:off x="6637869" y="1456267"/>
+            <a:ext cx="4715935" cy="4720696"/>
+          </a:xfrm>
+          <a:prstGeom prst="rect">
+            <a:avLst/>
+          </a:prstGeom>
+        </p:spPr>
+        <p:txBody>
+          <a:bodyPr vert="horz" lIns="91440" tIns="45720" rIns="91440" bIns="45720" rtlCol="0">
+            <a:normAutofit/>
+          </a:bodyPr>
+          <a:lstStyle>
+            <a:lvl1pPr marL="228600" indent="-228600" algn="l" defTabSz="914400" rtl="0" eaLnBrk="1" latinLnBrk="0" hangingPunct="1">
+              <a:lnSpc>
+                <a:spcPct val="90000"/>
+              </a:lnSpc>
+              <a:spcBef>
+                <a:spcPts val="1000"/>
+              </a:spcBef>
+              <a:buFont typeface="Arial" panose="020B0604020202020204" pitchFamily="34" charset="0"/>
+              <a:buChar char="•"/>
+              <a:defRPr sz="2800" kern="1200">
+                <a:solidFill>
+                  <a:schemeClr val="tx1"/>
+                </a:solidFill>
+                <a:latin typeface="+mn-lt"/>
+                <a:ea typeface="+mn-ea"/>
+                <a:cs typeface="+mn-cs"/>
+              </a:defRPr>
+            </a:lvl1pPr>
+            <a:lvl2pPr marL="685800" indent="-228600" algn="l" defTabSz="914400" rtl="0" eaLnBrk="1" latinLnBrk="0" hangingPunct="1">
+              <a:lnSpc>
+                <a:spcPct val="90000"/>
+              </a:lnSpc>
+              <a:spcBef>
+                <a:spcPts val="500"/>
+              </a:spcBef>
+              <a:buFont typeface="Arial" panose="020B0604020202020204" pitchFamily="34" charset="0"/>
+              <a:buChar char="•"/>
+              <a:defRPr sz="2400" kern="1200">
+                <a:solidFill>
+                  <a:schemeClr val="tx1"/>
+                </a:solidFill>
+                <a:latin typeface="+mn-lt"/>
+                <a:ea typeface="+mn-ea"/>
+                <a:cs typeface="+mn-cs"/>
+              </a:defRPr>
+            </a:lvl2pPr>
+            <a:lvl3pPr marL="1143000" indent="-228600" algn="l" defTabSz="914400" rtl="0" eaLnBrk="1" latinLnBrk="0" hangingPunct="1">
+              <a:lnSpc>
+                <a:spcPct val="90000"/>
+              </a:lnSpc>
+              <a:spcBef>
+                <a:spcPts val="500"/>
+              </a:spcBef>
+              <a:buFont typeface="Arial" panose="020B0604020202020204" pitchFamily="34" charset="0"/>
+              <a:buChar char="•"/>
+              <a:defRPr sz="2000" kern="1200">
+                <a:solidFill>
+                  <a:schemeClr val="tx1"/>
+                </a:solidFill>
+                <a:latin typeface="+mn-lt"/>
+                <a:ea typeface="+mn-ea"/>
+                <a:cs typeface="+mn-cs"/>
+              </a:defRPr>
+            </a:lvl3pPr>
+            <a:lvl4pPr marL="1600200" indent="-228600" algn="l" defTabSz="914400" rtl="0" eaLnBrk="1" latinLnBrk="0" hangingPunct="1">
+              <a:lnSpc>
+                <a:spcPct val="90000"/>
+              </a:lnSpc>
+              <a:spcBef>
+                <a:spcPts val="500"/>
+              </a:spcBef>
+              <a:buFont typeface="Arial" panose="020B0604020202020204" pitchFamily="34" charset="0"/>
+              <a:buChar char="•"/>
+              <a:defRPr sz="1800" kern="1200">
+                <a:solidFill>
+                  <a:schemeClr val="tx1"/>
+                </a:solidFill>
+                <a:latin typeface="+mn-lt"/>
+                <a:ea typeface="+mn-ea"/>
+                <a:cs typeface="+mn-cs"/>
+              </a:defRPr>
+            </a:lvl4pPr>
+            <a:lvl5pPr marL="2057400" indent="-228600" algn="l" defTabSz="914400" rtl="0" eaLnBrk="1" latinLnBrk="0" hangingPunct="1">
+              <a:lnSpc>
+                <a:spcPct val="90000"/>
+              </a:lnSpc>
+              <a:spcBef>
+                <a:spcPts val="500"/>
+              </a:spcBef>
+              <a:buFont typeface="Arial" panose="020B0604020202020204" pitchFamily="34" charset="0"/>
+              <a:buChar char="•"/>
+              <a:defRPr sz="1800" kern="1200">
+                <a:solidFill>
+                  <a:schemeClr val="tx1"/>
+                </a:solidFill>
+                <a:latin typeface="+mn-lt"/>
+                <a:ea typeface="+mn-ea"/>
+                <a:cs typeface="+mn-cs"/>
+              </a:defRPr>
+            </a:lvl5pPr>
+            <a:lvl6pPr marL="2514600" indent="-228600" algn="l" defTabSz="914400" rtl="0" eaLnBrk="1" latinLnBrk="0" hangingPunct="1">
+              <a:lnSpc>
+                <a:spcPct val="90000"/>
+              </a:lnSpc>
+              <a:spcBef>
+                <a:spcPts val="500"/>
+              </a:spcBef>
+              <a:buFont typeface="Arial" panose="020B0604020202020204" pitchFamily="34" charset="0"/>
+              <a:buChar char="•"/>
+              <a:defRPr sz="1800" kern="1200">
+                <a:solidFill>
+                  <a:schemeClr val="tx1"/>
+                </a:solidFill>
+                <a:latin typeface="+mn-lt"/>
+                <a:ea typeface="+mn-ea"/>
+                <a:cs typeface="+mn-cs"/>
+              </a:defRPr>
+            </a:lvl6pPr>
+            <a:lvl7pPr marL="2971800" indent="-228600" algn="l" defTabSz="914400" rtl="0" eaLnBrk="1" latinLnBrk="0" hangingPunct="1">
+              <a:lnSpc>
+                <a:spcPct val="90000"/>
+              </a:lnSpc>
+              <a:spcBef>
+                <a:spcPts val="500"/>
+              </a:spcBef>
+              <a:buFont typeface="Arial" panose="020B0604020202020204" pitchFamily="34" charset="0"/>
+              <a:buChar char="•"/>
+              <a:defRPr sz="1800" kern="1200">
+                <a:solidFill>
+                  <a:schemeClr val="tx1"/>
+                </a:solidFill>
+                <a:latin typeface="+mn-lt"/>
+                <a:ea typeface="+mn-ea"/>
+                <a:cs typeface="+mn-cs"/>
+              </a:defRPr>
+            </a:lvl7pPr>
+            <a:lvl8pPr marL="3429000" indent="-228600" algn="l" defTabSz="914400" rtl="0" eaLnBrk="1" latinLnBrk="0" hangingPunct="1">
+              <a:lnSpc>
+                <a:spcPct val="90000"/>
+              </a:lnSpc>
+              <a:spcBef>
+                <a:spcPts val="500"/>
+              </a:spcBef>
+              <a:buFont typeface="Arial" panose="020B0604020202020204" pitchFamily="34" charset="0"/>
+              <a:buChar char="•"/>
+              <a:defRPr sz="1800" kern="1200">
+                <a:solidFill>
+                  <a:schemeClr val="tx1"/>
+                </a:solidFill>
+                <a:latin typeface="+mn-lt"/>
+                <a:ea typeface="+mn-ea"/>
+                <a:cs typeface="+mn-cs"/>
+              </a:defRPr>
+            </a:lvl8pPr>
+            <a:lvl9pPr marL="3886200" indent="-228600" algn="l" defTabSz="914400" rtl="0" eaLnBrk="1" latinLnBrk="0" hangingPunct="1">
+              <a:lnSpc>
+                <a:spcPct val="90000"/>
+              </a:lnSpc>
+              <a:spcBef>
+                <a:spcPts val="500"/>
+              </a:spcBef>
+              <a:buFont typeface="Arial" panose="020B0604020202020204" pitchFamily="34" charset="0"/>
+              <a:buChar char="•"/>
+              <a:defRPr sz="1800" kern="1200">
+                <a:solidFill>
+                  <a:schemeClr val="tx1"/>
+                </a:solidFill>
+                <a:latin typeface="+mn-lt"/>
+                <a:ea typeface="+mn-ea"/>
+                <a:cs typeface="+mn-cs"/>
+              </a:defRPr>
+            </a:lvl9pPr>
+          </a:lstStyle>
+          <a:p>
+            <a:pPr marL="0" indent="0">
+              <a:spcBef>
+                <a:spcPts val="0"/>
+              </a:spcBef>
+              <a:buNone/>
+            </a:pPr>
+            <a:r>
+              <a:rPr lang="nl-NL" sz="1800" dirty="0">
+                <a:latin typeface="Courier New" panose="02070309020205020404" pitchFamily="49" charset="0"/>
+                <a:cs typeface="Courier New" panose="02070309020205020404" pitchFamily="49" charset="0"/>
+              </a:rPr>
+              <a:t>[project]</a:t>
+            </a:r>
+          </a:p>
+          <a:p>
+            <a:pPr marL="0" indent="0">
+              <a:spcBef>
+                <a:spcPts val="0"/>
+              </a:spcBef>
+              <a:buNone/>
+            </a:pPr>
+            <a:r>
+              <a:rPr lang="nl-NL" sz="1800" dirty="0">
+                <a:latin typeface="Courier New" panose="02070309020205020404" pitchFamily="49" charset="0"/>
+                <a:cs typeface="Courier New" panose="02070309020205020404" pitchFamily="49" charset="0"/>
+              </a:rPr>
+              <a:t>name = "</a:t>
+            </a:r>
+            <a:r>
+              <a:rPr lang="nl-NL" sz="1800" dirty="0" err="1">
+                <a:latin typeface="Courier New" panose="02070309020205020404" pitchFamily="49" charset="0"/>
+                <a:cs typeface="Courier New" panose="02070309020205020404" pitchFamily="49" charset="0"/>
+              </a:rPr>
+              <a:t>my</a:t>
+            </a:r>
+            <a:r>
+              <a:rPr lang="nl-NL" sz="1800" dirty="0">
+                <a:latin typeface="Courier New" panose="02070309020205020404" pitchFamily="49" charset="0"/>
+                <a:cs typeface="Courier New" panose="02070309020205020404" pitchFamily="49" charset="0"/>
+              </a:rPr>
+              <a:t>-package"</a:t>
+            </a:r>
+          </a:p>
+          <a:p>
+            <a:pPr marL="0" indent="0">
+              <a:spcBef>
+                <a:spcPts val="0"/>
+              </a:spcBef>
+              <a:buNone/>
+            </a:pPr>
+            <a:r>
+              <a:rPr lang="nl-NL" sz="1800" dirty="0" err="1">
+                <a:latin typeface="Courier New" panose="02070309020205020404" pitchFamily="49" charset="0"/>
+                <a:cs typeface="Courier New" panose="02070309020205020404" pitchFamily="49" charset="0"/>
+              </a:rPr>
+              <a:t>version</a:t>
+            </a:r>
+            <a:r>
+              <a:rPr lang="nl-NL" sz="1800" dirty="0">
+                <a:latin typeface="Courier New" panose="02070309020205020404" pitchFamily="49" charset="0"/>
+                <a:cs typeface="Courier New" panose="02070309020205020404" pitchFamily="49" charset="0"/>
+              </a:rPr>
+              <a:t> = "0.1.0"</a:t>
+            </a:r>
+          </a:p>
+          <a:p>
+            <a:pPr marL="0" indent="0">
+              <a:spcBef>
+                <a:spcPts val="0"/>
+              </a:spcBef>
+              <a:buNone/>
+            </a:pPr>
+            <a:r>
+              <a:rPr lang="nl-NL" sz="1800" dirty="0" err="1">
+                <a:latin typeface="Courier New" panose="02070309020205020404" pitchFamily="49" charset="0"/>
+                <a:cs typeface="Courier New" panose="02070309020205020404" pitchFamily="49" charset="0"/>
+              </a:rPr>
+              <a:t>description</a:t>
+            </a:r>
+            <a:r>
+              <a:rPr lang="nl-NL" sz="1800" dirty="0">
+                <a:latin typeface="Courier New" panose="02070309020205020404" pitchFamily="49" charset="0"/>
+                <a:cs typeface="Courier New" panose="02070309020205020404" pitchFamily="49" charset="0"/>
+              </a:rPr>
+              <a:t> = "</a:t>
+            </a:r>
+            <a:r>
+              <a:rPr lang="nl-NL" sz="1800" dirty="0" err="1">
+                <a:latin typeface="Courier New" panose="02070309020205020404" pitchFamily="49" charset="0"/>
+                <a:cs typeface="Courier New" panose="02070309020205020404" pitchFamily="49" charset="0"/>
+              </a:rPr>
+              <a:t>Description</a:t>
+            </a:r>
+            <a:r>
+              <a:rPr lang="nl-NL" sz="1800" dirty="0">
+                <a:latin typeface="Courier New" panose="02070309020205020404" pitchFamily="49" charset="0"/>
+                <a:cs typeface="Courier New" panose="02070309020205020404" pitchFamily="49" charset="0"/>
+              </a:rPr>
+              <a:t> here"</a:t>
+            </a:r>
+          </a:p>
+          <a:p>
+            <a:pPr marL="0" indent="0">
+              <a:spcBef>
+                <a:spcPts val="0"/>
+              </a:spcBef>
+              <a:buNone/>
+            </a:pPr>
+            <a:r>
+              <a:rPr lang="nl-NL" sz="1800" dirty="0" err="1">
+                <a:latin typeface="Courier New" panose="02070309020205020404" pitchFamily="49" charset="0"/>
+                <a:cs typeface="Courier New" panose="02070309020205020404" pitchFamily="49" charset="0"/>
+              </a:rPr>
+              <a:t>readme</a:t>
+            </a:r>
+            <a:r>
+              <a:rPr lang="nl-NL" sz="1800" dirty="0">
+                <a:latin typeface="Courier New" panose="02070309020205020404" pitchFamily="49" charset="0"/>
+                <a:cs typeface="Courier New" panose="02070309020205020404" pitchFamily="49" charset="0"/>
+              </a:rPr>
+              <a:t> = "README.md"</a:t>
+            </a:r>
+          </a:p>
+          <a:p>
+            <a:pPr marL="0" indent="0">
+              <a:spcBef>
+                <a:spcPts val="0"/>
+              </a:spcBef>
+              <a:buNone/>
+            </a:pPr>
+            <a:r>
+              <a:rPr lang="nl-NL" sz="1800" dirty="0" err="1">
+                <a:latin typeface="Courier New" panose="02070309020205020404" pitchFamily="49" charset="0"/>
+                <a:cs typeface="Courier New" panose="02070309020205020404" pitchFamily="49" charset="0"/>
+              </a:rPr>
+              <a:t>authors</a:t>
+            </a:r>
+            <a:r>
+              <a:rPr lang="nl-NL" sz="1800" dirty="0">
+                <a:latin typeface="Courier New" panose="02070309020205020404" pitchFamily="49" charset="0"/>
+                <a:cs typeface="Courier New" panose="02070309020205020404" pitchFamily="49" charset="0"/>
+              </a:rPr>
+              <a:t> = [</a:t>
+            </a:r>
+          </a:p>
+          <a:p>
+            <a:pPr marL="0" indent="0">
+              <a:spcBef>
+                <a:spcPts val="0"/>
+              </a:spcBef>
+              <a:buNone/>
+            </a:pPr>
+            <a:r>
+              <a:rPr lang="nl-NL" sz="1800" dirty="0">
+                <a:latin typeface="Courier New" panose="02070309020205020404" pitchFamily="49" charset="0"/>
+                <a:cs typeface="Courier New" panose="02070309020205020404" pitchFamily="49" charset="0"/>
+              </a:rPr>
+              <a:t>    { name = "Lukas Koning" }</a:t>
+            </a:r>
+          </a:p>
+          <a:p>
+            <a:pPr marL="0" indent="0">
+              <a:spcBef>
+                <a:spcPts val="0"/>
+              </a:spcBef>
+              <a:buNone/>
+            </a:pPr>
+            <a:r>
+              <a:rPr lang="nl-NL" sz="1800" dirty="0">
+                <a:latin typeface="Courier New" panose="02070309020205020404" pitchFamily="49" charset="0"/>
+                <a:cs typeface="Courier New" panose="02070309020205020404" pitchFamily="49" charset="0"/>
+              </a:rPr>
+              <a:t>]</a:t>
+            </a:r>
+          </a:p>
+          <a:p>
+            <a:pPr marL="0" indent="0">
+              <a:spcBef>
+                <a:spcPts val="0"/>
+              </a:spcBef>
+              <a:buNone/>
+            </a:pPr>
+            <a:r>
+              <a:rPr lang="nl-NL" sz="1800" dirty="0" err="1">
+                <a:latin typeface="Courier New" panose="02070309020205020404" pitchFamily="49" charset="0"/>
+                <a:cs typeface="Courier New" panose="02070309020205020404" pitchFamily="49" charset="0"/>
+              </a:rPr>
+              <a:t>requires</a:t>
+            </a:r>
+            <a:r>
+              <a:rPr lang="nl-NL" sz="1800" dirty="0">
+                <a:latin typeface="Courier New" panose="02070309020205020404" pitchFamily="49" charset="0"/>
+                <a:cs typeface="Courier New" panose="02070309020205020404" pitchFamily="49" charset="0"/>
+              </a:rPr>
+              <a:t>-python = "&gt;=3.13"</a:t>
+            </a:r>
+          </a:p>
+          <a:p>
+            <a:pPr marL="0" indent="0">
+              <a:spcBef>
+                <a:spcPts val="0"/>
+              </a:spcBef>
+              <a:buNone/>
+            </a:pPr>
+            <a:r>
+              <a:rPr lang="nl-NL" sz="1800" dirty="0">
+                <a:latin typeface="Courier New" panose="02070309020205020404" pitchFamily="49" charset="0"/>
+                <a:cs typeface="Courier New" panose="02070309020205020404" pitchFamily="49" charset="0"/>
+              </a:rPr>
+              <a:t>dependencies = []</a:t>
+            </a:r>
+          </a:p>
+          <a:p>
+            <a:pPr marL="0" indent="0">
+              <a:spcBef>
+                <a:spcPts val="0"/>
+              </a:spcBef>
+              <a:buNone/>
+            </a:pPr>
+            <a:endParaRPr lang="nl-NL" sz="1800" dirty="0">
+              <a:latin typeface="Courier New" panose="02070309020205020404" pitchFamily="49" charset="0"/>
+              <a:cs typeface="Courier New" panose="02070309020205020404" pitchFamily="49" charset="0"/>
+            </a:endParaRPr>
+          </a:p>
+          <a:p>
+            <a:pPr marL="0" indent="0">
+              <a:spcBef>
+                <a:spcPts val="0"/>
+              </a:spcBef>
+              <a:buNone/>
+            </a:pPr>
+            <a:r>
+              <a:rPr lang="nl-NL" sz="1800" dirty="0">
+                <a:latin typeface="Courier New" panose="02070309020205020404" pitchFamily="49" charset="0"/>
+                <a:cs typeface="Courier New" panose="02070309020205020404" pitchFamily="49" charset="0"/>
+              </a:rPr>
+              <a:t>[</a:t>
+            </a:r>
+            <a:r>
+              <a:rPr lang="nl-NL" sz="1800" dirty="0" err="1">
+                <a:latin typeface="Courier New" panose="02070309020205020404" pitchFamily="49" charset="0"/>
+                <a:cs typeface="Courier New" panose="02070309020205020404" pitchFamily="49" charset="0"/>
+              </a:rPr>
+              <a:t>project.scripts</a:t>
+            </a:r>
+            <a:r>
+              <a:rPr lang="nl-NL" sz="1800" dirty="0">
+                <a:latin typeface="Courier New" panose="02070309020205020404" pitchFamily="49" charset="0"/>
+                <a:cs typeface="Courier New" panose="02070309020205020404" pitchFamily="49" charset="0"/>
+              </a:rPr>
+              <a:t>]</a:t>
+            </a:r>
+          </a:p>
+          <a:p>
+            <a:pPr marL="0" indent="0">
+              <a:spcBef>
+                <a:spcPts val="0"/>
+              </a:spcBef>
+              <a:buNone/>
+            </a:pPr>
+            <a:r>
+              <a:rPr lang="nl-NL" sz="1800" dirty="0" err="1">
+                <a:latin typeface="Courier New" panose="02070309020205020404" pitchFamily="49" charset="0"/>
+                <a:cs typeface="Courier New" panose="02070309020205020404" pitchFamily="49" charset="0"/>
+              </a:rPr>
+              <a:t>my</a:t>
+            </a:r>
+            <a:r>
+              <a:rPr lang="nl-NL" sz="1800" dirty="0">
+                <a:latin typeface="Courier New" panose="02070309020205020404" pitchFamily="49" charset="0"/>
+                <a:cs typeface="Courier New" panose="02070309020205020404" pitchFamily="49" charset="0"/>
+              </a:rPr>
+              <a:t>-package = "</a:t>
+            </a:r>
+            <a:r>
+              <a:rPr lang="nl-NL" sz="1800" dirty="0" err="1">
+                <a:latin typeface="Courier New" panose="02070309020205020404" pitchFamily="49" charset="0"/>
+                <a:cs typeface="Courier New" panose="02070309020205020404" pitchFamily="49" charset="0"/>
+              </a:rPr>
+              <a:t>my_package:main</a:t>
+            </a:r>
+            <a:r>
+              <a:rPr lang="nl-NL" sz="1800" dirty="0">
+                <a:latin typeface="Courier New" panose="02070309020205020404" pitchFamily="49" charset="0"/>
+                <a:cs typeface="Courier New" panose="02070309020205020404" pitchFamily="49" charset="0"/>
+              </a:rPr>
+              <a:t>"</a:t>
+            </a:r>
+          </a:p>
+          <a:p>
+            <a:pPr marL="0" indent="0">
+              <a:spcBef>
+                <a:spcPts val="0"/>
+              </a:spcBef>
+              <a:buNone/>
+            </a:pPr>
+            <a:endParaRPr lang="nl-NL" sz="1800" dirty="0">
+              <a:latin typeface="Courier New" panose="02070309020205020404" pitchFamily="49" charset="0"/>
+              <a:cs typeface="Courier New" panose="02070309020205020404" pitchFamily="49" charset="0"/>
+            </a:endParaRPr>
+          </a:p>
+          <a:p>
+            <a:pPr marL="0" indent="0">
+              <a:spcBef>
+                <a:spcPts val="0"/>
+              </a:spcBef>
+              <a:buNone/>
+            </a:pPr>
+            <a:r>
+              <a:rPr lang="nl-NL" sz="1800" dirty="0">
+                <a:latin typeface="Courier New" panose="02070309020205020404" pitchFamily="49" charset="0"/>
+                <a:cs typeface="Courier New" panose="02070309020205020404" pitchFamily="49" charset="0"/>
+              </a:rPr>
+              <a:t>[</a:t>
+            </a:r>
+            <a:r>
+              <a:rPr lang="nl-NL" sz="1800" dirty="0" err="1">
+                <a:latin typeface="Courier New" panose="02070309020205020404" pitchFamily="49" charset="0"/>
+                <a:cs typeface="Courier New" panose="02070309020205020404" pitchFamily="49" charset="0"/>
+              </a:rPr>
+              <a:t>build</a:t>
+            </a:r>
+            <a:r>
+              <a:rPr lang="nl-NL" sz="1800" dirty="0">
+                <a:latin typeface="Courier New" panose="02070309020205020404" pitchFamily="49" charset="0"/>
+                <a:cs typeface="Courier New" panose="02070309020205020404" pitchFamily="49" charset="0"/>
+              </a:rPr>
+              <a:t>-system]</a:t>
+            </a:r>
+          </a:p>
+          <a:p>
+            <a:pPr marL="0" indent="0">
+              <a:spcBef>
+                <a:spcPts val="0"/>
+              </a:spcBef>
+              <a:buNone/>
+            </a:pPr>
+            <a:r>
+              <a:rPr lang="nl-NL" sz="1800" dirty="0" err="1">
+                <a:latin typeface="Courier New" panose="02070309020205020404" pitchFamily="49" charset="0"/>
+                <a:cs typeface="Courier New" panose="02070309020205020404" pitchFamily="49" charset="0"/>
+              </a:rPr>
+              <a:t>requires</a:t>
+            </a:r>
+            <a:r>
+              <a:rPr lang="nl-NL" sz="1800" dirty="0">
+                <a:latin typeface="Courier New" panose="02070309020205020404" pitchFamily="49" charset="0"/>
+                <a:cs typeface="Courier New" panose="02070309020205020404" pitchFamily="49" charset="0"/>
+              </a:rPr>
+              <a:t> = ["</a:t>
+            </a:r>
+            <a:r>
+              <a:rPr lang="nl-NL" sz="1800" dirty="0" err="1">
+                <a:latin typeface="Courier New" panose="02070309020205020404" pitchFamily="49" charset="0"/>
+                <a:cs typeface="Courier New" panose="02070309020205020404" pitchFamily="49" charset="0"/>
+              </a:rPr>
+              <a:t>uv_build</a:t>
+            </a:r>
+            <a:r>
+              <a:rPr lang="nl-NL" sz="1800" dirty="0">
+                <a:latin typeface="Courier New" panose="02070309020205020404" pitchFamily="49" charset="0"/>
+                <a:cs typeface="Courier New" panose="02070309020205020404" pitchFamily="49" charset="0"/>
+              </a:rPr>
+              <a:t>&gt;=0.11"]</a:t>
+            </a:r>
+          </a:p>
+          <a:p>
+            <a:pPr marL="0" indent="0">
+              <a:spcBef>
+                <a:spcPts val="0"/>
+              </a:spcBef>
+              <a:buNone/>
+            </a:pPr>
+            <a:r>
+              <a:rPr lang="nl-NL" sz="1800" dirty="0" err="1">
+                <a:latin typeface="Courier New" panose="02070309020205020404" pitchFamily="49" charset="0"/>
+                <a:cs typeface="Courier New" panose="02070309020205020404" pitchFamily="49" charset="0"/>
+              </a:rPr>
+              <a:t>build</a:t>
+            </a:r>
+            <a:r>
+              <a:rPr lang="nl-NL" sz="1800" dirty="0">
+                <a:latin typeface="Courier New" panose="02070309020205020404" pitchFamily="49" charset="0"/>
+                <a:cs typeface="Courier New" panose="02070309020205020404" pitchFamily="49" charset="0"/>
+              </a:rPr>
+              <a:t>-backend = "</a:t>
+            </a:r>
+            <a:r>
+              <a:rPr lang="nl-NL" sz="1800" dirty="0" err="1">
+                <a:latin typeface="Courier New" panose="02070309020205020404" pitchFamily="49" charset="0"/>
+                <a:cs typeface="Courier New" panose="02070309020205020404" pitchFamily="49" charset="0"/>
+              </a:rPr>
+              <a:t>uv_build</a:t>
+            </a:r>
+            <a:r>
+              <a:rPr lang="nl-NL" sz="1800" dirty="0">
+                <a:latin typeface="Courier New" panose="02070309020205020404" pitchFamily="49" charset="0"/>
+                <a:cs typeface="Courier New" panose="02070309020205020404" pitchFamily="49" charset="0"/>
+              </a:rPr>
+              <a:t>"</a:t>
+            </a:r>
+          </a:p>
+        </p:txBody>
+      </p:sp>
+    </p:spTree>
+    <p:extLst>
+      <p:ext uri="{BB962C8B-B14F-4D97-AF65-F5344CB8AC3E}">
+        <p14:creationId xmlns:p14="http://schemas.microsoft.com/office/powerpoint/2010/main" val="1148242955"/>
+      </p:ext>
+    </p:extLst>
+  </p:cSld>
+  <p:clrMapOvr>
+    <a:masterClrMapping/>
+  </p:clrMapOvr>
+</p:sld>
+</file>
+
+<file path=ppt/slides/slide34.xml><?xml version="1.0" encoding="utf-8"?>
+<p:sld xmlns:a="http://schemas.openxmlformats.org/drawingml/2006/main" xmlns:r="http://schemas.openxmlformats.org/officeDocument/2006/relationships" xmlns:p="http://schemas.openxmlformats.org/presentationml/2006/main">
+  <p:cSld>
+    <p:spTree>
+      <p:nvGrpSpPr>
+        <p:cNvPr id="1" name="">
+          <a:extLst>
+            <a:ext uri="{FF2B5EF4-FFF2-40B4-BE49-F238E27FC236}">
               <a16:creationId xmlns:a16="http://schemas.microsoft.com/office/drawing/2014/main" id="{BE0339F0-2D02-907F-DBB6-BF47FCD59719}"/>
             </a:ext>
           </a:extLst>
@@ -15982,7 +16855,7 @@
 </p:sld>
 </file>
 
-<file path=ppt/slides/slide34.xml><?xml version="1.0" encoding="utf-8"?>
+<file path=ppt/slides/slide35.xml><?xml version="1.0" encoding="utf-8"?>
 <p:sld xmlns:a="http://schemas.openxmlformats.org/drawingml/2006/main" xmlns:r="http://schemas.openxmlformats.org/officeDocument/2006/relationships" xmlns:p="http://schemas.openxmlformats.org/presentationml/2006/main">
   <p:cSld>
     <p:spTree>
@@ -16470,7 +17343,7 @@
 </p:sld>
 </file>
 
-<file path=ppt/slides/slide35.xml><?xml version="1.0" encoding="utf-8"?>
+<file path=ppt/slides/slide36.xml><?xml version="1.0" encoding="utf-8"?>
 <p:sld xmlns:a="http://schemas.openxmlformats.org/drawingml/2006/main" xmlns:r="http://schemas.openxmlformats.org/officeDocument/2006/relationships" xmlns:p="http://schemas.openxmlformats.org/presentationml/2006/main">
   <p:cSld>
     <p:spTree>
@@ -17070,7 +17943,7 @@
 </p:sld>
 </file>
 
-<file path=ppt/slides/slide36.xml><?xml version="1.0" encoding="utf-8"?>
+<file path=ppt/slides/slide37.xml><?xml version="1.0" encoding="utf-8"?>
 <p:sld xmlns:a="http://schemas.openxmlformats.org/drawingml/2006/main" xmlns:r="http://schemas.openxmlformats.org/officeDocument/2006/relationships" xmlns:p="http://schemas.openxmlformats.org/presentationml/2006/main">
   <p:cSld>
     <p:spTree>
@@ -17165,7 +18038,7 @@
 </p:sld>
 </file>
 
-<file path=ppt/slides/slide37.xml><?xml version="1.0" encoding="utf-8"?>
+<file path=ppt/slides/slide38.xml><?xml version="1.0" encoding="utf-8"?>
 <p:sld xmlns:a="http://schemas.openxmlformats.org/drawingml/2006/main" xmlns:r="http://schemas.openxmlformats.org/officeDocument/2006/relationships" xmlns:p="http://schemas.openxmlformats.org/presentationml/2006/main">
   <p:cSld>
     <p:spTree>
@@ -17524,7 +18397,7 @@
 </p:sld>
 </file>
 
-<file path=ppt/slides/slide38.xml><?xml version="1.0" encoding="utf-8"?>
+<file path=ppt/slides/slide39.xml><?xml version="1.0" encoding="utf-8"?>
 <p:sld xmlns:a="http://schemas.openxmlformats.org/drawingml/2006/main" xmlns:r="http://schemas.openxmlformats.org/officeDocument/2006/relationships" xmlns:p="http://schemas.openxmlformats.org/presentationml/2006/main">
   <p:cSld>
     <p:spTree>
@@ -17877,7 +18750,241 @@
 </p:sld>
 </file>
 
-<file path=ppt/slides/slide39.xml><?xml version="1.0" encoding="utf-8"?>
+<file path=ppt/slides/slide4.xml><?xml version="1.0" encoding="utf-8"?>
+<p:sld xmlns:a="http://schemas.openxmlformats.org/drawingml/2006/main" xmlns:r="http://schemas.openxmlformats.org/officeDocument/2006/relationships" xmlns:p="http://schemas.openxmlformats.org/presentationml/2006/main">
+  <p:cSld>
+    <p:spTree>
+      <p:nvGrpSpPr>
+        <p:cNvPr id="1" name=""/>
+        <p:cNvGrpSpPr/>
+        <p:nvPr/>
+      </p:nvGrpSpPr>
+      <p:grpSpPr>
+        <a:xfrm>
+          <a:off x="0" y="0"/>
+          <a:ext cx="0" cy="0"/>
+          <a:chOff x="0" y="0"/>
+          <a:chExt cx="0" cy="0"/>
+        </a:xfrm>
+      </p:grpSpPr>
+      <p:pic>
+        <p:nvPicPr>
+          <p:cNvPr id="1026" name="Picture 2" descr="Python">
+            <a:extLst>
+              <a:ext uri="{FF2B5EF4-FFF2-40B4-BE49-F238E27FC236}">
+                <a16:creationId xmlns:a16="http://schemas.microsoft.com/office/drawing/2014/main" id="{2604CCD1-B710-B7B3-3C01-61B36162D61A}"/>
+              </a:ext>
+            </a:extLst>
+          </p:cNvPr>
+          <p:cNvPicPr>
+            <a:picLocks noChangeAspect="1" noChangeArrowheads="1"/>
+          </p:cNvPicPr>
+          <p:nvPr/>
+        </p:nvPicPr>
+        <p:blipFill>
+          <a:blip r:embed="rId2">
+            <a:extLst>
+              <a:ext uri="{28A0092B-C50C-407E-A947-70E740481C1C}">
+                <a14:useLocalDpi xmlns:a14="http://schemas.microsoft.com/office/drawing/2010/main" val="0"/>
+              </a:ext>
+            </a:extLst>
+          </a:blip>
+          <a:srcRect/>
+          <a:stretch>
+            <a:fillRect/>
+          </a:stretch>
+        </p:blipFill>
+        <p:spPr bwMode="auto">
+          <a:xfrm>
+            <a:off x="6880227" y="1098853"/>
+            <a:ext cx="4473573" cy="5078110"/>
+          </a:xfrm>
+          <a:prstGeom prst="rect">
+            <a:avLst/>
+          </a:prstGeom>
+          <a:noFill/>
+          <a:extLst>
+            <a:ext uri="{909E8E84-426E-40DD-AFC4-6F175D3DCCD1}">
+              <a14:hiddenFill xmlns:a14="http://schemas.microsoft.com/office/drawing/2010/main">
+                <a:solidFill>
+                  <a:srgbClr val="FFFFFF"/>
+                </a:solidFill>
+              </a14:hiddenFill>
+            </a:ext>
+          </a:extLst>
+        </p:spPr>
+      </p:pic>
+      <p:sp>
+        <p:nvSpPr>
+          <p:cNvPr id="2" name="Title 1">
+            <a:extLst>
+              <a:ext uri="{FF2B5EF4-FFF2-40B4-BE49-F238E27FC236}">
+                <a16:creationId xmlns:a16="http://schemas.microsoft.com/office/drawing/2014/main" id="{39A1D606-8DD1-369C-5C09-471CDD551AD5}"/>
+              </a:ext>
+            </a:extLst>
+          </p:cNvPr>
+          <p:cNvSpPr>
+            <a:spLocks noGrp="1"/>
+          </p:cNvSpPr>
+          <p:nvPr>
+            <p:ph type="title"/>
+          </p:nvPr>
+        </p:nvSpPr>
+        <p:spPr>
+          <a:xfrm>
+            <a:off x="838200" y="365126"/>
+            <a:ext cx="10515600" cy="718608"/>
+          </a:xfrm>
+        </p:spPr>
+        <p:txBody>
+          <a:bodyPr>
+            <a:normAutofit/>
+          </a:bodyPr>
+          <a:lstStyle/>
+          <a:p>
+            <a:r>
+              <a:rPr lang="nl-NL" sz="3600" noProof="0" dirty="0"/>
+              <a:t>Sterke en zwakke punten</a:t>
+            </a:r>
+          </a:p>
+        </p:txBody>
+      </p:sp>
+      <p:sp>
+        <p:nvSpPr>
+          <p:cNvPr id="3" name="Content Placeholder 2">
+            <a:extLst>
+              <a:ext uri="{FF2B5EF4-FFF2-40B4-BE49-F238E27FC236}">
+                <a16:creationId xmlns:a16="http://schemas.microsoft.com/office/drawing/2014/main" id="{F4C2D286-E049-0AAB-1360-B7157E11AD7E}"/>
+              </a:ext>
+            </a:extLst>
+          </p:cNvPr>
+          <p:cNvSpPr>
+            <a:spLocks noGrp="1"/>
+          </p:cNvSpPr>
+          <p:nvPr>
+            <p:ph idx="1"/>
+          </p:nvPr>
+        </p:nvSpPr>
+        <p:spPr>
+          <a:xfrm>
+            <a:off x="838200" y="1456267"/>
+            <a:ext cx="4749800" cy="4720696"/>
+          </a:xfrm>
+        </p:spPr>
+        <p:txBody>
+          <a:bodyPr>
+            <a:normAutofit/>
+          </a:bodyPr>
+          <a:lstStyle/>
+          <a:p>
+            <a:pPr marL="0" indent="0">
+              <a:buNone/>
+            </a:pPr>
+            <a:r>
+              <a:rPr lang="nl-NL" sz="2000" b="1" noProof="0" dirty="0"/>
+              <a:t>Sterke punten:</a:t>
+            </a:r>
+          </a:p>
+          <a:p>
+            <a:pPr marL="0" indent="0">
+              <a:buNone/>
+            </a:pPr>
+            <a:endParaRPr lang="nl-NL" sz="2000" noProof="0" dirty="0"/>
+          </a:p>
+          <a:p>
+            <a:pPr>
+              <a:buFontTx/>
+              <a:buChar char="-"/>
+            </a:pPr>
+            <a:r>
+              <a:rPr lang="nl-NL" sz="2000" noProof="0" dirty="0"/>
+              <a:t>Makkelijk te leren, flexibele syntax.</a:t>
+            </a:r>
+          </a:p>
+          <a:p>
+            <a:pPr>
+              <a:buFontTx/>
+              <a:buChar char="-"/>
+            </a:pPr>
+            <a:endParaRPr lang="nl-NL" sz="2000" noProof="0" dirty="0"/>
+          </a:p>
+          <a:p>
+            <a:pPr>
+              <a:buFontTx/>
+              <a:buChar char="-"/>
+            </a:pPr>
+            <a:r>
+              <a:rPr lang="nl-NL" sz="2000" noProof="0" dirty="0"/>
+              <a:t>Veel ontwikkelaars en gebruikers.</a:t>
+            </a:r>
+          </a:p>
+          <a:p>
+            <a:pPr>
+              <a:buFontTx/>
+              <a:buChar char="-"/>
+            </a:pPr>
+            <a:endParaRPr lang="nl-NL" sz="2000" noProof="0" dirty="0"/>
+          </a:p>
+          <a:p>
+            <a:pPr>
+              <a:buFontTx/>
+              <a:buChar char="-"/>
+            </a:pPr>
+            <a:r>
+              <a:rPr lang="nl-NL" sz="2000" noProof="0" dirty="0"/>
+              <a:t>Veel online informatie.</a:t>
+            </a:r>
+          </a:p>
+          <a:p>
+            <a:pPr>
+              <a:buFontTx/>
+              <a:buChar char="-"/>
+            </a:pPr>
+            <a:endParaRPr lang="nl-NL" sz="2000" noProof="0" dirty="0"/>
+          </a:p>
+          <a:p>
+            <a:pPr>
+              <a:buFontTx/>
+              <a:buChar char="-"/>
+            </a:pPr>
+            <a:r>
+              <a:rPr lang="nl-NL" sz="2000" noProof="0" dirty="0"/>
+              <a:t>Uitgebreid ecosysteem van uitbreidingen.</a:t>
+            </a:r>
+          </a:p>
+          <a:p>
+            <a:pPr>
+              <a:buFontTx/>
+              <a:buChar char="-"/>
+            </a:pPr>
+            <a:endParaRPr lang="nl-NL" sz="2000" noProof="0" dirty="0"/>
+          </a:p>
+          <a:p>
+            <a:pPr>
+              <a:buFontTx/>
+              <a:buChar char="-"/>
+            </a:pPr>
+            <a:r>
+              <a:rPr lang="nl-NL" sz="2000" noProof="0" dirty="0"/>
+              <a:t>Breed inzetbaar.</a:t>
+            </a:r>
+          </a:p>
+        </p:txBody>
+      </p:sp>
+    </p:spTree>
+    <p:extLst>
+      <p:ext uri="{BB962C8B-B14F-4D97-AF65-F5344CB8AC3E}">
+        <p14:creationId xmlns:p14="http://schemas.microsoft.com/office/powerpoint/2010/main" val="344422135"/>
+      </p:ext>
+    </p:extLst>
+  </p:cSld>
+  <p:clrMapOvr>
+    <a:masterClrMapping/>
+  </p:clrMapOvr>
+</p:sld>
+</file>
+
+<file path=ppt/slides/slide40.xml><?xml version="1.0" encoding="utf-8"?>
 <p:sld xmlns:a="http://schemas.openxmlformats.org/drawingml/2006/main" xmlns:r="http://schemas.openxmlformats.org/officeDocument/2006/relationships" xmlns:p="http://schemas.openxmlformats.org/presentationml/2006/main">
   <p:cSld>
     <p:spTree>
@@ -18181,241 +19288,7 @@
 </p:sld>
 </file>
 
-<file path=ppt/slides/slide4.xml><?xml version="1.0" encoding="utf-8"?>
-<p:sld xmlns:a="http://schemas.openxmlformats.org/drawingml/2006/main" xmlns:r="http://schemas.openxmlformats.org/officeDocument/2006/relationships" xmlns:p="http://schemas.openxmlformats.org/presentationml/2006/main">
-  <p:cSld>
-    <p:spTree>
-      <p:nvGrpSpPr>
-        <p:cNvPr id="1" name=""/>
-        <p:cNvGrpSpPr/>
-        <p:nvPr/>
-      </p:nvGrpSpPr>
-      <p:grpSpPr>
-        <a:xfrm>
-          <a:off x="0" y="0"/>
-          <a:ext cx="0" cy="0"/>
-          <a:chOff x="0" y="0"/>
-          <a:chExt cx="0" cy="0"/>
-        </a:xfrm>
-      </p:grpSpPr>
-      <p:pic>
-        <p:nvPicPr>
-          <p:cNvPr id="1026" name="Picture 2" descr="Python">
-            <a:extLst>
-              <a:ext uri="{FF2B5EF4-FFF2-40B4-BE49-F238E27FC236}">
-                <a16:creationId xmlns:a16="http://schemas.microsoft.com/office/drawing/2014/main" id="{2604CCD1-B710-B7B3-3C01-61B36162D61A}"/>
-              </a:ext>
-            </a:extLst>
-          </p:cNvPr>
-          <p:cNvPicPr>
-            <a:picLocks noChangeAspect="1" noChangeArrowheads="1"/>
-          </p:cNvPicPr>
-          <p:nvPr/>
-        </p:nvPicPr>
-        <p:blipFill>
-          <a:blip r:embed="rId2">
-            <a:extLst>
-              <a:ext uri="{28A0092B-C50C-407E-A947-70E740481C1C}">
-                <a14:useLocalDpi xmlns:a14="http://schemas.microsoft.com/office/drawing/2010/main" val="0"/>
-              </a:ext>
-            </a:extLst>
-          </a:blip>
-          <a:srcRect/>
-          <a:stretch>
-            <a:fillRect/>
-          </a:stretch>
-        </p:blipFill>
-        <p:spPr bwMode="auto">
-          <a:xfrm>
-            <a:off x="6880227" y="1098853"/>
-            <a:ext cx="4473573" cy="5078110"/>
-          </a:xfrm>
-          <a:prstGeom prst="rect">
-            <a:avLst/>
-          </a:prstGeom>
-          <a:noFill/>
-          <a:extLst>
-            <a:ext uri="{909E8E84-426E-40DD-AFC4-6F175D3DCCD1}">
-              <a14:hiddenFill xmlns:a14="http://schemas.microsoft.com/office/drawing/2010/main">
-                <a:solidFill>
-                  <a:srgbClr val="FFFFFF"/>
-                </a:solidFill>
-              </a14:hiddenFill>
-            </a:ext>
-          </a:extLst>
-        </p:spPr>
-      </p:pic>
-      <p:sp>
-        <p:nvSpPr>
-          <p:cNvPr id="2" name="Title 1">
-            <a:extLst>
-              <a:ext uri="{FF2B5EF4-FFF2-40B4-BE49-F238E27FC236}">
-                <a16:creationId xmlns:a16="http://schemas.microsoft.com/office/drawing/2014/main" id="{39A1D606-8DD1-369C-5C09-471CDD551AD5}"/>
-              </a:ext>
-            </a:extLst>
-          </p:cNvPr>
-          <p:cNvSpPr>
-            <a:spLocks noGrp="1"/>
-          </p:cNvSpPr>
-          <p:nvPr>
-            <p:ph type="title"/>
-          </p:nvPr>
-        </p:nvSpPr>
-        <p:spPr>
-          <a:xfrm>
-            <a:off x="838200" y="365126"/>
-            <a:ext cx="10515600" cy="718608"/>
-          </a:xfrm>
-        </p:spPr>
-        <p:txBody>
-          <a:bodyPr>
-            <a:normAutofit/>
-          </a:bodyPr>
-          <a:lstStyle/>
-          <a:p>
-            <a:r>
-              <a:rPr lang="nl-NL" sz="3600" noProof="0" dirty="0"/>
-              <a:t>Sterke en zwakke punten</a:t>
-            </a:r>
-          </a:p>
-        </p:txBody>
-      </p:sp>
-      <p:sp>
-        <p:nvSpPr>
-          <p:cNvPr id="3" name="Content Placeholder 2">
-            <a:extLst>
-              <a:ext uri="{FF2B5EF4-FFF2-40B4-BE49-F238E27FC236}">
-                <a16:creationId xmlns:a16="http://schemas.microsoft.com/office/drawing/2014/main" id="{F4C2D286-E049-0AAB-1360-B7157E11AD7E}"/>
-              </a:ext>
-            </a:extLst>
-          </p:cNvPr>
-          <p:cNvSpPr>
-            <a:spLocks noGrp="1"/>
-          </p:cNvSpPr>
-          <p:nvPr>
-            <p:ph idx="1"/>
-          </p:nvPr>
-        </p:nvSpPr>
-        <p:spPr>
-          <a:xfrm>
-            <a:off x="838200" y="1456267"/>
-            <a:ext cx="4749800" cy="4720696"/>
-          </a:xfrm>
-        </p:spPr>
-        <p:txBody>
-          <a:bodyPr>
-            <a:normAutofit/>
-          </a:bodyPr>
-          <a:lstStyle/>
-          <a:p>
-            <a:pPr marL="0" indent="0">
-              <a:buNone/>
-            </a:pPr>
-            <a:r>
-              <a:rPr lang="nl-NL" sz="2000" b="1" noProof="0" dirty="0"/>
-              <a:t>Sterke punten:</a:t>
-            </a:r>
-          </a:p>
-          <a:p>
-            <a:pPr marL="0" indent="0">
-              <a:buNone/>
-            </a:pPr>
-            <a:endParaRPr lang="nl-NL" sz="2000" noProof="0" dirty="0"/>
-          </a:p>
-          <a:p>
-            <a:pPr>
-              <a:buFontTx/>
-              <a:buChar char="-"/>
-            </a:pPr>
-            <a:r>
-              <a:rPr lang="nl-NL" sz="2000" noProof="0" dirty="0"/>
-              <a:t>Makkelijk te leren, flexibele syntax.</a:t>
-            </a:r>
-          </a:p>
-          <a:p>
-            <a:pPr>
-              <a:buFontTx/>
-              <a:buChar char="-"/>
-            </a:pPr>
-            <a:endParaRPr lang="nl-NL" sz="2000" noProof="0" dirty="0"/>
-          </a:p>
-          <a:p>
-            <a:pPr>
-              <a:buFontTx/>
-              <a:buChar char="-"/>
-            </a:pPr>
-            <a:r>
-              <a:rPr lang="nl-NL" sz="2000" noProof="0" dirty="0"/>
-              <a:t>Veel ontwikkelaars en gebruikers.</a:t>
-            </a:r>
-          </a:p>
-          <a:p>
-            <a:pPr>
-              <a:buFontTx/>
-              <a:buChar char="-"/>
-            </a:pPr>
-            <a:endParaRPr lang="nl-NL" sz="2000" noProof="0" dirty="0"/>
-          </a:p>
-          <a:p>
-            <a:pPr>
-              <a:buFontTx/>
-              <a:buChar char="-"/>
-            </a:pPr>
-            <a:r>
-              <a:rPr lang="nl-NL" sz="2000" noProof="0" dirty="0"/>
-              <a:t>Veel online informatie.</a:t>
-            </a:r>
-          </a:p>
-          <a:p>
-            <a:pPr>
-              <a:buFontTx/>
-              <a:buChar char="-"/>
-            </a:pPr>
-            <a:endParaRPr lang="nl-NL" sz="2000" noProof="0" dirty="0"/>
-          </a:p>
-          <a:p>
-            <a:pPr>
-              <a:buFontTx/>
-              <a:buChar char="-"/>
-            </a:pPr>
-            <a:r>
-              <a:rPr lang="nl-NL" sz="2000" noProof="0" dirty="0"/>
-              <a:t>Uitgebreid ecosysteem van uitbreidingen.</a:t>
-            </a:r>
-          </a:p>
-          <a:p>
-            <a:pPr>
-              <a:buFontTx/>
-              <a:buChar char="-"/>
-            </a:pPr>
-            <a:endParaRPr lang="nl-NL" sz="2000" noProof="0" dirty="0"/>
-          </a:p>
-          <a:p>
-            <a:pPr>
-              <a:buFontTx/>
-              <a:buChar char="-"/>
-            </a:pPr>
-            <a:r>
-              <a:rPr lang="nl-NL" sz="2000" noProof="0" dirty="0"/>
-              <a:t>Breed inzetbaar.</a:t>
-            </a:r>
-          </a:p>
-        </p:txBody>
-      </p:sp>
-    </p:spTree>
-    <p:extLst>
-      <p:ext uri="{BB962C8B-B14F-4D97-AF65-F5344CB8AC3E}">
-        <p14:creationId xmlns:p14="http://schemas.microsoft.com/office/powerpoint/2010/main" val="344422135"/>
-      </p:ext>
-    </p:extLst>
-  </p:cSld>
-  <p:clrMapOvr>
-    <a:masterClrMapping/>
-  </p:clrMapOvr>
-</p:sld>
-</file>
-
-<file path=ppt/slides/slide40.xml><?xml version="1.0" encoding="utf-8"?>
+<file path=ppt/slides/slide41.xml><?xml version="1.0" encoding="utf-8"?>
 <p:sld xmlns:a="http://schemas.openxmlformats.org/drawingml/2006/main" xmlns:r="http://schemas.openxmlformats.org/officeDocument/2006/relationships" xmlns:p="http://schemas.openxmlformats.org/presentationml/2006/main" show="0">
   <p:cSld>
     <p:spTree>

</xml_diff>

<commit_message>
Update Python 4P part 1
</commit_message>
<xml_diff>
--- a/python_course_4p/1_venv_package/1_venv_package.pptx
+++ b/python_course_4p/1_venv_package/1_venv_package.pptx
@@ -5,7 +5,7 @@
     <p:sldMasterId id="2147483648" r:id="rId1"/>
   </p:sldMasterIdLst>
   <p:notesMasterIdLst>
-    <p:notesMasterId r:id="rId58"/>
+    <p:notesMasterId r:id="rId60"/>
   </p:notesMasterIdLst>
   <p:sldIdLst>
     <p:sldId id="256" r:id="rId2"/>
@@ -49,21 +49,23 @@
     <p:sldId id="375" r:id="rId40"/>
     <p:sldId id="381" r:id="rId41"/>
     <p:sldId id="397" r:id="rId42"/>
-    <p:sldId id="378" r:id="rId43"/>
-    <p:sldId id="379" r:id="rId44"/>
-    <p:sldId id="380" r:id="rId45"/>
-    <p:sldId id="359" r:id="rId46"/>
-    <p:sldId id="383" r:id="rId47"/>
-    <p:sldId id="384" r:id="rId48"/>
-    <p:sldId id="385" r:id="rId49"/>
-    <p:sldId id="387" r:id="rId50"/>
-    <p:sldId id="382" r:id="rId51"/>
-    <p:sldId id="388" r:id="rId52"/>
-    <p:sldId id="389" r:id="rId53"/>
-    <p:sldId id="386" r:id="rId54"/>
-    <p:sldId id="266" r:id="rId55"/>
-    <p:sldId id="278" r:id="rId56"/>
-    <p:sldId id="282" r:id="rId57"/>
+    <p:sldId id="399" r:id="rId43"/>
+    <p:sldId id="400" r:id="rId44"/>
+    <p:sldId id="378" r:id="rId45"/>
+    <p:sldId id="379" r:id="rId46"/>
+    <p:sldId id="380" r:id="rId47"/>
+    <p:sldId id="359" r:id="rId48"/>
+    <p:sldId id="383" r:id="rId49"/>
+    <p:sldId id="384" r:id="rId50"/>
+    <p:sldId id="385" r:id="rId51"/>
+    <p:sldId id="387" r:id="rId52"/>
+    <p:sldId id="382" r:id="rId53"/>
+    <p:sldId id="388" r:id="rId54"/>
+    <p:sldId id="389" r:id="rId55"/>
+    <p:sldId id="386" r:id="rId56"/>
+    <p:sldId id="266" r:id="rId57"/>
+    <p:sldId id="278" r:id="rId58"/>
+    <p:sldId id="282" r:id="rId59"/>
   </p:sldIdLst>
   <p:sldSz cx="12192000" cy="6858000"/>
   <p:notesSz cx="6858000" cy="9144000"/>
@@ -252,7 +254,7 @@
           <a:p>
             <a:fld id="{3BADDCAA-88FC-44D4-A91A-DD0530AB88E0}" type="datetimeFigureOut">
               <a:rPr lang="en-NL" smtClean="0"/>
-              <a:t>23/10/2026</a:t>
+              <a:t>26/10/2026</a:t>
             </a:fld>
             <a:endParaRPr lang="en-NL"/>
           </a:p>
@@ -1104,7 +1106,7 @@
           <a:p>
             <a:fld id="{4BAF0DEA-1372-46C0-8FC9-2869E9CCF7DA}" type="slidenum">
               <a:rPr lang="en-NL" smtClean="0"/>
-              <a:t>43</a:t>
+              <a:t>45</a:t>
             </a:fld>
             <a:endParaRPr lang="en-NL"/>
           </a:p>
@@ -1212,7 +1214,7 @@
           <a:p>
             <a:fld id="{4BAF0DEA-1372-46C0-8FC9-2869E9CCF7DA}" type="slidenum">
               <a:rPr lang="en-NL" smtClean="0"/>
-              <a:t>46</a:t>
+              <a:t>48</a:t>
             </a:fld>
             <a:endParaRPr lang="en-NL"/>
           </a:p>
@@ -1342,7 +1344,7 @@
           <a:p>
             <a:fld id="{4BAF0DEA-1372-46C0-8FC9-2869E9CCF7DA}" type="slidenum">
               <a:rPr lang="en-NL" smtClean="0"/>
-              <a:t>47</a:t>
+              <a:t>49</a:t>
             </a:fld>
             <a:endParaRPr lang="en-NL"/>
           </a:p>
@@ -1458,7 +1460,7 @@
           <a:p>
             <a:fld id="{4BAF0DEA-1372-46C0-8FC9-2869E9CCF7DA}" type="slidenum">
               <a:rPr lang="en-NL" smtClean="0"/>
-              <a:t>48</a:t>
+              <a:t>50</a:t>
             </a:fld>
             <a:endParaRPr lang="en-NL"/>
           </a:p>
@@ -1626,7 +1628,7 @@
           <a:p>
             <a:fld id="{0EBB069A-003F-4FC0-8534-236B0C5C7B5F}" type="datetimeFigureOut">
               <a:rPr lang="en-NL" smtClean="0"/>
-              <a:t>23/10/2026</a:t>
+              <a:t>26/10/2026</a:t>
             </a:fld>
             <a:endParaRPr lang="en-NL"/>
           </a:p>
@@ -1826,7 +1828,7 @@
           <a:p>
             <a:fld id="{0EBB069A-003F-4FC0-8534-236B0C5C7B5F}" type="datetimeFigureOut">
               <a:rPr lang="en-NL" smtClean="0"/>
-              <a:t>23/10/2026</a:t>
+              <a:t>26/10/2026</a:t>
             </a:fld>
             <a:endParaRPr lang="en-NL"/>
           </a:p>
@@ -2036,7 +2038,7 @@
           <a:p>
             <a:fld id="{0EBB069A-003F-4FC0-8534-236B0C5C7B5F}" type="datetimeFigureOut">
               <a:rPr lang="en-NL" smtClean="0"/>
-              <a:t>23/10/2026</a:t>
+              <a:t>26/10/2026</a:t>
             </a:fld>
             <a:endParaRPr lang="en-NL"/>
           </a:p>
@@ -2236,7 +2238,7 @@
           <a:p>
             <a:fld id="{0EBB069A-003F-4FC0-8534-236B0C5C7B5F}" type="datetimeFigureOut">
               <a:rPr lang="en-NL" smtClean="0"/>
-              <a:t>23/10/2026</a:t>
+              <a:t>26/10/2026</a:t>
             </a:fld>
             <a:endParaRPr lang="en-NL"/>
           </a:p>
@@ -2512,7 +2514,7 @@
           <a:p>
             <a:fld id="{0EBB069A-003F-4FC0-8534-236B0C5C7B5F}" type="datetimeFigureOut">
               <a:rPr lang="en-NL" smtClean="0"/>
-              <a:t>23/10/2026</a:t>
+              <a:t>26/10/2026</a:t>
             </a:fld>
             <a:endParaRPr lang="en-NL"/>
           </a:p>
@@ -2780,7 +2782,7 @@
           <a:p>
             <a:fld id="{0EBB069A-003F-4FC0-8534-236B0C5C7B5F}" type="datetimeFigureOut">
               <a:rPr lang="en-NL" smtClean="0"/>
-              <a:t>23/10/2026</a:t>
+              <a:t>26/10/2026</a:t>
             </a:fld>
             <a:endParaRPr lang="en-NL"/>
           </a:p>
@@ -3195,7 +3197,7 @@
           <a:p>
             <a:fld id="{0EBB069A-003F-4FC0-8534-236B0C5C7B5F}" type="datetimeFigureOut">
               <a:rPr lang="en-NL" smtClean="0"/>
-              <a:t>23/10/2026</a:t>
+              <a:t>26/10/2026</a:t>
             </a:fld>
             <a:endParaRPr lang="en-NL"/>
           </a:p>
@@ -3337,7 +3339,7 @@
           <a:p>
             <a:fld id="{0EBB069A-003F-4FC0-8534-236B0C5C7B5F}" type="datetimeFigureOut">
               <a:rPr lang="en-NL" smtClean="0"/>
-              <a:t>23/10/2026</a:t>
+              <a:t>26/10/2026</a:t>
             </a:fld>
             <a:endParaRPr lang="en-NL"/>
           </a:p>
@@ -3450,7 +3452,7 @@
           <a:p>
             <a:fld id="{0EBB069A-003F-4FC0-8534-236B0C5C7B5F}" type="datetimeFigureOut">
               <a:rPr lang="en-NL" smtClean="0"/>
-              <a:t>23/10/2026</a:t>
+              <a:t>26/10/2026</a:t>
             </a:fld>
             <a:endParaRPr lang="en-NL"/>
           </a:p>
@@ -3763,7 +3765,7 @@
           <a:p>
             <a:fld id="{0EBB069A-003F-4FC0-8534-236B0C5C7B5F}" type="datetimeFigureOut">
               <a:rPr lang="en-NL" smtClean="0"/>
-              <a:t>23/10/2026</a:t>
+              <a:t>26/10/2026</a:t>
             </a:fld>
             <a:endParaRPr lang="en-NL"/>
           </a:p>
@@ -4052,7 +4054,7 @@
           <a:p>
             <a:fld id="{0EBB069A-003F-4FC0-8534-236B0C5C7B5F}" type="datetimeFigureOut">
               <a:rPr lang="en-NL" smtClean="0"/>
-              <a:t>23/10/2026</a:t>
+              <a:t>26/10/2026</a:t>
             </a:fld>
             <a:endParaRPr lang="en-NL"/>
           </a:p>
@@ -4295,7 +4297,7 @@
           <a:p>
             <a:fld id="{0EBB069A-003F-4FC0-8534-236B0C5C7B5F}" type="datetimeFigureOut">
               <a:rPr lang="en-NL" smtClean="0"/>
-              <a:t>23/10/2026</a:t>
+              <a:t>26/10/2026</a:t>
             </a:fld>
             <a:endParaRPr lang="en-NL"/>
           </a:p>
@@ -5521,19 +5523,20 @@
               <a:rPr lang="nl-NL" sz="1800" b="1" noProof="0" dirty="0">
                 <a:cs typeface="Courier New" panose="02070309020205020404" pitchFamily="49" charset="0"/>
               </a:rPr>
-              <a:t>1.   </a:t>
-            </a:r>
-            <a:r>
-              <a:rPr lang="nl-NL" sz="1800" b="1" noProof="0" dirty="0">
+              <a:t>1. </a:t>
+            </a:r>
+            <a:r>
+              <a:rPr lang="nl-NL" sz="1800" b="1" noProof="0" dirty="0"/>
+              <a:t>Zoek en download met </a:t>
+            </a:r>
+            <a:r>
+              <a:rPr lang="nl-NL" sz="1800" b="1" dirty="0">
                 <a:latin typeface="Courier New" panose="02070309020205020404" pitchFamily="49" charset="0"/>
                 <a:cs typeface="Courier New" panose="02070309020205020404" pitchFamily="49" charset="0"/>
               </a:rPr>
               <a:t>pip</a:t>
             </a:r>
-            <a:r>
-              <a:rPr lang="nl-NL" sz="1800" b="1" noProof="0" dirty="0"/>
-              <a:t>: zoek en download package</a:t>
-            </a:r>
+            <a:endParaRPr lang="nl-NL" sz="1800" b="1" noProof="0" dirty="0"/>
           </a:p>
           <a:p>
             <a:pPr marL="0" indent="0">
@@ -5582,19 +5585,20 @@
               <a:rPr lang="nl-NL" sz="1800" b="1" noProof="0" dirty="0">
                 <a:cs typeface="Courier New" panose="02070309020205020404" pitchFamily="49" charset="0"/>
               </a:rPr>
-              <a:t>2.   </a:t>
-            </a:r>
-            <a:r>
-              <a:rPr lang="nl-NL" sz="1800" b="1" noProof="0" dirty="0">
+              <a:t>2. I</a:t>
+            </a:r>
+            <a:r>
+              <a:rPr lang="nl-NL" sz="1800" b="1" noProof="0" dirty="0"/>
+              <a:t>nstalleer met </a:t>
+            </a:r>
+            <a:r>
+              <a:rPr lang="nl-NL" sz="1800" b="1" dirty="0">
                 <a:latin typeface="Courier New" panose="02070309020205020404" pitchFamily="49" charset="0"/>
                 <a:cs typeface="Courier New" panose="02070309020205020404" pitchFamily="49" charset="0"/>
               </a:rPr>
               <a:t>setuptools</a:t>
             </a:r>
-            <a:r>
-              <a:rPr lang="nl-NL" sz="1800" b="1" noProof="0" dirty="0"/>
-              <a:t>: installeer package</a:t>
-            </a:r>
+            <a:endParaRPr lang="nl-NL" sz="1800" b="1" noProof="0" dirty="0"/>
           </a:p>
           <a:p>
             <a:pPr marL="0" indent="0">
@@ -5634,7 +5638,7 @@
             </a:pPr>
             <a:r>
               <a:rPr lang="nl-NL" sz="1800" b="1" dirty="0"/>
-              <a:t>3.   Herhaal 1 en 2 voor afhankelijkheden</a:t>
+              <a:t>3.   Herhaal voor afhankelijkheden</a:t>
             </a:r>
           </a:p>
           <a:p>
@@ -10889,7 +10893,7 @@
             </a:pPr>
             <a:r>
               <a:rPr lang="nl-NL" sz="1800" dirty="0"/>
-              <a:t>Helpt ook bij opzetten van projecten en beheer van afhankelijkheden.</a:t>
+              <a:t>Helpt bij opzetten van projecten en beheer van afhankelijkheden.</a:t>
             </a:r>
             <a:endParaRPr lang="nl-NL" sz="1800" noProof="0" dirty="0"/>
           </a:p>
@@ -19923,6 +19927,50 @@
           </a:p>
         </p:txBody>
       </p:sp>
+      <p:sp>
+        <p:nvSpPr>
+          <p:cNvPr id="5" name="TextBox 4">
+            <a:extLst>
+              <a:ext uri="{FF2B5EF4-FFF2-40B4-BE49-F238E27FC236}">
+                <a16:creationId xmlns:a16="http://schemas.microsoft.com/office/drawing/2014/main" id="{1D9C23FF-BC59-0370-9126-7F3EB891962B}"/>
+              </a:ext>
+            </a:extLst>
+          </p:cNvPr>
+          <p:cNvSpPr txBox="1"/>
+          <p:nvPr/>
+        </p:nvSpPr>
+        <p:spPr>
+          <a:xfrm>
+            <a:off x="9619967" y="6471982"/>
+            <a:ext cx="2499246" cy="307777"/>
+          </a:xfrm>
+          <a:prstGeom prst="rect">
+            <a:avLst/>
+          </a:prstGeom>
+          <a:noFill/>
+        </p:spPr>
+        <p:txBody>
+          <a:bodyPr wrap="square">
+            <a:spAutoFit/>
+          </a:bodyPr>
+          <a:lstStyle/>
+          <a:p>
+            <a:pPr algn="r"/>
+            <a:r>
+              <a:rPr lang="en-US" sz="1400" dirty="0"/>
+              <a:t>D: </a:t>
+            </a:r>
+            <a:r>
+              <a:rPr lang="en-US" sz="1400" dirty="0" err="1"/>
+              <a:t>uv</a:t>
+            </a:r>
+            <a:r>
+              <a:rPr lang="en-US" sz="1400" dirty="0"/>
+              <a:t> sync.</a:t>
+            </a:r>
+          </a:p>
+        </p:txBody>
+      </p:sp>
     </p:spTree>
     <p:extLst>
       <p:ext uri="{BB962C8B-B14F-4D97-AF65-F5344CB8AC3E}">
@@ -20078,15 +20126,7 @@
           <a:p>
             <a:r>
               <a:rPr lang="nl-NL" sz="3600" dirty="0"/>
-              <a:t>Project </a:t>
-            </a:r>
-            <a:r>
-              <a:rPr lang="nl-NL" sz="3600" dirty="0" err="1"/>
-              <a:t>vs</a:t>
-            </a:r>
-            <a:r>
-              <a:rPr lang="nl-NL" sz="3600" dirty="0"/>
-              <a:t> package</a:t>
+              <a:t>Project versus package</a:t>
             </a:r>
             <a:endParaRPr lang="nl-NL" sz="3600" noProof="0" dirty="0"/>
           </a:p>
@@ -22675,7 +22715,7 @@
             </a:pPr>
             <a:r>
               <a:rPr lang="nl-NL" sz="1800" noProof="0" dirty="0"/>
-              <a:t>Uitgebreid ecosysteem van uitbreidingen.</a:t>
+              <a:t>Uitgebreid ecosysteem van packages.</a:t>
             </a:r>
           </a:p>
           <a:p>
@@ -22693,6 +22733,23 @@
             <a:r>
               <a:rPr lang="nl-NL" sz="1800" noProof="0" dirty="0"/>
               <a:t>Breed inzetbaar.</a:t>
+            </a:r>
+          </a:p>
+          <a:p>
+            <a:pPr>
+              <a:buFontTx/>
+              <a:buChar char="-"/>
+            </a:pPr>
+            <a:endParaRPr lang="nl-NL" sz="1800" dirty="0"/>
+          </a:p>
+          <a:p>
+            <a:pPr>
+              <a:buFontTx/>
+              <a:buChar char="-"/>
+            </a:pPr>
+            <a:r>
+              <a:rPr lang="nl-NL" sz="1800" noProof="0" dirty="0"/>
+              <a:t>Open source!</a:t>
             </a:r>
           </a:p>
         </p:txBody>
@@ -22833,28 +22890,7 @@
             </a:pPr>
             <a:r>
               <a:rPr lang="nl-NL" sz="1800" dirty="0"/>
-              <a:t>Vaak leeg bestand, maar kan code bevatten.</a:t>
-            </a:r>
-          </a:p>
-          <a:p>
-            <a:pPr marL="0" indent="0">
-              <a:buNone/>
-            </a:pPr>
-            <a:endParaRPr lang="nl-NL" sz="1800" dirty="0"/>
-          </a:p>
-          <a:p>
-            <a:pPr marL="0" indent="0">
-              <a:buNone/>
-            </a:pPr>
-            <a:endParaRPr lang="nl-NL" sz="1800" dirty="0"/>
-          </a:p>
-          <a:p>
-            <a:pPr marL="0" indent="0">
-              <a:buNone/>
-            </a:pPr>
-            <a:r>
-              <a:rPr lang="nl-NL" sz="1800" dirty="0"/>
-              <a:t>Code in </a:t>
+              <a:t>De </a:t>
             </a:r>
             <a:r>
               <a:rPr lang="nl-NL" sz="1800" dirty="0">
@@ -22867,6 +22903,39 @@
               <a:rPr lang="nl-NL" sz="1800" dirty="0"/>
               <a:t> wordt uitgevoerd bij importeren package.</a:t>
             </a:r>
+          </a:p>
+          <a:p>
+            <a:pPr marL="0" indent="0">
+              <a:buNone/>
+            </a:pPr>
+            <a:endParaRPr lang="nl-NL" sz="1800" dirty="0"/>
+          </a:p>
+          <a:p>
+            <a:pPr marL="0" indent="0">
+              <a:buNone/>
+            </a:pPr>
+            <a:endParaRPr lang="nl-NL" sz="1800" dirty="0"/>
+          </a:p>
+          <a:p>
+            <a:pPr marL="0" indent="0">
+              <a:buNone/>
+            </a:pPr>
+            <a:r>
+              <a:rPr lang="nl-NL" sz="1800" dirty="0"/>
+              <a:t>Vaak leeg bestand, maar kan code bevatten.</a:t>
+            </a:r>
+          </a:p>
+          <a:p>
+            <a:pPr marL="0" indent="0">
+              <a:buNone/>
+            </a:pPr>
+            <a:endParaRPr lang="nl-NL" sz="1800" dirty="0"/>
+          </a:p>
+          <a:p>
+            <a:pPr marL="0" indent="0">
+              <a:buNone/>
+            </a:pPr>
+            <a:endParaRPr lang="nl-NL" sz="1800" dirty="0"/>
           </a:p>
         </p:txBody>
       </p:sp>
@@ -23303,10 +23372,401 @@
       </p:sp>
       <p:sp>
         <p:nvSpPr>
+          <p:cNvPr id="7" name="Content Placeholder 2">
+            <a:extLst>
+              <a:ext uri="{FF2B5EF4-FFF2-40B4-BE49-F238E27FC236}">
+                <a16:creationId xmlns:a16="http://schemas.microsoft.com/office/drawing/2014/main" id="{77A33588-7257-AFA3-2116-EE339FD4C232}"/>
+              </a:ext>
+            </a:extLst>
+          </p:cNvPr>
+          <p:cNvSpPr txBox="1">
+            <a:spLocks/>
+          </p:cNvSpPr>
+          <p:nvPr/>
+        </p:nvSpPr>
+        <p:spPr>
+          <a:xfrm>
+            <a:off x="4760239" y="1377779"/>
+            <a:ext cx="2400587" cy="1705231"/>
+          </a:xfrm>
+          <a:prstGeom prst="rect">
+            <a:avLst/>
+          </a:prstGeom>
+        </p:spPr>
+        <p:txBody>
+          <a:bodyPr vert="horz" lIns="91440" tIns="45720" rIns="91440" bIns="45720" rtlCol="0">
+            <a:noAutofit/>
+          </a:bodyPr>
+          <a:lstStyle>
+            <a:lvl1pPr marL="228600" indent="-228600" algn="l" defTabSz="914400" rtl="0" eaLnBrk="1" latinLnBrk="0" hangingPunct="1">
+              <a:lnSpc>
+                <a:spcPct val="90000"/>
+              </a:lnSpc>
+              <a:spcBef>
+                <a:spcPts val="1000"/>
+              </a:spcBef>
+              <a:buFont typeface="Arial" panose="020B0604020202020204" pitchFamily="34" charset="0"/>
+              <a:buChar char="•"/>
+              <a:defRPr sz="2800" kern="1200">
+                <a:solidFill>
+                  <a:schemeClr val="tx1"/>
+                </a:solidFill>
+                <a:latin typeface="+mn-lt"/>
+                <a:ea typeface="+mn-ea"/>
+                <a:cs typeface="+mn-cs"/>
+              </a:defRPr>
+            </a:lvl1pPr>
+            <a:lvl2pPr marL="685800" indent="-228600" algn="l" defTabSz="914400" rtl="0" eaLnBrk="1" latinLnBrk="0" hangingPunct="1">
+              <a:lnSpc>
+                <a:spcPct val="90000"/>
+              </a:lnSpc>
+              <a:spcBef>
+                <a:spcPts val="500"/>
+              </a:spcBef>
+              <a:buFont typeface="Arial" panose="020B0604020202020204" pitchFamily="34" charset="0"/>
+              <a:buChar char="•"/>
+              <a:defRPr sz="2400" kern="1200">
+                <a:solidFill>
+                  <a:schemeClr val="tx1"/>
+                </a:solidFill>
+                <a:latin typeface="+mn-lt"/>
+                <a:ea typeface="+mn-ea"/>
+                <a:cs typeface="+mn-cs"/>
+              </a:defRPr>
+            </a:lvl2pPr>
+            <a:lvl3pPr marL="1143000" indent="-228600" algn="l" defTabSz="914400" rtl="0" eaLnBrk="1" latinLnBrk="0" hangingPunct="1">
+              <a:lnSpc>
+                <a:spcPct val="90000"/>
+              </a:lnSpc>
+              <a:spcBef>
+                <a:spcPts val="500"/>
+              </a:spcBef>
+              <a:buFont typeface="Arial" panose="020B0604020202020204" pitchFamily="34" charset="0"/>
+              <a:buChar char="•"/>
+              <a:defRPr sz="2000" kern="1200">
+                <a:solidFill>
+                  <a:schemeClr val="tx1"/>
+                </a:solidFill>
+                <a:latin typeface="+mn-lt"/>
+                <a:ea typeface="+mn-ea"/>
+                <a:cs typeface="+mn-cs"/>
+              </a:defRPr>
+            </a:lvl3pPr>
+            <a:lvl4pPr marL="1600200" indent="-228600" algn="l" defTabSz="914400" rtl="0" eaLnBrk="1" latinLnBrk="0" hangingPunct="1">
+              <a:lnSpc>
+                <a:spcPct val="90000"/>
+              </a:lnSpc>
+              <a:spcBef>
+                <a:spcPts val="500"/>
+              </a:spcBef>
+              <a:buFont typeface="Arial" panose="020B0604020202020204" pitchFamily="34" charset="0"/>
+              <a:buChar char="•"/>
+              <a:defRPr sz="1800" kern="1200">
+                <a:solidFill>
+                  <a:schemeClr val="tx1"/>
+                </a:solidFill>
+                <a:latin typeface="+mn-lt"/>
+                <a:ea typeface="+mn-ea"/>
+                <a:cs typeface="+mn-cs"/>
+              </a:defRPr>
+            </a:lvl4pPr>
+            <a:lvl5pPr marL="2057400" indent="-228600" algn="l" defTabSz="914400" rtl="0" eaLnBrk="1" latinLnBrk="0" hangingPunct="1">
+              <a:lnSpc>
+                <a:spcPct val="90000"/>
+              </a:lnSpc>
+              <a:spcBef>
+                <a:spcPts val="500"/>
+              </a:spcBef>
+              <a:buFont typeface="Arial" panose="020B0604020202020204" pitchFamily="34" charset="0"/>
+              <a:buChar char="•"/>
+              <a:defRPr sz="1800" kern="1200">
+                <a:solidFill>
+                  <a:schemeClr val="tx1"/>
+                </a:solidFill>
+                <a:latin typeface="+mn-lt"/>
+                <a:ea typeface="+mn-ea"/>
+                <a:cs typeface="+mn-cs"/>
+              </a:defRPr>
+            </a:lvl5pPr>
+            <a:lvl6pPr marL="2514600" indent="-228600" algn="l" defTabSz="914400" rtl="0" eaLnBrk="1" latinLnBrk="0" hangingPunct="1">
+              <a:lnSpc>
+                <a:spcPct val="90000"/>
+              </a:lnSpc>
+              <a:spcBef>
+                <a:spcPts val="500"/>
+              </a:spcBef>
+              <a:buFont typeface="Arial" panose="020B0604020202020204" pitchFamily="34" charset="0"/>
+              <a:buChar char="•"/>
+              <a:defRPr sz="1800" kern="1200">
+                <a:solidFill>
+                  <a:schemeClr val="tx1"/>
+                </a:solidFill>
+                <a:latin typeface="+mn-lt"/>
+                <a:ea typeface="+mn-ea"/>
+                <a:cs typeface="+mn-cs"/>
+              </a:defRPr>
+            </a:lvl6pPr>
+            <a:lvl7pPr marL="2971800" indent="-228600" algn="l" defTabSz="914400" rtl="0" eaLnBrk="1" latinLnBrk="0" hangingPunct="1">
+              <a:lnSpc>
+                <a:spcPct val="90000"/>
+              </a:lnSpc>
+              <a:spcBef>
+                <a:spcPts val="500"/>
+              </a:spcBef>
+              <a:buFont typeface="Arial" panose="020B0604020202020204" pitchFamily="34" charset="0"/>
+              <a:buChar char="•"/>
+              <a:defRPr sz="1800" kern="1200">
+                <a:solidFill>
+                  <a:schemeClr val="tx1"/>
+                </a:solidFill>
+                <a:latin typeface="+mn-lt"/>
+                <a:ea typeface="+mn-ea"/>
+                <a:cs typeface="+mn-cs"/>
+              </a:defRPr>
+            </a:lvl7pPr>
+            <a:lvl8pPr marL="3429000" indent="-228600" algn="l" defTabSz="914400" rtl="0" eaLnBrk="1" latinLnBrk="0" hangingPunct="1">
+              <a:lnSpc>
+                <a:spcPct val="90000"/>
+              </a:lnSpc>
+              <a:spcBef>
+                <a:spcPts val="500"/>
+              </a:spcBef>
+              <a:buFont typeface="Arial" panose="020B0604020202020204" pitchFamily="34" charset="0"/>
+              <a:buChar char="•"/>
+              <a:defRPr sz="1800" kern="1200">
+                <a:solidFill>
+                  <a:schemeClr val="tx1"/>
+                </a:solidFill>
+                <a:latin typeface="+mn-lt"/>
+                <a:ea typeface="+mn-ea"/>
+                <a:cs typeface="+mn-cs"/>
+              </a:defRPr>
+            </a:lvl8pPr>
+            <a:lvl9pPr marL="3886200" indent="-228600" algn="l" defTabSz="914400" rtl="0" eaLnBrk="1" latinLnBrk="0" hangingPunct="1">
+              <a:lnSpc>
+                <a:spcPct val="90000"/>
+              </a:lnSpc>
+              <a:spcBef>
+                <a:spcPts val="500"/>
+              </a:spcBef>
+              <a:buFont typeface="Arial" panose="020B0604020202020204" pitchFamily="34" charset="0"/>
+              <a:buChar char="•"/>
+              <a:defRPr sz="1800" kern="1200">
+                <a:solidFill>
+                  <a:schemeClr val="tx1"/>
+                </a:solidFill>
+                <a:latin typeface="+mn-lt"/>
+                <a:ea typeface="+mn-ea"/>
+                <a:cs typeface="+mn-cs"/>
+              </a:defRPr>
+            </a:lvl9pPr>
+          </a:lstStyle>
+          <a:p>
+            <a:pPr marL="0" indent="0">
+              <a:spcBef>
+                <a:spcPts val="0"/>
+              </a:spcBef>
+              <a:buNone/>
+            </a:pPr>
+            <a:r>
+              <a:rPr lang="nl-NL" sz="1600" dirty="0" err="1">
+                <a:latin typeface="Courier New" panose="02070309020205020404" pitchFamily="49" charset="0"/>
+                <a:cs typeface="Courier New" panose="02070309020205020404" pitchFamily="49" charset="0"/>
+              </a:rPr>
+              <a:t>src</a:t>
+            </a:r>
+            <a:r>
+              <a:rPr lang="nl-NL" sz="1600" dirty="0">
+                <a:latin typeface="Courier New" panose="02070309020205020404" pitchFamily="49" charset="0"/>
+                <a:cs typeface="Courier New" panose="02070309020205020404" pitchFamily="49" charset="0"/>
+              </a:rPr>
+              <a:t>/</a:t>
+            </a:r>
+          </a:p>
+          <a:p>
+            <a:pPr marL="0" indent="0">
+              <a:spcBef>
+                <a:spcPts val="0"/>
+              </a:spcBef>
+              <a:buNone/>
+            </a:pPr>
+            <a:r>
+              <a:rPr lang="nl-NL" sz="1600" dirty="0">
+                <a:latin typeface="Courier New" panose="02070309020205020404" pitchFamily="49" charset="0"/>
+                <a:cs typeface="Courier New" panose="02070309020205020404" pitchFamily="49" charset="0"/>
+              </a:rPr>
+              <a:t>│</a:t>
+            </a:r>
+          </a:p>
+          <a:p>
+            <a:pPr marL="0" indent="0">
+              <a:spcBef>
+                <a:spcPts val="0"/>
+              </a:spcBef>
+              <a:buNone/>
+            </a:pPr>
+            <a:r>
+              <a:rPr lang="nl-NL" sz="1600" dirty="0">
+                <a:latin typeface="Courier New" panose="02070309020205020404" pitchFamily="49" charset="0"/>
+                <a:cs typeface="Courier New" panose="02070309020205020404" pitchFamily="49" charset="0"/>
+              </a:rPr>
+              <a:t>└─ </a:t>
+            </a:r>
+            <a:r>
+              <a:rPr lang="nl-NL" sz="1600" dirty="0" err="1">
+                <a:latin typeface="Courier New" panose="02070309020205020404" pitchFamily="49" charset="0"/>
+                <a:cs typeface="Courier New" panose="02070309020205020404" pitchFamily="49" charset="0"/>
+              </a:rPr>
+              <a:t>hi_world</a:t>
+            </a:r>
+            <a:r>
+              <a:rPr lang="nl-NL" sz="1600" dirty="0">
+                <a:latin typeface="Courier New" panose="02070309020205020404" pitchFamily="49" charset="0"/>
+                <a:cs typeface="Courier New" panose="02070309020205020404" pitchFamily="49" charset="0"/>
+              </a:rPr>
+              <a:t> /</a:t>
+            </a:r>
+          </a:p>
+          <a:p>
+            <a:pPr marL="0" indent="0">
+              <a:spcBef>
+                <a:spcPts val="0"/>
+              </a:spcBef>
+              <a:buNone/>
+            </a:pPr>
+            <a:r>
+              <a:rPr lang="nl-NL" sz="1600" dirty="0">
+                <a:latin typeface="Courier New" panose="02070309020205020404" pitchFamily="49" charset="0"/>
+                <a:cs typeface="Courier New" panose="02070309020205020404" pitchFamily="49" charset="0"/>
+              </a:rPr>
+              <a:t>   │</a:t>
+            </a:r>
+          </a:p>
+          <a:p>
+            <a:pPr marL="0" indent="0">
+              <a:spcBef>
+                <a:spcPts val="0"/>
+              </a:spcBef>
+              <a:buNone/>
+            </a:pPr>
+            <a:r>
+              <a:rPr lang="nl-NL" sz="1600" dirty="0">
+                <a:latin typeface="Courier New" panose="02070309020205020404" pitchFamily="49" charset="0"/>
+                <a:cs typeface="Courier New" panose="02070309020205020404" pitchFamily="49" charset="0"/>
+              </a:rPr>
+              <a:t>   ├─ __init__.py</a:t>
+            </a:r>
+          </a:p>
+          <a:p>
+            <a:pPr marL="0" indent="0">
+              <a:spcBef>
+                <a:spcPts val="0"/>
+              </a:spcBef>
+              <a:buNone/>
+            </a:pPr>
+            <a:r>
+              <a:rPr lang="nl-NL" sz="1600" dirty="0">
+                <a:latin typeface="Courier New" panose="02070309020205020404" pitchFamily="49" charset="0"/>
+                <a:cs typeface="Courier New" panose="02070309020205020404" pitchFamily="49" charset="0"/>
+              </a:rPr>
+              <a:t>   │     </a:t>
+            </a:r>
+          </a:p>
+          <a:p>
+            <a:pPr marL="0" indent="0">
+              <a:spcBef>
+                <a:spcPts val="0"/>
+              </a:spcBef>
+              <a:buNone/>
+            </a:pPr>
+            <a:r>
+              <a:rPr lang="nl-NL" sz="1600" dirty="0">
+                <a:latin typeface="Courier New" panose="02070309020205020404" pitchFamily="49" charset="0"/>
+                <a:cs typeface="Courier New" panose="02070309020205020404" pitchFamily="49" charset="0"/>
+              </a:rPr>
+              <a:t>   └─ greet.py</a:t>
+            </a:r>
+          </a:p>
+        </p:txBody>
+      </p:sp>
+    </p:spTree>
+    <p:extLst>
+      <p:ext uri="{BB962C8B-B14F-4D97-AF65-F5344CB8AC3E}">
+        <p14:creationId xmlns:p14="http://schemas.microsoft.com/office/powerpoint/2010/main" val="1209835813"/>
+      </p:ext>
+    </p:extLst>
+  </p:cSld>
+  <p:clrMapOvr>
+    <a:masterClrMapping/>
+  </p:clrMapOvr>
+</p:sld>
+</file>
+
+<file path=ppt/slides/slide42.xml><?xml version="1.0" encoding="utf-8"?>
+<p:sld xmlns:a="http://schemas.openxmlformats.org/drawingml/2006/main" xmlns:r="http://schemas.openxmlformats.org/officeDocument/2006/relationships" xmlns:p="http://schemas.openxmlformats.org/presentationml/2006/main">
+  <p:cSld>
+    <p:spTree>
+      <p:nvGrpSpPr>
+        <p:cNvPr id="1" name="">
+          <a:extLst>
+            <a:ext uri="{FF2B5EF4-FFF2-40B4-BE49-F238E27FC236}">
+              <a16:creationId xmlns:a16="http://schemas.microsoft.com/office/drawing/2014/main" id="{B13A0AAF-9226-09BF-DFA2-8E7B55565C39}"/>
+            </a:ext>
+          </a:extLst>
+        </p:cNvPr>
+        <p:cNvGrpSpPr/>
+        <p:nvPr/>
+      </p:nvGrpSpPr>
+      <p:grpSpPr>
+        <a:xfrm>
+          <a:off x="0" y="0"/>
+          <a:ext cx="0" cy="0"/>
+          <a:chOff x="0" y="0"/>
+          <a:chExt cx="0" cy="0"/>
+        </a:xfrm>
+      </p:grpSpPr>
+      <p:sp>
+        <p:nvSpPr>
+          <p:cNvPr id="2" name="Title 1">
+            <a:extLst>
+              <a:ext uri="{FF2B5EF4-FFF2-40B4-BE49-F238E27FC236}">
+                <a16:creationId xmlns:a16="http://schemas.microsoft.com/office/drawing/2014/main" id="{CB952951-29D7-74FB-082A-F008CF865A76}"/>
+              </a:ext>
+            </a:extLst>
+          </p:cNvPr>
+          <p:cNvSpPr>
+            <a:spLocks noGrp="1"/>
+          </p:cNvSpPr>
+          <p:nvPr>
+            <p:ph type="title"/>
+          </p:nvPr>
+        </p:nvSpPr>
+        <p:spPr>
+          <a:xfrm>
+            <a:off x="838200" y="365126"/>
+            <a:ext cx="10515600" cy="718608"/>
+          </a:xfrm>
+        </p:spPr>
+        <p:txBody>
+          <a:bodyPr>
+            <a:normAutofit/>
+          </a:bodyPr>
+          <a:lstStyle/>
+          <a:p>
+            <a:r>
+              <a:rPr lang="nl-NL" sz="3600" dirty="0"/>
+              <a:t>Functie van __init__.py</a:t>
+            </a:r>
+            <a:endParaRPr lang="nl-NL" sz="3600" noProof="0" dirty="0"/>
+          </a:p>
+        </p:txBody>
+      </p:sp>
+      <p:sp>
+        <p:nvSpPr>
           <p:cNvPr id="3" name="Content Placeholder 2">
             <a:extLst>
               <a:ext uri="{FF2B5EF4-FFF2-40B4-BE49-F238E27FC236}">
-                <a16:creationId xmlns:a16="http://schemas.microsoft.com/office/drawing/2014/main" id="{C893D080-831C-D6F8-F21E-78125CD6E82A}"/>
+                <a16:creationId xmlns:a16="http://schemas.microsoft.com/office/drawing/2014/main" id="{6AC04D14-B924-5F9E-91E0-45FFC19E1A3A}"/>
               </a:ext>
             </a:extLst>
           </p:cNvPr>
@@ -23446,10 +23906,544 @@
       </p:sp>
       <p:sp>
         <p:nvSpPr>
+          <p:cNvPr id="7" name="Content Placeholder 2">
+            <a:extLst>
+              <a:ext uri="{FF2B5EF4-FFF2-40B4-BE49-F238E27FC236}">
+                <a16:creationId xmlns:a16="http://schemas.microsoft.com/office/drawing/2014/main" id="{F2F57477-C5C1-5AE5-C310-A837777CE51F}"/>
+              </a:ext>
+            </a:extLst>
+          </p:cNvPr>
+          <p:cNvSpPr txBox="1">
+            <a:spLocks/>
+          </p:cNvSpPr>
+          <p:nvPr/>
+        </p:nvSpPr>
+        <p:spPr>
+          <a:xfrm>
+            <a:off x="4760239" y="1377779"/>
+            <a:ext cx="2400587" cy="1705231"/>
+          </a:xfrm>
+          <a:prstGeom prst="rect">
+            <a:avLst/>
+          </a:prstGeom>
+        </p:spPr>
+        <p:txBody>
+          <a:bodyPr vert="horz" lIns="91440" tIns="45720" rIns="91440" bIns="45720" rtlCol="0">
+            <a:noAutofit/>
+          </a:bodyPr>
+          <a:lstStyle>
+            <a:lvl1pPr marL="228600" indent="-228600" algn="l" defTabSz="914400" rtl="0" eaLnBrk="1" latinLnBrk="0" hangingPunct="1">
+              <a:lnSpc>
+                <a:spcPct val="90000"/>
+              </a:lnSpc>
+              <a:spcBef>
+                <a:spcPts val="1000"/>
+              </a:spcBef>
+              <a:buFont typeface="Arial" panose="020B0604020202020204" pitchFamily="34" charset="0"/>
+              <a:buChar char="•"/>
+              <a:defRPr sz="2800" kern="1200">
+                <a:solidFill>
+                  <a:schemeClr val="tx1"/>
+                </a:solidFill>
+                <a:latin typeface="+mn-lt"/>
+                <a:ea typeface="+mn-ea"/>
+                <a:cs typeface="+mn-cs"/>
+              </a:defRPr>
+            </a:lvl1pPr>
+            <a:lvl2pPr marL="685800" indent="-228600" algn="l" defTabSz="914400" rtl="0" eaLnBrk="1" latinLnBrk="0" hangingPunct="1">
+              <a:lnSpc>
+                <a:spcPct val="90000"/>
+              </a:lnSpc>
+              <a:spcBef>
+                <a:spcPts val="500"/>
+              </a:spcBef>
+              <a:buFont typeface="Arial" panose="020B0604020202020204" pitchFamily="34" charset="0"/>
+              <a:buChar char="•"/>
+              <a:defRPr sz="2400" kern="1200">
+                <a:solidFill>
+                  <a:schemeClr val="tx1"/>
+                </a:solidFill>
+                <a:latin typeface="+mn-lt"/>
+                <a:ea typeface="+mn-ea"/>
+                <a:cs typeface="+mn-cs"/>
+              </a:defRPr>
+            </a:lvl2pPr>
+            <a:lvl3pPr marL="1143000" indent="-228600" algn="l" defTabSz="914400" rtl="0" eaLnBrk="1" latinLnBrk="0" hangingPunct="1">
+              <a:lnSpc>
+                <a:spcPct val="90000"/>
+              </a:lnSpc>
+              <a:spcBef>
+                <a:spcPts val="500"/>
+              </a:spcBef>
+              <a:buFont typeface="Arial" panose="020B0604020202020204" pitchFamily="34" charset="0"/>
+              <a:buChar char="•"/>
+              <a:defRPr sz="2000" kern="1200">
+                <a:solidFill>
+                  <a:schemeClr val="tx1"/>
+                </a:solidFill>
+                <a:latin typeface="+mn-lt"/>
+                <a:ea typeface="+mn-ea"/>
+                <a:cs typeface="+mn-cs"/>
+              </a:defRPr>
+            </a:lvl3pPr>
+            <a:lvl4pPr marL="1600200" indent="-228600" algn="l" defTabSz="914400" rtl="0" eaLnBrk="1" latinLnBrk="0" hangingPunct="1">
+              <a:lnSpc>
+                <a:spcPct val="90000"/>
+              </a:lnSpc>
+              <a:spcBef>
+                <a:spcPts val="500"/>
+              </a:spcBef>
+              <a:buFont typeface="Arial" panose="020B0604020202020204" pitchFamily="34" charset="0"/>
+              <a:buChar char="•"/>
+              <a:defRPr sz="1800" kern="1200">
+                <a:solidFill>
+                  <a:schemeClr val="tx1"/>
+                </a:solidFill>
+                <a:latin typeface="+mn-lt"/>
+                <a:ea typeface="+mn-ea"/>
+                <a:cs typeface="+mn-cs"/>
+              </a:defRPr>
+            </a:lvl4pPr>
+            <a:lvl5pPr marL="2057400" indent="-228600" algn="l" defTabSz="914400" rtl="0" eaLnBrk="1" latinLnBrk="0" hangingPunct="1">
+              <a:lnSpc>
+                <a:spcPct val="90000"/>
+              </a:lnSpc>
+              <a:spcBef>
+                <a:spcPts val="500"/>
+              </a:spcBef>
+              <a:buFont typeface="Arial" panose="020B0604020202020204" pitchFamily="34" charset="0"/>
+              <a:buChar char="•"/>
+              <a:defRPr sz="1800" kern="1200">
+                <a:solidFill>
+                  <a:schemeClr val="tx1"/>
+                </a:solidFill>
+                <a:latin typeface="+mn-lt"/>
+                <a:ea typeface="+mn-ea"/>
+                <a:cs typeface="+mn-cs"/>
+              </a:defRPr>
+            </a:lvl5pPr>
+            <a:lvl6pPr marL="2514600" indent="-228600" algn="l" defTabSz="914400" rtl="0" eaLnBrk="1" latinLnBrk="0" hangingPunct="1">
+              <a:lnSpc>
+                <a:spcPct val="90000"/>
+              </a:lnSpc>
+              <a:spcBef>
+                <a:spcPts val="500"/>
+              </a:spcBef>
+              <a:buFont typeface="Arial" panose="020B0604020202020204" pitchFamily="34" charset="0"/>
+              <a:buChar char="•"/>
+              <a:defRPr sz="1800" kern="1200">
+                <a:solidFill>
+                  <a:schemeClr val="tx1"/>
+                </a:solidFill>
+                <a:latin typeface="+mn-lt"/>
+                <a:ea typeface="+mn-ea"/>
+                <a:cs typeface="+mn-cs"/>
+              </a:defRPr>
+            </a:lvl6pPr>
+            <a:lvl7pPr marL="2971800" indent="-228600" algn="l" defTabSz="914400" rtl="0" eaLnBrk="1" latinLnBrk="0" hangingPunct="1">
+              <a:lnSpc>
+                <a:spcPct val="90000"/>
+              </a:lnSpc>
+              <a:spcBef>
+                <a:spcPts val="500"/>
+              </a:spcBef>
+              <a:buFont typeface="Arial" panose="020B0604020202020204" pitchFamily="34" charset="0"/>
+              <a:buChar char="•"/>
+              <a:defRPr sz="1800" kern="1200">
+                <a:solidFill>
+                  <a:schemeClr val="tx1"/>
+                </a:solidFill>
+                <a:latin typeface="+mn-lt"/>
+                <a:ea typeface="+mn-ea"/>
+                <a:cs typeface="+mn-cs"/>
+              </a:defRPr>
+            </a:lvl7pPr>
+            <a:lvl8pPr marL="3429000" indent="-228600" algn="l" defTabSz="914400" rtl="0" eaLnBrk="1" latinLnBrk="0" hangingPunct="1">
+              <a:lnSpc>
+                <a:spcPct val="90000"/>
+              </a:lnSpc>
+              <a:spcBef>
+                <a:spcPts val="500"/>
+              </a:spcBef>
+              <a:buFont typeface="Arial" panose="020B0604020202020204" pitchFamily="34" charset="0"/>
+              <a:buChar char="•"/>
+              <a:defRPr sz="1800" kern="1200">
+                <a:solidFill>
+                  <a:schemeClr val="tx1"/>
+                </a:solidFill>
+                <a:latin typeface="+mn-lt"/>
+                <a:ea typeface="+mn-ea"/>
+                <a:cs typeface="+mn-cs"/>
+              </a:defRPr>
+            </a:lvl8pPr>
+            <a:lvl9pPr marL="3886200" indent="-228600" algn="l" defTabSz="914400" rtl="0" eaLnBrk="1" latinLnBrk="0" hangingPunct="1">
+              <a:lnSpc>
+                <a:spcPct val="90000"/>
+              </a:lnSpc>
+              <a:spcBef>
+                <a:spcPts val="500"/>
+              </a:spcBef>
+              <a:buFont typeface="Arial" panose="020B0604020202020204" pitchFamily="34" charset="0"/>
+              <a:buChar char="•"/>
+              <a:defRPr sz="1800" kern="1200">
+                <a:solidFill>
+                  <a:schemeClr val="tx1"/>
+                </a:solidFill>
+                <a:latin typeface="+mn-lt"/>
+                <a:ea typeface="+mn-ea"/>
+                <a:cs typeface="+mn-cs"/>
+              </a:defRPr>
+            </a:lvl9pPr>
+          </a:lstStyle>
+          <a:p>
+            <a:pPr marL="0" indent="0">
+              <a:spcBef>
+                <a:spcPts val="0"/>
+              </a:spcBef>
+              <a:buNone/>
+            </a:pPr>
+            <a:r>
+              <a:rPr lang="nl-NL" sz="1600" dirty="0" err="1">
+                <a:latin typeface="Courier New" panose="02070309020205020404" pitchFamily="49" charset="0"/>
+                <a:cs typeface="Courier New" panose="02070309020205020404" pitchFamily="49" charset="0"/>
+              </a:rPr>
+              <a:t>src</a:t>
+            </a:r>
+            <a:r>
+              <a:rPr lang="nl-NL" sz="1600" dirty="0">
+                <a:latin typeface="Courier New" panose="02070309020205020404" pitchFamily="49" charset="0"/>
+                <a:cs typeface="Courier New" panose="02070309020205020404" pitchFamily="49" charset="0"/>
+              </a:rPr>
+              <a:t>/</a:t>
+            </a:r>
+          </a:p>
+          <a:p>
+            <a:pPr marL="0" indent="0">
+              <a:spcBef>
+                <a:spcPts val="0"/>
+              </a:spcBef>
+              <a:buNone/>
+            </a:pPr>
+            <a:r>
+              <a:rPr lang="nl-NL" sz="1600" dirty="0">
+                <a:latin typeface="Courier New" panose="02070309020205020404" pitchFamily="49" charset="0"/>
+                <a:cs typeface="Courier New" panose="02070309020205020404" pitchFamily="49" charset="0"/>
+              </a:rPr>
+              <a:t>│</a:t>
+            </a:r>
+          </a:p>
+          <a:p>
+            <a:pPr marL="0" indent="0">
+              <a:spcBef>
+                <a:spcPts val="0"/>
+              </a:spcBef>
+              <a:buNone/>
+            </a:pPr>
+            <a:r>
+              <a:rPr lang="nl-NL" sz="1600" dirty="0">
+                <a:latin typeface="Courier New" panose="02070309020205020404" pitchFamily="49" charset="0"/>
+                <a:cs typeface="Courier New" panose="02070309020205020404" pitchFamily="49" charset="0"/>
+              </a:rPr>
+              <a:t>└─ </a:t>
+            </a:r>
+            <a:r>
+              <a:rPr lang="nl-NL" sz="1600" dirty="0" err="1">
+                <a:latin typeface="Courier New" panose="02070309020205020404" pitchFamily="49" charset="0"/>
+                <a:cs typeface="Courier New" panose="02070309020205020404" pitchFamily="49" charset="0"/>
+              </a:rPr>
+              <a:t>hi_world</a:t>
+            </a:r>
+            <a:r>
+              <a:rPr lang="nl-NL" sz="1600" dirty="0">
+                <a:latin typeface="Courier New" panose="02070309020205020404" pitchFamily="49" charset="0"/>
+                <a:cs typeface="Courier New" panose="02070309020205020404" pitchFamily="49" charset="0"/>
+              </a:rPr>
+              <a:t> /</a:t>
+            </a:r>
+          </a:p>
+          <a:p>
+            <a:pPr marL="0" indent="0">
+              <a:spcBef>
+                <a:spcPts val="0"/>
+              </a:spcBef>
+              <a:buNone/>
+            </a:pPr>
+            <a:r>
+              <a:rPr lang="nl-NL" sz="1600" dirty="0">
+                <a:latin typeface="Courier New" panose="02070309020205020404" pitchFamily="49" charset="0"/>
+                <a:cs typeface="Courier New" panose="02070309020205020404" pitchFamily="49" charset="0"/>
+              </a:rPr>
+              <a:t>   │</a:t>
+            </a:r>
+          </a:p>
+          <a:p>
+            <a:pPr marL="0" indent="0">
+              <a:spcBef>
+                <a:spcPts val="0"/>
+              </a:spcBef>
+              <a:buNone/>
+            </a:pPr>
+            <a:r>
+              <a:rPr lang="nl-NL" sz="1600" dirty="0">
+                <a:latin typeface="Courier New" panose="02070309020205020404" pitchFamily="49" charset="0"/>
+                <a:cs typeface="Courier New" panose="02070309020205020404" pitchFamily="49" charset="0"/>
+              </a:rPr>
+              <a:t>   ├─ __init__.py</a:t>
+            </a:r>
+          </a:p>
+          <a:p>
+            <a:pPr marL="0" indent="0">
+              <a:spcBef>
+                <a:spcPts val="0"/>
+              </a:spcBef>
+              <a:buNone/>
+            </a:pPr>
+            <a:r>
+              <a:rPr lang="nl-NL" sz="1600" dirty="0">
+                <a:latin typeface="Courier New" panose="02070309020205020404" pitchFamily="49" charset="0"/>
+                <a:cs typeface="Courier New" panose="02070309020205020404" pitchFamily="49" charset="0"/>
+              </a:rPr>
+              <a:t>   │     </a:t>
+            </a:r>
+          </a:p>
+          <a:p>
+            <a:pPr marL="0" indent="0">
+              <a:spcBef>
+                <a:spcPts val="0"/>
+              </a:spcBef>
+              <a:buNone/>
+            </a:pPr>
+            <a:r>
+              <a:rPr lang="nl-NL" sz="1600" dirty="0">
+                <a:latin typeface="Courier New" panose="02070309020205020404" pitchFamily="49" charset="0"/>
+                <a:cs typeface="Courier New" panose="02070309020205020404" pitchFamily="49" charset="0"/>
+              </a:rPr>
+              <a:t>   └─ greet.py</a:t>
+            </a:r>
+          </a:p>
+        </p:txBody>
+      </p:sp>
+    </p:spTree>
+    <p:extLst>
+      <p:ext uri="{BB962C8B-B14F-4D97-AF65-F5344CB8AC3E}">
+        <p14:creationId xmlns:p14="http://schemas.microsoft.com/office/powerpoint/2010/main" val="223850850"/>
+      </p:ext>
+    </p:extLst>
+  </p:cSld>
+  <p:clrMapOvr>
+    <a:masterClrMapping/>
+  </p:clrMapOvr>
+</p:sld>
+</file>
+
+<file path=ppt/slides/slide43.xml><?xml version="1.0" encoding="utf-8"?>
+<p:sld xmlns:a="http://schemas.openxmlformats.org/drawingml/2006/main" xmlns:r="http://schemas.openxmlformats.org/officeDocument/2006/relationships" xmlns:p="http://schemas.openxmlformats.org/presentationml/2006/main">
+  <p:cSld>
+    <p:spTree>
+      <p:nvGrpSpPr>
+        <p:cNvPr id="1" name="">
+          <a:extLst>
+            <a:ext uri="{FF2B5EF4-FFF2-40B4-BE49-F238E27FC236}">
+              <a16:creationId xmlns:a16="http://schemas.microsoft.com/office/drawing/2014/main" id="{12346A97-8717-48B9-A42F-20B618D52DF0}"/>
+            </a:ext>
+          </a:extLst>
+        </p:cNvPr>
+        <p:cNvGrpSpPr/>
+        <p:nvPr/>
+      </p:nvGrpSpPr>
+      <p:grpSpPr>
+        <a:xfrm>
+          <a:off x="0" y="0"/>
+          <a:ext cx="0" cy="0"/>
+          <a:chOff x="0" y="0"/>
+          <a:chExt cx="0" cy="0"/>
+        </a:xfrm>
+      </p:grpSpPr>
+      <p:sp>
+        <p:nvSpPr>
+          <p:cNvPr id="2" name="Title 1">
+            <a:extLst>
+              <a:ext uri="{FF2B5EF4-FFF2-40B4-BE49-F238E27FC236}">
+                <a16:creationId xmlns:a16="http://schemas.microsoft.com/office/drawing/2014/main" id="{600ED08E-5EC3-7D8B-AE8F-2DCCA2175879}"/>
+              </a:ext>
+            </a:extLst>
+          </p:cNvPr>
+          <p:cNvSpPr>
+            <a:spLocks noGrp="1"/>
+          </p:cNvSpPr>
+          <p:nvPr>
+            <p:ph type="title"/>
+          </p:nvPr>
+        </p:nvSpPr>
+        <p:spPr>
+          <a:xfrm>
+            <a:off x="838200" y="365126"/>
+            <a:ext cx="10515600" cy="718608"/>
+          </a:xfrm>
+        </p:spPr>
+        <p:txBody>
+          <a:bodyPr>
+            <a:normAutofit/>
+          </a:bodyPr>
+          <a:lstStyle/>
+          <a:p>
+            <a:r>
+              <a:rPr lang="nl-NL" sz="3600" dirty="0"/>
+              <a:t>Functie van __init__.py</a:t>
+            </a:r>
+            <a:endParaRPr lang="nl-NL" sz="3600" noProof="0" dirty="0"/>
+          </a:p>
+        </p:txBody>
+      </p:sp>
+      <p:sp>
+        <p:nvSpPr>
+          <p:cNvPr id="3" name="Content Placeholder 2">
+            <a:extLst>
+              <a:ext uri="{FF2B5EF4-FFF2-40B4-BE49-F238E27FC236}">
+                <a16:creationId xmlns:a16="http://schemas.microsoft.com/office/drawing/2014/main" id="{526FB5EF-B5D1-96CF-4426-715353F0E44F}"/>
+              </a:ext>
+            </a:extLst>
+          </p:cNvPr>
+          <p:cNvSpPr>
+            <a:spLocks noGrp="1"/>
+          </p:cNvSpPr>
+          <p:nvPr>
+            <p:ph idx="1"/>
+          </p:nvPr>
+        </p:nvSpPr>
+        <p:spPr>
+          <a:xfrm>
+            <a:off x="838198" y="3632885"/>
+            <a:ext cx="4715935" cy="2544077"/>
+          </a:xfrm>
+        </p:spPr>
+        <p:txBody>
+          <a:bodyPr>
+            <a:normAutofit/>
+          </a:bodyPr>
+          <a:lstStyle/>
+          <a:p>
+            <a:pPr marL="0" indent="0">
+              <a:buNone/>
+            </a:pPr>
+            <a:r>
+              <a:rPr lang="nl-NL" sz="1800" b="1" dirty="0">
+                <a:cs typeface="Courier New" panose="02070309020205020404" pitchFamily="49" charset="0"/>
+              </a:rPr>
+              <a:t>Inhoud</a:t>
+            </a:r>
+            <a:r>
+              <a:rPr lang="nl-NL" sz="1800" b="1" dirty="0">
+                <a:latin typeface="Courier New" panose="02070309020205020404" pitchFamily="49" charset="0"/>
+                <a:cs typeface="Courier New" panose="02070309020205020404" pitchFamily="49" charset="0"/>
+              </a:rPr>
+              <a:t> __init__.py:</a:t>
+            </a:r>
+          </a:p>
+          <a:p>
+            <a:pPr marL="0" indent="0">
+              <a:buNone/>
+            </a:pPr>
+            <a:r>
+              <a:rPr lang="nl-NL" sz="1800" dirty="0">
+                <a:latin typeface="Courier New" panose="02070309020205020404" pitchFamily="49" charset="0"/>
+                <a:cs typeface="Courier New" panose="02070309020205020404" pitchFamily="49" charset="0"/>
+              </a:rPr>
+              <a:t>&lt;leeg&gt;</a:t>
+            </a:r>
+          </a:p>
+          <a:p>
+            <a:pPr marL="0" indent="0">
+              <a:buNone/>
+            </a:pPr>
+            <a:endParaRPr lang="nl-NL" sz="1800" dirty="0">
+              <a:latin typeface="Courier New" panose="02070309020205020404" pitchFamily="49" charset="0"/>
+              <a:cs typeface="Courier New" panose="02070309020205020404" pitchFamily="49" charset="0"/>
+            </a:endParaRPr>
+          </a:p>
+          <a:p>
+            <a:pPr marL="0" indent="0">
+              <a:buNone/>
+            </a:pPr>
+            <a:r>
+              <a:rPr lang="nl-NL" sz="1800" b="1" dirty="0">
+                <a:cs typeface="Courier New" panose="02070309020205020404" pitchFamily="49" charset="0"/>
+              </a:rPr>
+              <a:t>Importeren:</a:t>
+            </a:r>
+          </a:p>
+          <a:p>
+            <a:pPr marL="0" indent="0">
+              <a:buNone/>
+            </a:pPr>
+            <a:r>
+              <a:rPr lang="nl-NL" sz="1800" dirty="0" err="1">
+                <a:solidFill>
+                  <a:srgbClr val="7030A0"/>
+                </a:solidFill>
+                <a:latin typeface="Courier New" panose="02070309020205020404" pitchFamily="49" charset="0"/>
+                <a:cs typeface="Courier New" panose="02070309020205020404" pitchFamily="49" charset="0"/>
+              </a:rPr>
+              <a:t>from</a:t>
+            </a:r>
+            <a:r>
+              <a:rPr lang="nl-NL" sz="1800" dirty="0">
+                <a:latin typeface="Courier New" panose="02070309020205020404" pitchFamily="49" charset="0"/>
+                <a:cs typeface="Courier New" panose="02070309020205020404" pitchFamily="49" charset="0"/>
+              </a:rPr>
+              <a:t> </a:t>
+            </a:r>
+            <a:r>
+              <a:rPr lang="nl-NL" sz="1800" dirty="0" err="1">
+                <a:latin typeface="Courier New" panose="02070309020205020404" pitchFamily="49" charset="0"/>
+                <a:cs typeface="Courier New" panose="02070309020205020404" pitchFamily="49" charset="0"/>
+              </a:rPr>
+              <a:t>hi_world.greet</a:t>
+            </a:r>
+            <a:r>
+              <a:rPr lang="nl-NL" sz="1800" dirty="0">
+                <a:latin typeface="Courier New" panose="02070309020205020404" pitchFamily="49" charset="0"/>
+                <a:cs typeface="Courier New" panose="02070309020205020404" pitchFamily="49" charset="0"/>
+              </a:rPr>
+              <a:t> </a:t>
+            </a:r>
+            <a:r>
+              <a:rPr lang="nl-NL" sz="1800" dirty="0">
+                <a:solidFill>
+                  <a:srgbClr val="7030A0"/>
+                </a:solidFill>
+                <a:latin typeface="Courier New" panose="02070309020205020404" pitchFamily="49" charset="0"/>
+                <a:cs typeface="Courier New" panose="02070309020205020404" pitchFamily="49" charset="0"/>
+              </a:rPr>
+              <a:t>import</a:t>
+            </a:r>
+            <a:r>
+              <a:rPr lang="nl-NL" sz="1800" dirty="0">
+                <a:latin typeface="Courier New" panose="02070309020205020404" pitchFamily="49" charset="0"/>
+                <a:cs typeface="Courier New" panose="02070309020205020404" pitchFamily="49" charset="0"/>
+              </a:rPr>
+              <a:t> </a:t>
+            </a:r>
+            <a:r>
+              <a:rPr lang="nl-NL" sz="1800" dirty="0" err="1">
+                <a:latin typeface="Courier New" panose="02070309020205020404" pitchFamily="49" charset="0"/>
+                <a:cs typeface="Courier New" panose="02070309020205020404" pitchFamily="49" charset="0"/>
+              </a:rPr>
+              <a:t>hello</a:t>
+            </a:r>
+            <a:endParaRPr lang="nl-NL" sz="1800" dirty="0">
+              <a:latin typeface="Courier New" panose="02070309020205020404" pitchFamily="49" charset="0"/>
+              <a:cs typeface="Courier New" panose="02070309020205020404" pitchFamily="49" charset="0"/>
+            </a:endParaRPr>
+          </a:p>
+        </p:txBody>
+      </p:sp>
+      <p:sp>
+        <p:nvSpPr>
           <p:cNvPr id="5" name="Content Placeholder 2">
             <a:extLst>
               <a:ext uri="{FF2B5EF4-FFF2-40B4-BE49-F238E27FC236}">
-                <a16:creationId xmlns:a16="http://schemas.microsoft.com/office/drawing/2014/main" id="{54402707-3B5E-3D4E-880B-81EE7166113B}"/>
+                <a16:creationId xmlns:a16="http://schemas.microsoft.com/office/drawing/2014/main" id="{33997DED-0C26-0CDD-C683-DA1B1621D31F}"/>
               </a:ext>
             </a:extLst>
           </p:cNvPr>
@@ -23808,7 +24802,7 @@
           <p:cNvPr id="4" name="Straight Connector 3">
             <a:extLst>
               <a:ext uri="{FF2B5EF4-FFF2-40B4-BE49-F238E27FC236}">
-                <a16:creationId xmlns:a16="http://schemas.microsoft.com/office/drawing/2014/main" id="{3E3C33AF-342F-C740-ACFD-62CAB82B7580}"/>
+                <a16:creationId xmlns:a16="http://schemas.microsoft.com/office/drawing/2014/main" id="{79E3EDDD-67FF-F7CE-2771-098199B38990}"/>
               </a:ext>
             </a:extLst>
           </p:cNvPr>
@@ -23846,7 +24840,7 @@
           <p:cNvPr id="7" name="Content Placeholder 2">
             <a:extLst>
               <a:ext uri="{FF2B5EF4-FFF2-40B4-BE49-F238E27FC236}">
-                <a16:creationId xmlns:a16="http://schemas.microsoft.com/office/drawing/2014/main" id="{77A33588-7257-AFA3-2116-EE339FD4C232}"/>
+                <a16:creationId xmlns:a16="http://schemas.microsoft.com/office/drawing/2014/main" id="{5DEA8ADA-DFF7-463A-B7D6-DEFDD6B7D352}"/>
               </a:ext>
             </a:extLst>
           </p:cNvPr>
@@ -24163,7 +25157,7 @@
     </p:spTree>
     <p:extLst>
       <p:ext uri="{BB962C8B-B14F-4D97-AF65-F5344CB8AC3E}">
-        <p14:creationId xmlns:p14="http://schemas.microsoft.com/office/powerpoint/2010/main" val="1209835813"/>
+        <p14:creationId xmlns:p14="http://schemas.microsoft.com/office/powerpoint/2010/main" val="747279176"/>
       </p:ext>
     </p:extLst>
   </p:cSld>
@@ -24173,7 +25167,7 @@
 </p:sld>
 </file>
 
-<file path=ppt/slides/slide42.xml><?xml version="1.0" encoding="utf-8"?>
+<file path=ppt/slides/slide44.xml><?xml version="1.0" encoding="utf-8"?>
 <p:sld xmlns:a="http://schemas.openxmlformats.org/drawingml/2006/main" xmlns:r="http://schemas.openxmlformats.org/officeDocument/2006/relationships" xmlns:p="http://schemas.openxmlformats.org/presentationml/2006/main">
   <p:cSld>
     <p:spTree>
@@ -24803,7 +25797,7 @@
             </a:pPr>
             <a:r>
               <a:rPr lang="nl-NL" sz="2000" dirty="0"/>
-              <a:t>Scripts zijn CLI commando's die je package kan uitvoeren.</a:t>
+              <a:t>Scripts zijn shell commando's die je package kan uitvoeren.</a:t>
             </a:r>
           </a:p>
           <a:p>
@@ -25112,7 +26106,7 @@
 </p:sld>
 </file>
 
-<file path=ppt/slides/slide43.xml><?xml version="1.0" encoding="utf-8"?>
+<file path=ppt/slides/slide45.xml><?xml version="1.0" encoding="utf-8"?>
 <p:sld xmlns:a="http://schemas.openxmlformats.org/drawingml/2006/main" xmlns:r="http://schemas.openxmlformats.org/officeDocument/2006/relationships" xmlns:p="http://schemas.openxmlformats.org/presentationml/2006/main">
   <p:cSld>
     <p:spTree>
@@ -25596,7 +26590,7 @@
 </p:sld>
 </file>
 
-<file path=ppt/slides/slide44.xml><?xml version="1.0" encoding="utf-8"?>
+<file path=ppt/slides/slide46.xml><?xml version="1.0" encoding="utf-8"?>
 <p:sld xmlns:a="http://schemas.openxmlformats.org/drawingml/2006/main" xmlns:r="http://schemas.openxmlformats.org/officeDocument/2006/relationships" xmlns:p="http://schemas.openxmlformats.org/presentationml/2006/main">
   <p:cSld>
     <p:spTree>
@@ -26247,7 +27241,7 @@
 </p:sld>
 </file>
 
-<file path=ppt/slides/slide45.xml><?xml version="1.0" encoding="utf-8"?>
+<file path=ppt/slides/slide47.xml><?xml version="1.0" encoding="utf-8"?>
 <p:sld xmlns:a="http://schemas.openxmlformats.org/drawingml/2006/main" xmlns:r="http://schemas.openxmlformats.org/officeDocument/2006/relationships" xmlns:p="http://schemas.openxmlformats.org/presentationml/2006/main">
   <p:cSld>
     <p:spTree>
@@ -26336,7 +27330,7 @@
 </p:sld>
 </file>
 
-<file path=ppt/slides/slide46.xml><?xml version="1.0" encoding="utf-8"?>
+<file path=ppt/slides/slide48.xml><?xml version="1.0" encoding="utf-8"?>
 <p:sld xmlns:a="http://schemas.openxmlformats.org/drawingml/2006/main" xmlns:r="http://schemas.openxmlformats.org/officeDocument/2006/relationships" xmlns:p="http://schemas.openxmlformats.org/presentationml/2006/main">
   <p:cSld>
     <p:spTree>
@@ -26794,7 +27788,7 @@
 </p:sld>
 </file>
 
-<file path=ppt/slides/slide47.xml><?xml version="1.0" encoding="utf-8"?>
+<file path=ppt/slides/slide49.xml><?xml version="1.0" encoding="utf-8"?>
 <p:sld xmlns:a="http://schemas.openxmlformats.org/drawingml/2006/main" xmlns:r="http://schemas.openxmlformats.org/officeDocument/2006/relationships" xmlns:p="http://schemas.openxmlformats.org/presentationml/2006/main">
   <p:cSld>
     <p:spTree>
@@ -27348,7 +28342,947 @@
 </p:sld>
 </file>
 
-<file path=ppt/slides/slide48.xml><?xml version="1.0" encoding="utf-8"?>
+<file path=ppt/slides/slide5.xml><?xml version="1.0" encoding="utf-8"?>
+<p:sld xmlns:a="http://schemas.openxmlformats.org/drawingml/2006/main" xmlns:r="http://schemas.openxmlformats.org/officeDocument/2006/relationships" xmlns:p="http://schemas.openxmlformats.org/presentationml/2006/main">
+  <p:cSld>
+    <p:spTree>
+      <p:nvGrpSpPr>
+        <p:cNvPr id="1" name="">
+          <a:extLst>
+            <a:ext uri="{FF2B5EF4-FFF2-40B4-BE49-F238E27FC236}">
+              <a16:creationId xmlns:a16="http://schemas.microsoft.com/office/drawing/2014/main" id="{F4B537BD-A938-DAF3-FEF2-1B5E3A6E1778}"/>
+            </a:ext>
+          </a:extLst>
+        </p:cNvPr>
+        <p:cNvGrpSpPr/>
+        <p:nvPr/>
+      </p:nvGrpSpPr>
+      <p:grpSpPr>
+        <a:xfrm>
+          <a:off x="0" y="0"/>
+          <a:ext cx="0" cy="0"/>
+          <a:chOff x="0" y="0"/>
+          <a:chExt cx="0" cy="0"/>
+        </a:xfrm>
+      </p:grpSpPr>
+      <p:sp>
+        <p:nvSpPr>
+          <p:cNvPr id="2" name="Title 1">
+            <a:extLst>
+              <a:ext uri="{FF2B5EF4-FFF2-40B4-BE49-F238E27FC236}">
+                <a16:creationId xmlns:a16="http://schemas.microsoft.com/office/drawing/2014/main" id="{9934E2EF-C0A7-A70B-04F1-1E24BD18D62D}"/>
+              </a:ext>
+            </a:extLst>
+          </p:cNvPr>
+          <p:cNvSpPr>
+            <a:spLocks noGrp="1"/>
+          </p:cNvSpPr>
+          <p:nvPr>
+            <p:ph type="title"/>
+          </p:nvPr>
+        </p:nvSpPr>
+        <p:spPr>
+          <a:xfrm>
+            <a:off x="838200" y="365126"/>
+            <a:ext cx="10515600" cy="718608"/>
+          </a:xfrm>
+        </p:spPr>
+        <p:txBody>
+          <a:bodyPr>
+            <a:normAutofit/>
+          </a:bodyPr>
+          <a:lstStyle/>
+          <a:p>
+            <a:r>
+              <a:rPr lang="nl-NL" sz="3600" noProof="0" dirty="0"/>
+              <a:t>Zwakke punten</a:t>
+            </a:r>
+          </a:p>
+        </p:txBody>
+      </p:sp>
+      <p:sp>
+        <p:nvSpPr>
+          <p:cNvPr id="3" name="Content Placeholder 2">
+            <a:extLst>
+              <a:ext uri="{FF2B5EF4-FFF2-40B4-BE49-F238E27FC236}">
+                <a16:creationId xmlns:a16="http://schemas.microsoft.com/office/drawing/2014/main" id="{AE69D57C-00B8-1248-107F-AA6E5F085DF9}"/>
+              </a:ext>
+            </a:extLst>
+          </p:cNvPr>
+          <p:cNvSpPr>
+            <a:spLocks noGrp="1"/>
+          </p:cNvSpPr>
+          <p:nvPr>
+            <p:ph idx="1"/>
+          </p:nvPr>
+        </p:nvSpPr>
+        <p:spPr>
+          <a:xfrm>
+            <a:off x="838200" y="1456267"/>
+            <a:ext cx="4749800" cy="4720696"/>
+          </a:xfrm>
+        </p:spPr>
+        <p:txBody>
+          <a:bodyPr>
+            <a:normAutofit/>
+          </a:bodyPr>
+          <a:lstStyle/>
+          <a:p>
+            <a:pPr>
+              <a:buFontTx/>
+              <a:buChar char="-"/>
+            </a:pPr>
+            <a:r>
+              <a:rPr lang="nl-NL" sz="1800" dirty="0"/>
+              <a:t>Makkelijk om “slechte” code te schrijven.</a:t>
+            </a:r>
+          </a:p>
+          <a:p>
+            <a:pPr>
+              <a:buFontTx/>
+              <a:buChar char="-"/>
+            </a:pPr>
+            <a:endParaRPr lang="nl-NL" sz="1800" dirty="0"/>
+          </a:p>
+          <a:p>
+            <a:pPr>
+              <a:buFontTx/>
+              <a:buChar char="-"/>
+            </a:pPr>
+            <a:r>
+              <a:rPr lang="nl-NL" sz="1800" dirty="0"/>
+              <a:t>Relatief traag  (vgl. C, C++, Rust).</a:t>
+            </a:r>
+          </a:p>
+          <a:p>
+            <a:pPr>
+              <a:buFontTx/>
+              <a:buChar char="-"/>
+            </a:pPr>
+            <a:endParaRPr lang="nl-NL" sz="1800" dirty="0"/>
+          </a:p>
+          <a:p>
+            <a:pPr>
+              <a:buFontTx/>
+              <a:buChar char="-"/>
+            </a:pPr>
+            <a:r>
+              <a:rPr lang="nl-NL" sz="1800" dirty="0"/>
+              <a:t>Fouten komen aan het licht bij uitvoeren code.</a:t>
+            </a:r>
+          </a:p>
+          <a:p>
+            <a:pPr>
+              <a:buFontTx/>
+              <a:buChar char="-"/>
+            </a:pPr>
+            <a:endParaRPr lang="nl-NL" sz="1800" dirty="0"/>
+          </a:p>
+          <a:p>
+            <a:pPr>
+              <a:buFontTx/>
+              <a:buChar char="-"/>
+            </a:pPr>
+            <a:r>
+              <a:rPr lang="nl-NL" sz="1800" dirty="0"/>
+              <a:t>Distributie code niet eenduidig.</a:t>
+            </a:r>
+          </a:p>
+        </p:txBody>
+      </p:sp>
+      <p:sp>
+        <p:nvSpPr>
+          <p:cNvPr id="4" name="Content Placeholder 2">
+            <a:extLst>
+              <a:ext uri="{FF2B5EF4-FFF2-40B4-BE49-F238E27FC236}">
+                <a16:creationId xmlns:a16="http://schemas.microsoft.com/office/drawing/2014/main" id="{2210A4AD-7C19-5184-ECB4-77EDD34F6402}"/>
+              </a:ext>
+            </a:extLst>
+          </p:cNvPr>
+          <p:cNvSpPr txBox="1">
+            <a:spLocks/>
+          </p:cNvSpPr>
+          <p:nvPr/>
+        </p:nvSpPr>
+        <p:spPr>
+          <a:xfrm>
+            <a:off x="6409267" y="1456267"/>
+            <a:ext cx="4749800" cy="4720696"/>
+          </a:xfrm>
+          <a:prstGeom prst="rect">
+            <a:avLst/>
+          </a:prstGeom>
+        </p:spPr>
+        <p:txBody>
+          <a:bodyPr vert="horz" lIns="91440" tIns="45720" rIns="91440" bIns="45720" rtlCol="0">
+            <a:normAutofit/>
+          </a:bodyPr>
+          <a:lstStyle>
+            <a:lvl1pPr marL="228600" indent="-228600" algn="l" defTabSz="914400" rtl="0" eaLnBrk="1" latinLnBrk="0" hangingPunct="1">
+              <a:lnSpc>
+                <a:spcPct val="90000"/>
+              </a:lnSpc>
+              <a:spcBef>
+                <a:spcPts val="1000"/>
+              </a:spcBef>
+              <a:buFont typeface="Arial" panose="020B0604020202020204" pitchFamily="34" charset="0"/>
+              <a:buChar char="•"/>
+              <a:defRPr sz="2800" kern="1200">
+                <a:solidFill>
+                  <a:schemeClr val="tx1"/>
+                </a:solidFill>
+                <a:latin typeface="+mn-lt"/>
+                <a:ea typeface="+mn-ea"/>
+                <a:cs typeface="+mn-cs"/>
+              </a:defRPr>
+            </a:lvl1pPr>
+            <a:lvl2pPr marL="685800" indent="-228600" algn="l" defTabSz="914400" rtl="0" eaLnBrk="1" latinLnBrk="0" hangingPunct="1">
+              <a:lnSpc>
+                <a:spcPct val="90000"/>
+              </a:lnSpc>
+              <a:spcBef>
+                <a:spcPts val="500"/>
+              </a:spcBef>
+              <a:buFont typeface="Arial" panose="020B0604020202020204" pitchFamily="34" charset="0"/>
+              <a:buChar char="•"/>
+              <a:defRPr sz="2400" kern="1200">
+                <a:solidFill>
+                  <a:schemeClr val="tx1"/>
+                </a:solidFill>
+                <a:latin typeface="+mn-lt"/>
+                <a:ea typeface="+mn-ea"/>
+                <a:cs typeface="+mn-cs"/>
+              </a:defRPr>
+            </a:lvl2pPr>
+            <a:lvl3pPr marL="1143000" indent="-228600" algn="l" defTabSz="914400" rtl="0" eaLnBrk="1" latinLnBrk="0" hangingPunct="1">
+              <a:lnSpc>
+                <a:spcPct val="90000"/>
+              </a:lnSpc>
+              <a:spcBef>
+                <a:spcPts val="500"/>
+              </a:spcBef>
+              <a:buFont typeface="Arial" panose="020B0604020202020204" pitchFamily="34" charset="0"/>
+              <a:buChar char="•"/>
+              <a:defRPr sz="2000" kern="1200">
+                <a:solidFill>
+                  <a:schemeClr val="tx1"/>
+                </a:solidFill>
+                <a:latin typeface="+mn-lt"/>
+                <a:ea typeface="+mn-ea"/>
+                <a:cs typeface="+mn-cs"/>
+              </a:defRPr>
+            </a:lvl3pPr>
+            <a:lvl4pPr marL="1600200" indent="-228600" algn="l" defTabSz="914400" rtl="0" eaLnBrk="1" latinLnBrk="0" hangingPunct="1">
+              <a:lnSpc>
+                <a:spcPct val="90000"/>
+              </a:lnSpc>
+              <a:spcBef>
+                <a:spcPts val="500"/>
+              </a:spcBef>
+              <a:buFont typeface="Arial" panose="020B0604020202020204" pitchFamily="34" charset="0"/>
+              <a:buChar char="•"/>
+              <a:defRPr sz="1800" kern="1200">
+                <a:solidFill>
+                  <a:schemeClr val="tx1"/>
+                </a:solidFill>
+                <a:latin typeface="+mn-lt"/>
+                <a:ea typeface="+mn-ea"/>
+                <a:cs typeface="+mn-cs"/>
+              </a:defRPr>
+            </a:lvl4pPr>
+            <a:lvl5pPr marL="2057400" indent="-228600" algn="l" defTabSz="914400" rtl="0" eaLnBrk="1" latinLnBrk="0" hangingPunct="1">
+              <a:lnSpc>
+                <a:spcPct val="90000"/>
+              </a:lnSpc>
+              <a:spcBef>
+                <a:spcPts val="500"/>
+              </a:spcBef>
+              <a:buFont typeface="Arial" panose="020B0604020202020204" pitchFamily="34" charset="0"/>
+              <a:buChar char="•"/>
+              <a:defRPr sz="1800" kern="1200">
+                <a:solidFill>
+                  <a:schemeClr val="tx1"/>
+                </a:solidFill>
+                <a:latin typeface="+mn-lt"/>
+                <a:ea typeface="+mn-ea"/>
+                <a:cs typeface="+mn-cs"/>
+              </a:defRPr>
+            </a:lvl5pPr>
+            <a:lvl6pPr marL="2514600" indent="-228600" algn="l" defTabSz="914400" rtl="0" eaLnBrk="1" latinLnBrk="0" hangingPunct="1">
+              <a:lnSpc>
+                <a:spcPct val="90000"/>
+              </a:lnSpc>
+              <a:spcBef>
+                <a:spcPts val="500"/>
+              </a:spcBef>
+              <a:buFont typeface="Arial" panose="020B0604020202020204" pitchFamily="34" charset="0"/>
+              <a:buChar char="•"/>
+              <a:defRPr sz="1800" kern="1200">
+                <a:solidFill>
+                  <a:schemeClr val="tx1"/>
+                </a:solidFill>
+                <a:latin typeface="+mn-lt"/>
+                <a:ea typeface="+mn-ea"/>
+                <a:cs typeface="+mn-cs"/>
+              </a:defRPr>
+            </a:lvl6pPr>
+            <a:lvl7pPr marL="2971800" indent="-228600" algn="l" defTabSz="914400" rtl="0" eaLnBrk="1" latinLnBrk="0" hangingPunct="1">
+              <a:lnSpc>
+                <a:spcPct val="90000"/>
+              </a:lnSpc>
+              <a:spcBef>
+                <a:spcPts val="500"/>
+              </a:spcBef>
+              <a:buFont typeface="Arial" panose="020B0604020202020204" pitchFamily="34" charset="0"/>
+              <a:buChar char="•"/>
+              <a:defRPr sz="1800" kern="1200">
+                <a:solidFill>
+                  <a:schemeClr val="tx1"/>
+                </a:solidFill>
+                <a:latin typeface="+mn-lt"/>
+                <a:ea typeface="+mn-ea"/>
+                <a:cs typeface="+mn-cs"/>
+              </a:defRPr>
+            </a:lvl7pPr>
+            <a:lvl8pPr marL="3429000" indent="-228600" algn="l" defTabSz="914400" rtl="0" eaLnBrk="1" latinLnBrk="0" hangingPunct="1">
+              <a:lnSpc>
+                <a:spcPct val="90000"/>
+              </a:lnSpc>
+              <a:spcBef>
+                <a:spcPts val="500"/>
+              </a:spcBef>
+              <a:buFont typeface="Arial" panose="020B0604020202020204" pitchFamily="34" charset="0"/>
+              <a:buChar char="•"/>
+              <a:defRPr sz="1800" kern="1200">
+                <a:solidFill>
+                  <a:schemeClr val="tx1"/>
+                </a:solidFill>
+                <a:latin typeface="+mn-lt"/>
+                <a:ea typeface="+mn-ea"/>
+                <a:cs typeface="+mn-cs"/>
+              </a:defRPr>
+            </a:lvl8pPr>
+            <a:lvl9pPr marL="3886200" indent="-228600" algn="l" defTabSz="914400" rtl="0" eaLnBrk="1" latinLnBrk="0" hangingPunct="1">
+              <a:lnSpc>
+                <a:spcPct val="90000"/>
+              </a:lnSpc>
+              <a:spcBef>
+                <a:spcPts val="500"/>
+              </a:spcBef>
+              <a:buFont typeface="Arial" panose="020B0604020202020204" pitchFamily="34" charset="0"/>
+              <a:buChar char="•"/>
+              <a:defRPr sz="1800" kern="1200">
+                <a:solidFill>
+                  <a:schemeClr val="tx1"/>
+                </a:solidFill>
+                <a:latin typeface="+mn-lt"/>
+                <a:ea typeface="+mn-ea"/>
+                <a:cs typeface="+mn-cs"/>
+              </a:defRPr>
+            </a:lvl9pPr>
+          </a:lstStyle>
+          <a:p>
+            <a:pPr marL="0" indent="0">
+              <a:buNone/>
+            </a:pPr>
+            <a:endParaRPr lang="nl-NL" sz="2000" dirty="0"/>
+          </a:p>
+        </p:txBody>
+      </p:sp>
+      <p:sp>
+        <p:nvSpPr>
+          <p:cNvPr id="5" name="Content Placeholder 2">
+            <a:extLst>
+              <a:ext uri="{FF2B5EF4-FFF2-40B4-BE49-F238E27FC236}">
+                <a16:creationId xmlns:a16="http://schemas.microsoft.com/office/drawing/2014/main" id="{FE4D819A-A65A-B849-482E-28A9AA671928}"/>
+              </a:ext>
+            </a:extLst>
+          </p:cNvPr>
+          <p:cNvSpPr txBox="1">
+            <a:spLocks/>
+          </p:cNvSpPr>
+          <p:nvPr/>
+        </p:nvSpPr>
+        <p:spPr>
+          <a:xfrm>
+            <a:off x="6604000" y="1456267"/>
+            <a:ext cx="4749800" cy="4720696"/>
+          </a:xfrm>
+          <a:prstGeom prst="rect">
+            <a:avLst/>
+          </a:prstGeom>
+        </p:spPr>
+        <p:txBody>
+          <a:bodyPr vert="horz" lIns="91440" tIns="45720" rIns="91440" bIns="45720" rtlCol="0">
+            <a:normAutofit/>
+          </a:bodyPr>
+          <a:lstStyle>
+            <a:lvl1pPr marL="228600" indent="-228600" algn="l" defTabSz="914400" rtl="0" eaLnBrk="1" latinLnBrk="0" hangingPunct="1">
+              <a:lnSpc>
+                <a:spcPct val="90000"/>
+              </a:lnSpc>
+              <a:spcBef>
+                <a:spcPts val="1000"/>
+              </a:spcBef>
+              <a:buFont typeface="Arial" panose="020B0604020202020204" pitchFamily="34" charset="0"/>
+              <a:buChar char="•"/>
+              <a:defRPr sz="2800" kern="1200">
+                <a:solidFill>
+                  <a:schemeClr val="tx1"/>
+                </a:solidFill>
+                <a:latin typeface="+mn-lt"/>
+                <a:ea typeface="+mn-ea"/>
+                <a:cs typeface="+mn-cs"/>
+              </a:defRPr>
+            </a:lvl1pPr>
+            <a:lvl2pPr marL="685800" indent="-228600" algn="l" defTabSz="914400" rtl="0" eaLnBrk="1" latinLnBrk="0" hangingPunct="1">
+              <a:lnSpc>
+                <a:spcPct val="90000"/>
+              </a:lnSpc>
+              <a:spcBef>
+                <a:spcPts val="500"/>
+              </a:spcBef>
+              <a:buFont typeface="Arial" panose="020B0604020202020204" pitchFamily="34" charset="0"/>
+              <a:buChar char="•"/>
+              <a:defRPr sz="2400" kern="1200">
+                <a:solidFill>
+                  <a:schemeClr val="tx1"/>
+                </a:solidFill>
+                <a:latin typeface="+mn-lt"/>
+                <a:ea typeface="+mn-ea"/>
+                <a:cs typeface="+mn-cs"/>
+              </a:defRPr>
+            </a:lvl2pPr>
+            <a:lvl3pPr marL="1143000" indent="-228600" algn="l" defTabSz="914400" rtl="0" eaLnBrk="1" latinLnBrk="0" hangingPunct="1">
+              <a:lnSpc>
+                <a:spcPct val="90000"/>
+              </a:lnSpc>
+              <a:spcBef>
+                <a:spcPts val="500"/>
+              </a:spcBef>
+              <a:buFont typeface="Arial" panose="020B0604020202020204" pitchFamily="34" charset="0"/>
+              <a:buChar char="•"/>
+              <a:defRPr sz="2000" kern="1200">
+                <a:solidFill>
+                  <a:schemeClr val="tx1"/>
+                </a:solidFill>
+                <a:latin typeface="+mn-lt"/>
+                <a:ea typeface="+mn-ea"/>
+                <a:cs typeface="+mn-cs"/>
+              </a:defRPr>
+            </a:lvl3pPr>
+            <a:lvl4pPr marL="1600200" indent="-228600" algn="l" defTabSz="914400" rtl="0" eaLnBrk="1" latinLnBrk="0" hangingPunct="1">
+              <a:lnSpc>
+                <a:spcPct val="90000"/>
+              </a:lnSpc>
+              <a:spcBef>
+                <a:spcPts val="500"/>
+              </a:spcBef>
+              <a:buFont typeface="Arial" panose="020B0604020202020204" pitchFamily="34" charset="0"/>
+              <a:buChar char="•"/>
+              <a:defRPr sz="1800" kern="1200">
+                <a:solidFill>
+                  <a:schemeClr val="tx1"/>
+                </a:solidFill>
+                <a:latin typeface="+mn-lt"/>
+                <a:ea typeface="+mn-ea"/>
+                <a:cs typeface="+mn-cs"/>
+              </a:defRPr>
+            </a:lvl4pPr>
+            <a:lvl5pPr marL="2057400" indent="-228600" algn="l" defTabSz="914400" rtl="0" eaLnBrk="1" latinLnBrk="0" hangingPunct="1">
+              <a:lnSpc>
+                <a:spcPct val="90000"/>
+              </a:lnSpc>
+              <a:spcBef>
+                <a:spcPts val="500"/>
+              </a:spcBef>
+              <a:buFont typeface="Arial" panose="020B0604020202020204" pitchFamily="34" charset="0"/>
+              <a:buChar char="•"/>
+              <a:defRPr sz="1800" kern="1200">
+                <a:solidFill>
+                  <a:schemeClr val="tx1"/>
+                </a:solidFill>
+                <a:latin typeface="+mn-lt"/>
+                <a:ea typeface="+mn-ea"/>
+                <a:cs typeface="+mn-cs"/>
+              </a:defRPr>
+            </a:lvl5pPr>
+            <a:lvl6pPr marL="2514600" indent="-228600" algn="l" defTabSz="914400" rtl="0" eaLnBrk="1" latinLnBrk="0" hangingPunct="1">
+              <a:lnSpc>
+                <a:spcPct val="90000"/>
+              </a:lnSpc>
+              <a:spcBef>
+                <a:spcPts val="500"/>
+              </a:spcBef>
+              <a:buFont typeface="Arial" panose="020B0604020202020204" pitchFamily="34" charset="0"/>
+              <a:buChar char="•"/>
+              <a:defRPr sz="1800" kern="1200">
+                <a:solidFill>
+                  <a:schemeClr val="tx1"/>
+                </a:solidFill>
+                <a:latin typeface="+mn-lt"/>
+                <a:ea typeface="+mn-ea"/>
+                <a:cs typeface="+mn-cs"/>
+              </a:defRPr>
+            </a:lvl6pPr>
+            <a:lvl7pPr marL="2971800" indent="-228600" algn="l" defTabSz="914400" rtl="0" eaLnBrk="1" latinLnBrk="0" hangingPunct="1">
+              <a:lnSpc>
+                <a:spcPct val="90000"/>
+              </a:lnSpc>
+              <a:spcBef>
+                <a:spcPts val="500"/>
+              </a:spcBef>
+              <a:buFont typeface="Arial" panose="020B0604020202020204" pitchFamily="34" charset="0"/>
+              <a:buChar char="•"/>
+              <a:defRPr sz="1800" kern="1200">
+                <a:solidFill>
+                  <a:schemeClr val="tx1"/>
+                </a:solidFill>
+                <a:latin typeface="+mn-lt"/>
+                <a:ea typeface="+mn-ea"/>
+                <a:cs typeface="+mn-cs"/>
+              </a:defRPr>
+            </a:lvl7pPr>
+            <a:lvl8pPr marL="3429000" indent="-228600" algn="l" defTabSz="914400" rtl="0" eaLnBrk="1" latinLnBrk="0" hangingPunct="1">
+              <a:lnSpc>
+                <a:spcPct val="90000"/>
+              </a:lnSpc>
+              <a:spcBef>
+                <a:spcPts val="500"/>
+              </a:spcBef>
+              <a:buFont typeface="Arial" panose="020B0604020202020204" pitchFamily="34" charset="0"/>
+              <a:buChar char="•"/>
+              <a:defRPr sz="1800" kern="1200">
+                <a:solidFill>
+                  <a:schemeClr val="tx1"/>
+                </a:solidFill>
+                <a:latin typeface="+mn-lt"/>
+                <a:ea typeface="+mn-ea"/>
+                <a:cs typeface="+mn-cs"/>
+              </a:defRPr>
+            </a:lvl8pPr>
+            <a:lvl9pPr marL="3886200" indent="-228600" algn="l" defTabSz="914400" rtl="0" eaLnBrk="1" latinLnBrk="0" hangingPunct="1">
+              <a:lnSpc>
+                <a:spcPct val="90000"/>
+              </a:lnSpc>
+              <a:spcBef>
+                <a:spcPts val="500"/>
+              </a:spcBef>
+              <a:buFont typeface="Arial" panose="020B0604020202020204" pitchFamily="34" charset="0"/>
+              <a:buChar char="•"/>
+              <a:defRPr sz="1800" kern="1200">
+                <a:solidFill>
+                  <a:schemeClr val="tx1"/>
+                </a:solidFill>
+                <a:latin typeface="+mn-lt"/>
+                <a:ea typeface="+mn-ea"/>
+                <a:cs typeface="+mn-cs"/>
+              </a:defRPr>
+            </a:lvl9pPr>
+          </a:lstStyle>
+          <a:p>
+            <a:pPr marL="0" indent="0">
+              <a:lnSpc>
+                <a:spcPct val="100000"/>
+              </a:lnSpc>
+              <a:spcBef>
+                <a:spcPts val="0"/>
+              </a:spcBef>
+              <a:buFont typeface="Arial" panose="020B0604020202020204" pitchFamily="34" charset="0"/>
+              <a:buNone/>
+            </a:pPr>
+            <a:r>
+              <a:rPr lang="nl-NL" sz="1600" dirty="0" err="1">
+                <a:latin typeface="Courier New" panose="02070309020205020404" pitchFamily="49" charset="0"/>
+                <a:cs typeface="Courier New" panose="02070309020205020404" pitchFamily="49" charset="0"/>
+              </a:rPr>
+              <a:t>qs</a:t>
+            </a:r>
+            <a:r>
+              <a:rPr lang="nl-NL" sz="1600" dirty="0">
+                <a:latin typeface="Courier New" panose="02070309020205020404" pitchFamily="49" charset="0"/>
+                <a:cs typeface="Courier New" panose="02070309020205020404" pitchFamily="49" charset="0"/>
+              </a:rPr>
+              <a:t> = [</a:t>
+            </a:r>
+          </a:p>
+          <a:p>
+            <a:pPr marL="0" indent="0">
+              <a:lnSpc>
+                <a:spcPct val="100000"/>
+              </a:lnSpc>
+              <a:spcBef>
+                <a:spcPts val="0"/>
+              </a:spcBef>
+              <a:buFont typeface="Arial" panose="020B0604020202020204" pitchFamily="34" charset="0"/>
+              <a:buNone/>
+            </a:pPr>
+            <a:r>
+              <a:rPr lang="nl-NL" sz="1600" dirty="0">
+                <a:latin typeface="Courier New" panose="02070309020205020404" pitchFamily="49" charset="0"/>
+                <a:cs typeface="Courier New" panose="02070309020205020404" pitchFamily="49" charset="0"/>
+              </a:rPr>
+              <a:t>    _ ** 2 </a:t>
+            </a:r>
+            <a:r>
+              <a:rPr lang="nl-NL" sz="1600" dirty="0" err="1">
+                <a:solidFill>
+                  <a:srgbClr val="7030A0"/>
+                </a:solidFill>
+                <a:latin typeface="Courier New" panose="02070309020205020404" pitchFamily="49" charset="0"/>
+                <a:cs typeface="Courier New" panose="02070309020205020404" pitchFamily="49" charset="0"/>
+              </a:rPr>
+              <a:t>for</a:t>
+            </a:r>
+            <a:r>
+              <a:rPr lang="nl-NL" sz="1600" dirty="0">
+                <a:latin typeface="Courier New" panose="02070309020205020404" pitchFamily="49" charset="0"/>
+                <a:cs typeface="Courier New" panose="02070309020205020404" pitchFamily="49" charset="0"/>
+              </a:rPr>
+              <a:t> _ </a:t>
+            </a:r>
+            <a:r>
+              <a:rPr lang="nl-NL" sz="1600" dirty="0">
+                <a:solidFill>
+                  <a:srgbClr val="7030A0"/>
+                </a:solidFill>
+                <a:latin typeface="Courier New" panose="02070309020205020404" pitchFamily="49" charset="0"/>
+                <a:cs typeface="Courier New" panose="02070309020205020404" pitchFamily="49" charset="0"/>
+              </a:rPr>
+              <a:t>in</a:t>
+            </a:r>
+            <a:r>
+              <a:rPr lang="nl-NL" sz="1600" dirty="0">
+                <a:latin typeface="Courier New" panose="02070309020205020404" pitchFamily="49" charset="0"/>
+                <a:cs typeface="Courier New" panose="02070309020205020404" pitchFamily="49" charset="0"/>
+              </a:rPr>
+              <a:t> </a:t>
+            </a:r>
+            <a:r>
+              <a:rPr lang="nl-NL" sz="1600" dirty="0" err="1">
+                <a:latin typeface="Courier New" panose="02070309020205020404" pitchFamily="49" charset="0"/>
+                <a:cs typeface="Courier New" panose="02070309020205020404" pitchFamily="49" charset="0"/>
+              </a:rPr>
+              <a:t>my_list</a:t>
+            </a:r>
+            <a:endParaRPr lang="nl-NL" sz="1600" dirty="0">
+              <a:latin typeface="Courier New" panose="02070309020205020404" pitchFamily="49" charset="0"/>
+              <a:cs typeface="Courier New" panose="02070309020205020404" pitchFamily="49" charset="0"/>
+            </a:endParaRPr>
+          </a:p>
+          <a:p>
+            <a:pPr marL="0" indent="0">
+              <a:lnSpc>
+                <a:spcPct val="100000"/>
+              </a:lnSpc>
+              <a:spcBef>
+                <a:spcPts val="0"/>
+              </a:spcBef>
+              <a:buFont typeface="Arial" panose="020B0604020202020204" pitchFamily="34" charset="0"/>
+              <a:buNone/>
+            </a:pPr>
+            <a:r>
+              <a:rPr lang="nl-NL" sz="1600" dirty="0">
+                <a:latin typeface="Courier New" panose="02070309020205020404" pitchFamily="49" charset="0"/>
+                <a:cs typeface="Courier New" panose="02070309020205020404" pitchFamily="49" charset="0"/>
+              </a:rPr>
+              <a:t>    </a:t>
+            </a:r>
+            <a:r>
+              <a:rPr lang="nl-NL" sz="1600" dirty="0" err="1">
+                <a:solidFill>
+                  <a:srgbClr val="7030A0"/>
+                </a:solidFill>
+                <a:latin typeface="Courier New" panose="02070309020205020404" pitchFamily="49" charset="0"/>
+                <a:cs typeface="Courier New" panose="02070309020205020404" pitchFamily="49" charset="0"/>
+              </a:rPr>
+              <a:t>if</a:t>
+            </a:r>
+            <a:r>
+              <a:rPr lang="nl-NL" sz="1600" dirty="0">
+                <a:latin typeface="Courier New" panose="02070309020205020404" pitchFamily="49" charset="0"/>
+                <a:cs typeface="Courier New" panose="02070309020205020404" pitchFamily="49" charset="0"/>
+              </a:rPr>
+              <a:t> (</a:t>
+            </a:r>
+          </a:p>
+          <a:p>
+            <a:pPr marL="0" indent="0">
+              <a:lnSpc>
+                <a:spcPct val="100000"/>
+              </a:lnSpc>
+              <a:spcBef>
+                <a:spcPts val="0"/>
+              </a:spcBef>
+              <a:buFont typeface="Arial" panose="020B0604020202020204" pitchFamily="34" charset="0"/>
+              <a:buNone/>
+            </a:pPr>
+            <a:r>
+              <a:rPr lang="nl-NL" sz="1600" dirty="0">
+                <a:latin typeface="Courier New" panose="02070309020205020404" pitchFamily="49" charset="0"/>
+                <a:cs typeface="Courier New" panose="02070309020205020404" pitchFamily="49" charset="0"/>
+              </a:rPr>
+              <a:t>        type(_) </a:t>
+            </a:r>
+            <a:r>
+              <a:rPr lang="nl-NL" sz="1600" dirty="0">
+                <a:solidFill>
+                  <a:srgbClr val="7030A0"/>
+                </a:solidFill>
+                <a:latin typeface="Courier New" panose="02070309020205020404" pitchFamily="49" charset="0"/>
+                <a:cs typeface="Courier New" panose="02070309020205020404" pitchFamily="49" charset="0"/>
+              </a:rPr>
+              <a:t>in</a:t>
+            </a:r>
+            <a:r>
+              <a:rPr lang="nl-NL" sz="1600" dirty="0">
+                <a:latin typeface="Courier New" panose="02070309020205020404" pitchFamily="49" charset="0"/>
+                <a:cs typeface="Courier New" panose="02070309020205020404" pitchFamily="49" charset="0"/>
+              </a:rPr>
+              <a:t> (</a:t>
+            </a:r>
+            <a:r>
+              <a:rPr lang="nl-NL" sz="1600" dirty="0" err="1">
+                <a:solidFill>
+                  <a:schemeClr val="accent5">
+                    <a:lumMod val="75000"/>
+                  </a:schemeClr>
+                </a:solidFill>
+                <a:latin typeface="Courier New" panose="02070309020205020404" pitchFamily="49" charset="0"/>
+                <a:cs typeface="Courier New" panose="02070309020205020404" pitchFamily="49" charset="0"/>
+              </a:rPr>
+              <a:t>float</a:t>
+            </a:r>
+            <a:r>
+              <a:rPr lang="nl-NL" sz="1600" dirty="0">
+                <a:latin typeface="Courier New" panose="02070309020205020404" pitchFamily="49" charset="0"/>
+                <a:cs typeface="Courier New" panose="02070309020205020404" pitchFamily="49" charset="0"/>
+              </a:rPr>
+              <a:t>, </a:t>
+            </a:r>
+            <a:r>
+              <a:rPr lang="nl-NL" sz="1600" dirty="0">
+                <a:solidFill>
+                  <a:schemeClr val="accent5">
+                    <a:lumMod val="75000"/>
+                  </a:schemeClr>
+                </a:solidFill>
+                <a:latin typeface="Courier New" panose="02070309020205020404" pitchFamily="49" charset="0"/>
+                <a:cs typeface="Courier New" panose="02070309020205020404" pitchFamily="49" charset="0"/>
+              </a:rPr>
+              <a:t>int</a:t>
+            </a:r>
+            <a:r>
+              <a:rPr lang="nl-NL" sz="1600" dirty="0">
+                <a:latin typeface="Courier New" panose="02070309020205020404" pitchFamily="49" charset="0"/>
+                <a:cs typeface="Courier New" panose="02070309020205020404" pitchFamily="49" charset="0"/>
+              </a:rPr>
+              <a:t>)</a:t>
+            </a:r>
+          </a:p>
+          <a:p>
+            <a:pPr marL="0" indent="0">
+              <a:lnSpc>
+                <a:spcPct val="100000"/>
+              </a:lnSpc>
+              <a:spcBef>
+                <a:spcPts val="0"/>
+              </a:spcBef>
+              <a:buFont typeface="Arial" panose="020B0604020202020204" pitchFamily="34" charset="0"/>
+              <a:buNone/>
+            </a:pPr>
+            <a:r>
+              <a:rPr lang="nl-NL" sz="1600" dirty="0">
+                <a:latin typeface="Courier New" panose="02070309020205020404" pitchFamily="49" charset="0"/>
+                <a:cs typeface="Courier New" panose="02070309020205020404" pitchFamily="49" charset="0"/>
+              </a:rPr>
+              <a:t>        </a:t>
+            </a:r>
+            <a:r>
+              <a:rPr lang="nl-NL" sz="1600" dirty="0" err="1">
+                <a:solidFill>
+                  <a:srgbClr val="7030A0"/>
+                </a:solidFill>
+                <a:latin typeface="Courier New" panose="02070309020205020404" pitchFamily="49" charset="0"/>
+                <a:cs typeface="Courier New" panose="02070309020205020404" pitchFamily="49" charset="0"/>
+              </a:rPr>
+              <a:t>and</a:t>
+            </a:r>
+            <a:r>
+              <a:rPr lang="nl-NL" sz="1600" dirty="0">
+                <a:latin typeface="Courier New" panose="02070309020205020404" pitchFamily="49" charset="0"/>
+                <a:cs typeface="Courier New" panose="02070309020205020404" pitchFamily="49" charset="0"/>
+              </a:rPr>
+              <a:t> _ </a:t>
+            </a:r>
+            <a:r>
+              <a:rPr lang="nl-NL" sz="1600" dirty="0">
+                <a:solidFill>
+                  <a:srgbClr val="7030A0"/>
+                </a:solidFill>
+                <a:latin typeface="Courier New" panose="02070309020205020404" pitchFamily="49" charset="0"/>
+                <a:cs typeface="Courier New" panose="02070309020205020404" pitchFamily="49" charset="0"/>
+              </a:rPr>
+              <a:t>is </a:t>
+            </a:r>
+            <a:r>
+              <a:rPr lang="nl-NL" sz="1600" dirty="0" err="1">
+                <a:solidFill>
+                  <a:srgbClr val="7030A0"/>
+                </a:solidFill>
+                <a:latin typeface="Courier New" panose="02070309020205020404" pitchFamily="49" charset="0"/>
+                <a:cs typeface="Courier New" panose="02070309020205020404" pitchFamily="49" charset="0"/>
+              </a:rPr>
+              <a:t>not</a:t>
+            </a:r>
+            <a:r>
+              <a:rPr lang="nl-NL" sz="1600" dirty="0">
+                <a:latin typeface="Courier New" panose="02070309020205020404" pitchFamily="49" charset="0"/>
+                <a:cs typeface="Courier New" panose="02070309020205020404" pitchFamily="49" charset="0"/>
+              </a:rPr>
+              <a:t> </a:t>
+            </a:r>
+            <a:r>
+              <a:rPr lang="nl-NL" sz="1600" dirty="0">
+                <a:solidFill>
+                  <a:schemeClr val="accent5">
+                    <a:lumMod val="75000"/>
+                  </a:schemeClr>
+                </a:solidFill>
+                <a:latin typeface="Courier New" panose="02070309020205020404" pitchFamily="49" charset="0"/>
+                <a:cs typeface="Courier New" panose="02070309020205020404" pitchFamily="49" charset="0"/>
+              </a:rPr>
+              <a:t>None</a:t>
+            </a:r>
+          </a:p>
+          <a:p>
+            <a:pPr marL="0" indent="0">
+              <a:lnSpc>
+                <a:spcPct val="100000"/>
+              </a:lnSpc>
+              <a:spcBef>
+                <a:spcPts val="0"/>
+              </a:spcBef>
+              <a:buFont typeface="Arial" panose="020B0604020202020204" pitchFamily="34" charset="0"/>
+              <a:buNone/>
+            </a:pPr>
+            <a:r>
+              <a:rPr lang="nl-NL" sz="1600" dirty="0">
+                <a:latin typeface="Courier New" panose="02070309020205020404" pitchFamily="49" charset="0"/>
+                <a:cs typeface="Courier New" panose="02070309020205020404" pitchFamily="49" charset="0"/>
+              </a:rPr>
+              <a:t>        </a:t>
+            </a:r>
+            <a:r>
+              <a:rPr lang="nl-NL" sz="1600" dirty="0" err="1">
+                <a:solidFill>
+                  <a:srgbClr val="7030A0"/>
+                </a:solidFill>
+                <a:latin typeface="Courier New" panose="02070309020205020404" pitchFamily="49" charset="0"/>
+                <a:cs typeface="Courier New" panose="02070309020205020404" pitchFamily="49" charset="0"/>
+              </a:rPr>
+              <a:t>and</a:t>
+            </a:r>
+            <a:r>
+              <a:rPr lang="nl-NL" sz="1600" dirty="0">
+                <a:latin typeface="Courier New" panose="02070309020205020404" pitchFamily="49" charset="0"/>
+                <a:cs typeface="Courier New" panose="02070309020205020404" pitchFamily="49" charset="0"/>
+              </a:rPr>
+              <a:t> _ &gt;= 0</a:t>
+            </a:r>
+          </a:p>
+          <a:p>
+            <a:pPr marL="0" indent="0">
+              <a:lnSpc>
+                <a:spcPct val="100000"/>
+              </a:lnSpc>
+              <a:spcBef>
+                <a:spcPts val="0"/>
+              </a:spcBef>
+              <a:buFont typeface="Arial" panose="020B0604020202020204" pitchFamily="34" charset="0"/>
+              <a:buNone/>
+            </a:pPr>
+            <a:r>
+              <a:rPr lang="nl-NL" sz="1600" dirty="0">
+                <a:latin typeface="Courier New" panose="02070309020205020404" pitchFamily="49" charset="0"/>
+                <a:cs typeface="Courier New" panose="02070309020205020404" pitchFamily="49" charset="0"/>
+              </a:rPr>
+              <a:t>    )</a:t>
+            </a:r>
+          </a:p>
+          <a:p>
+            <a:pPr marL="0" indent="0">
+              <a:lnSpc>
+                <a:spcPct val="100000"/>
+              </a:lnSpc>
+              <a:spcBef>
+                <a:spcPts val="0"/>
+              </a:spcBef>
+              <a:buFont typeface="Arial" panose="020B0604020202020204" pitchFamily="34" charset="0"/>
+              <a:buNone/>
+            </a:pPr>
+            <a:r>
+              <a:rPr lang="nl-NL" sz="1600" dirty="0">
+                <a:latin typeface="Courier New" panose="02070309020205020404" pitchFamily="49" charset="0"/>
+                <a:cs typeface="Courier New" panose="02070309020205020404" pitchFamily="49" charset="0"/>
+              </a:rPr>
+              <a:t>]</a:t>
+            </a:r>
+          </a:p>
+        </p:txBody>
+      </p:sp>
+      <p:cxnSp>
+        <p:nvCxnSpPr>
+          <p:cNvPr id="6" name="Straight Connector 5">
+            <a:extLst>
+              <a:ext uri="{FF2B5EF4-FFF2-40B4-BE49-F238E27FC236}">
+                <a16:creationId xmlns:a16="http://schemas.microsoft.com/office/drawing/2014/main" id="{4E630EC8-816A-E473-7194-8B2BB5384102}"/>
+              </a:ext>
+            </a:extLst>
+          </p:cNvPr>
+          <p:cNvCxnSpPr>
+            <a:cxnSpLocks/>
+          </p:cNvCxnSpPr>
+          <p:nvPr/>
+        </p:nvCxnSpPr>
+        <p:spPr>
+          <a:xfrm>
+            <a:off x="5960533" y="1388533"/>
+            <a:ext cx="0" cy="4788430"/>
+          </a:xfrm>
+          <a:prstGeom prst="line">
+            <a:avLst/>
+          </a:prstGeom>
+        </p:spPr>
+        <p:style>
+          <a:lnRef idx="3">
+            <a:schemeClr val="dk1"/>
+          </a:lnRef>
+          <a:fillRef idx="0">
+            <a:schemeClr val="dk1"/>
+          </a:fillRef>
+          <a:effectRef idx="2">
+            <a:schemeClr val="dk1"/>
+          </a:effectRef>
+          <a:fontRef idx="minor">
+            <a:schemeClr val="tx1"/>
+          </a:fontRef>
+        </p:style>
+      </p:cxnSp>
+    </p:spTree>
+    <p:extLst>
+      <p:ext uri="{BB962C8B-B14F-4D97-AF65-F5344CB8AC3E}">
+        <p14:creationId xmlns:p14="http://schemas.microsoft.com/office/powerpoint/2010/main" val="2370871397"/>
+      </p:ext>
+    </p:extLst>
+  </p:cSld>
+  <p:clrMapOvr>
+    <a:masterClrMapping/>
+  </p:clrMapOvr>
+</p:sld>
+</file>
+
+<file path=ppt/slides/slide50.xml><?xml version="1.0" encoding="utf-8"?>
 <p:sld xmlns:a="http://schemas.openxmlformats.org/drawingml/2006/main" xmlns:r="http://schemas.openxmlformats.org/officeDocument/2006/relationships" xmlns:p="http://schemas.openxmlformats.org/presentationml/2006/main">
   <p:cSld>
     <p:spTree>
@@ -27861,7 +29795,7 @@
 </p:sld>
 </file>
 
-<file path=ppt/slides/slide49.xml><?xml version="1.0" encoding="utf-8"?>
+<file path=ppt/slides/slide51.xml><?xml version="1.0" encoding="utf-8"?>
 <p:sld xmlns:a="http://schemas.openxmlformats.org/drawingml/2006/main" xmlns:r="http://schemas.openxmlformats.org/officeDocument/2006/relationships" xmlns:p="http://schemas.openxmlformats.org/presentationml/2006/main">
   <p:cSld>
     <p:spTree>
@@ -28031,37 +29965,6 @@
               <a:rPr lang="nl-NL" sz="2000" dirty="0"/>
               <a:t> bestand; wat zit hierin?</a:t>
             </a:r>
-          </a:p>
-          <a:p>
-            <a:pPr marL="457200" indent="-457200">
-              <a:buAutoNum type="arabicPeriod"/>
-            </a:pPr>
-            <a:endParaRPr lang="nl-NL" sz="2000" dirty="0"/>
-          </a:p>
-          <a:p>
-            <a:pPr marL="457200" indent="-457200">
-              <a:buAutoNum type="arabicPeriod"/>
-            </a:pPr>
-            <a:r>
-              <a:rPr lang="nl-NL" sz="2000" noProof="0" dirty="0"/>
-              <a:t>Kun je </a:t>
-            </a:r>
-            <a:r>
-              <a:rPr lang="nl-NL" sz="2000" noProof="0" dirty="0" err="1">
-                <a:latin typeface="Courier New" panose="02070309020205020404" pitchFamily="49" charset="0"/>
-                <a:cs typeface="Courier New" panose="02070309020205020404" pitchFamily="49" charset="0"/>
-              </a:rPr>
-              <a:t>pandas</a:t>
-            </a:r>
-            <a:r>
-              <a:rPr lang="nl-NL" sz="2000" noProof="0" dirty="0"/>
-              <a:t> installeren via git?</a:t>
-            </a:r>
-          </a:p>
-          <a:p>
-            <a:pPr marL="0" indent="0">
-              <a:buNone/>
-            </a:pPr>
             <a:endParaRPr lang="nl-NL" sz="2000" noProof="0" dirty="0"/>
           </a:p>
           <a:p>
@@ -28091,930 +29994,7 @@
 </p:sld>
 </file>
 
-<file path=ppt/slides/slide5.xml><?xml version="1.0" encoding="utf-8"?>
-<p:sld xmlns:a="http://schemas.openxmlformats.org/drawingml/2006/main" xmlns:r="http://schemas.openxmlformats.org/officeDocument/2006/relationships" xmlns:p="http://schemas.openxmlformats.org/presentationml/2006/main">
-  <p:cSld>
-    <p:spTree>
-      <p:nvGrpSpPr>
-        <p:cNvPr id="1" name="">
-          <a:extLst>
-            <a:ext uri="{FF2B5EF4-FFF2-40B4-BE49-F238E27FC236}">
-              <a16:creationId xmlns:a16="http://schemas.microsoft.com/office/drawing/2014/main" id="{F4B537BD-A938-DAF3-FEF2-1B5E3A6E1778}"/>
-            </a:ext>
-          </a:extLst>
-        </p:cNvPr>
-        <p:cNvGrpSpPr/>
-        <p:nvPr/>
-      </p:nvGrpSpPr>
-      <p:grpSpPr>
-        <a:xfrm>
-          <a:off x="0" y="0"/>
-          <a:ext cx="0" cy="0"/>
-          <a:chOff x="0" y="0"/>
-          <a:chExt cx="0" cy="0"/>
-        </a:xfrm>
-      </p:grpSpPr>
-      <p:sp>
-        <p:nvSpPr>
-          <p:cNvPr id="2" name="Title 1">
-            <a:extLst>
-              <a:ext uri="{FF2B5EF4-FFF2-40B4-BE49-F238E27FC236}">
-                <a16:creationId xmlns:a16="http://schemas.microsoft.com/office/drawing/2014/main" id="{9934E2EF-C0A7-A70B-04F1-1E24BD18D62D}"/>
-              </a:ext>
-            </a:extLst>
-          </p:cNvPr>
-          <p:cNvSpPr>
-            <a:spLocks noGrp="1"/>
-          </p:cNvSpPr>
-          <p:nvPr>
-            <p:ph type="title"/>
-          </p:nvPr>
-        </p:nvSpPr>
-        <p:spPr>
-          <a:xfrm>
-            <a:off x="838200" y="365126"/>
-            <a:ext cx="10515600" cy="718608"/>
-          </a:xfrm>
-        </p:spPr>
-        <p:txBody>
-          <a:bodyPr>
-            <a:normAutofit/>
-          </a:bodyPr>
-          <a:lstStyle/>
-          <a:p>
-            <a:r>
-              <a:rPr lang="nl-NL" sz="3600" noProof="0" dirty="0"/>
-              <a:t>Zwakke punten</a:t>
-            </a:r>
-          </a:p>
-        </p:txBody>
-      </p:sp>
-      <p:sp>
-        <p:nvSpPr>
-          <p:cNvPr id="3" name="Content Placeholder 2">
-            <a:extLst>
-              <a:ext uri="{FF2B5EF4-FFF2-40B4-BE49-F238E27FC236}">
-                <a16:creationId xmlns:a16="http://schemas.microsoft.com/office/drawing/2014/main" id="{AE69D57C-00B8-1248-107F-AA6E5F085DF9}"/>
-              </a:ext>
-            </a:extLst>
-          </p:cNvPr>
-          <p:cNvSpPr>
-            <a:spLocks noGrp="1"/>
-          </p:cNvSpPr>
-          <p:nvPr>
-            <p:ph idx="1"/>
-          </p:nvPr>
-        </p:nvSpPr>
-        <p:spPr>
-          <a:xfrm>
-            <a:off x="838200" y="1456267"/>
-            <a:ext cx="4749800" cy="4720696"/>
-          </a:xfrm>
-        </p:spPr>
-        <p:txBody>
-          <a:bodyPr>
-            <a:normAutofit/>
-          </a:bodyPr>
-          <a:lstStyle/>
-          <a:p>
-            <a:pPr>
-              <a:buFontTx/>
-              <a:buChar char="-"/>
-            </a:pPr>
-            <a:r>
-              <a:rPr lang="nl-NL" sz="1800" dirty="0"/>
-              <a:t>Makkelijk om “slechte” code te schrijven.</a:t>
-            </a:r>
-          </a:p>
-          <a:p>
-            <a:pPr>
-              <a:buFontTx/>
-              <a:buChar char="-"/>
-            </a:pPr>
-            <a:endParaRPr lang="nl-NL" sz="1800" dirty="0"/>
-          </a:p>
-          <a:p>
-            <a:pPr>
-              <a:buFontTx/>
-              <a:buChar char="-"/>
-            </a:pPr>
-            <a:r>
-              <a:rPr lang="nl-NL" sz="1800" dirty="0"/>
-              <a:t>Relatief traag  (vgl. C, C++, Scala, Rust).</a:t>
-            </a:r>
-          </a:p>
-          <a:p>
-            <a:pPr>
-              <a:buFontTx/>
-              <a:buChar char="-"/>
-            </a:pPr>
-            <a:endParaRPr lang="nl-NL" sz="1800" dirty="0"/>
-          </a:p>
-          <a:p>
-            <a:pPr>
-              <a:buFontTx/>
-              <a:buChar char="-"/>
-            </a:pPr>
-            <a:r>
-              <a:rPr lang="nl-NL" sz="1800" dirty="0"/>
-              <a:t>Distributie code niet eenduidig.</a:t>
-            </a:r>
-          </a:p>
-        </p:txBody>
-      </p:sp>
-      <p:sp>
-        <p:nvSpPr>
-          <p:cNvPr id="4" name="Content Placeholder 2">
-            <a:extLst>
-              <a:ext uri="{FF2B5EF4-FFF2-40B4-BE49-F238E27FC236}">
-                <a16:creationId xmlns:a16="http://schemas.microsoft.com/office/drawing/2014/main" id="{2210A4AD-7C19-5184-ECB4-77EDD34F6402}"/>
-              </a:ext>
-            </a:extLst>
-          </p:cNvPr>
-          <p:cNvSpPr txBox="1">
-            <a:spLocks/>
-          </p:cNvSpPr>
-          <p:nvPr/>
-        </p:nvSpPr>
-        <p:spPr>
-          <a:xfrm>
-            <a:off x="6409267" y="1456267"/>
-            <a:ext cx="4749800" cy="4720696"/>
-          </a:xfrm>
-          <a:prstGeom prst="rect">
-            <a:avLst/>
-          </a:prstGeom>
-        </p:spPr>
-        <p:txBody>
-          <a:bodyPr vert="horz" lIns="91440" tIns="45720" rIns="91440" bIns="45720" rtlCol="0">
-            <a:normAutofit/>
-          </a:bodyPr>
-          <a:lstStyle>
-            <a:lvl1pPr marL="228600" indent="-228600" algn="l" defTabSz="914400" rtl="0" eaLnBrk="1" latinLnBrk="0" hangingPunct="1">
-              <a:lnSpc>
-                <a:spcPct val="90000"/>
-              </a:lnSpc>
-              <a:spcBef>
-                <a:spcPts val="1000"/>
-              </a:spcBef>
-              <a:buFont typeface="Arial" panose="020B0604020202020204" pitchFamily="34" charset="0"/>
-              <a:buChar char="•"/>
-              <a:defRPr sz="2800" kern="1200">
-                <a:solidFill>
-                  <a:schemeClr val="tx1"/>
-                </a:solidFill>
-                <a:latin typeface="+mn-lt"/>
-                <a:ea typeface="+mn-ea"/>
-                <a:cs typeface="+mn-cs"/>
-              </a:defRPr>
-            </a:lvl1pPr>
-            <a:lvl2pPr marL="685800" indent="-228600" algn="l" defTabSz="914400" rtl="0" eaLnBrk="1" latinLnBrk="0" hangingPunct="1">
-              <a:lnSpc>
-                <a:spcPct val="90000"/>
-              </a:lnSpc>
-              <a:spcBef>
-                <a:spcPts val="500"/>
-              </a:spcBef>
-              <a:buFont typeface="Arial" panose="020B0604020202020204" pitchFamily="34" charset="0"/>
-              <a:buChar char="•"/>
-              <a:defRPr sz="2400" kern="1200">
-                <a:solidFill>
-                  <a:schemeClr val="tx1"/>
-                </a:solidFill>
-                <a:latin typeface="+mn-lt"/>
-                <a:ea typeface="+mn-ea"/>
-                <a:cs typeface="+mn-cs"/>
-              </a:defRPr>
-            </a:lvl2pPr>
-            <a:lvl3pPr marL="1143000" indent="-228600" algn="l" defTabSz="914400" rtl="0" eaLnBrk="1" latinLnBrk="0" hangingPunct="1">
-              <a:lnSpc>
-                <a:spcPct val="90000"/>
-              </a:lnSpc>
-              <a:spcBef>
-                <a:spcPts val="500"/>
-              </a:spcBef>
-              <a:buFont typeface="Arial" panose="020B0604020202020204" pitchFamily="34" charset="0"/>
-              <a:buChar char="•"/>
-              <a:defRPr sz="2000" kern="1200">
-                <a:solidFill>
-                  <a:schemeClr val="tx1"/>
-                </a:solidFill>
-                <a:latin typeface="+mn-lt"/>
-                <a:ea typeface="+mn-ea"/>
-                <a:cs typeface="+mn-cs"/>
-              </a:defRPr>
-            </a:lvl3pPr>
-            <a:lvl4pPr marL="1600200" indent="-228600" algn="l" defTabSz="914400" rtl="0" eaLnBrk="1" latinLnBrk="0" hangingPunct="1">
-              <a:lnSpc>
-                <a:spcPct val="90000"/>
-              </a:lnSpc>
-              <a:spcBef>
-                <a:spcPts val="500"/>
-              </a:spcBef>
-              <a:buFont typeface="Arial" panose="020B0604020202020204" pitchFamily="34" charset="0"/>
-              <a:buChar char="•"/>
-              <a:defRPr sz="1800" kern="1200">
-                <a:solidFill>
-                  <a:schemeClr val="tx1"/>
-                </a:solidFill>
-                <a:latin typeface="+mn-lt"/>
-                <a:ea typeface="+mn-ea"/>
-                <a:cs typeface="+mn-cs"/>
-              </a:defRPr>
-            </a:lvl4pPr>
-            <a:lvl5pPr marL="2057400" indent="-228600" algn="l" defTabSz="914400" rtl="0" eaLnBrk="1" latinLnBrk="0" hangingPunct="1">
-              <a:lnSpc>
-                <a:spcPct val="90000"/>
-              </a:lnSpc>
-              <a:spcBef>
-                <a:spcPts val="500"/>
-              </a:spcBef>
-              <a:buFont typeface="Arial" panose="020B0604020202020204" pitchFamily="34" charset="0"/>
-              <a:buChar char="•"/>
-              <a:defRPr sz="1800" kern="1200">
-                <a:solidFill>
-                  <a:schemeClr val="tx1"/>
-                </a:solidFill>
-                <a:latin typeface="+mn-lt"/>
-                <a:ea typeface="+mn-ea"/>
-                <a:cs typeface="+mn-cs"/>
-              </a:defRPr>
-            </a:lvl5pPr>
-            <a:lvl6pPr marL="2514600" indent="-228600" algn="l" defTabSz="914400" rtl="0" eaLnBrk="1" latinLnBrk="0" hangingPunct="1">
-              <a:lnSpc>
-                <a:spcPct val="90000"/>
-              </a:lnSpc>
-              <a:spcBef>
-                <a:spcPts val="500"/>
-              </a:spcBef>
-              <a:buFont typeface="Arial" panose="020B0604020202020204" pitchFamily="34" charset="0"/>
-              <a:buChar char="•"/>
-              <a:defRPr sz="1800" kern="1200">
-                <a:solidFill>
-                  <a:schemeClr val="tx1"/>
-                </a:solidFill>
-                <a:latin typeface="+mn-lt"/>
-                <a:ea typeface="+mn-ea"/>
-                <a:cs typeface="+mn-cs"/>
-              </a:defRPr>
-            </a:lvl6pPr>
-            <a:lvl7pPr marL="2971800" indent="-228600" algn="l" defTabSz="914400" rtl="0" eaLnBrk="1" latinLnBrk="0" hangingPunct="1">
-              <a:lnSpc>
-                <a:spcPct val="90000"/>
-              </a:lnSpc>
-              <a:spcBef>
-                <a:spcPts val="500"/>
-              </a:spcBef>
-              <a:buFont typeface="Arial" panose="020B0604020202020204" pitchFamily="34" charset="0"/>
-              <a:buChar char="•"/>
-              <a:defRPr sz="1800" kern="1200">
-                <a:solidFill>
-                  <a:schemeClr val="tx1"/>
-                </a:solidFill>
-                <a:latin typeface="+mn-lt"/>
-                <a:ea typeface="+mn-ea"/>
-                <a:cs typeface="+mn-cs"/>
-              </a:defRPr>
-            </a:lvl7pPr>
-            <a:lvl8pPr marL="3429000" indent="-228600" algn="l" defTabSz="914400" rtl="0" eaLnBrk="1" latinLnBrk="0" hangingPunct="1">
-              <a:lnSpc>
-                <a:spcPct val="90000"/>
-              </a:lnSpc>
-              <a:spcBef>
-                <a:spcPts val="500"/>
-              </a:spcBef>
-              <a:buFont typeface="Arial" panose="020B0604020202020204" pitchFamily="34" charset="0"/>
-              <a:buChar char="•"/>
-              <a:defRPr sz="1800" kern="1200">
-                <a:solidFill>
-                  <a:schemeClr val="tx1"/>
-                </a:solidFill>
-                <a:latin typeface="+mn-lt"/>
-                <a:ea typeface="+mn-ea"/>
-                <a:cs typeface="+mn-cs"/>
-              </a:defRPr>
-            </a:lvl8pPr>
-            <a:lvl9pPr marL="3886200" indent="-228600" algn="l" defTabSz="914400" rtl="0" eaLnBrk="1" latinLnBrk="0" hangingPunct="1">
-              <a:lnSpc>
-                <a:spcPct val="90000"/>
-              </a:lnSpc>
-              <a:spcBef>
-                <a:spcPts val="500"/>
-              </a:spcBef>
-              <a:buFont typeface="Arial" panose="020B0604020202020204" pitchFamily="34" charset="0"/>
-              <a:buChar char="•"/>
-              <a:defRPr sz="1800" kern="1200">
-                <a:solidFill>
-                  <a:schemeClr val="tx1"/>
-                </a:solidFill>
-                <a:latin typeface="+mn-lt"/>
-                <a:ea typeface="+mn-ea"/>
-                <a:cs typeface="+mn-cs"/>
-              </a:defRPr>
-            </a:lvl9pPr>
-          </a:lstStyle>
-          <a:p>
-            <a:pPr marL="0" indent="0">
-              <a:buNone/>
-            </a:pPr>
-            <a:endParaRPr lang="nl-NL" sz="2000" dirty="0"/>
-          </a:p>
-        </p:txBody>
-      </p:sp>
-      <p:sp>
-        <p:nvSpPr>
-          <p:cNvPr id="5" name="Content Placeholder 2">
-            <a:extLst>
-              <a:ext uri="{FF2B5EF4-FFF2-40B4-BE49-F238E27FC236}">
-                <a16:creationId xmlns:a16="http://schemas.microsoft.com/office/drawing/2014/main" id="{FE4D819A-A65A-B849-482E-28A9AA671928}"/>
-              </a:ext>
-            </a:extLst>
-          </p:cNvPr>
-          <p:cNvSpPr txBox="1">
-            <a:spLocks/>
-          </p:cNvSpPr>
-          <p:nvPr/>
-        </p:nvSpPr>
-        <p:spPr>
-          <a:xfrm>
-            <a:off x="6604000" y="1456267"/>
-            <a:ext cx="4749800" cy="4720696"/>
-          </a:xfrm>
-          <a:prstGeom prst="rect">
-            <a:avLst/>
-          </a:prstGeom>
-        </p:spPr>
-        <p:txBody>
-          <a:bodyPr vert="horz" lIns="91440" tIns="45720" rIns="91440" bIns="45720" rtlCol="0">
-            <a:normAutofit/>
-          </a:bodyPr>
-          <a:lstStyle>
-            <a:lvl1pPr marL="228600" indent="-228600" algn="l" defTabSz="914400" rtl="0" eaLnBrk="1" latinLnBrk="0" hangingPunct="1">
-              <a:lnSpc>
-                <a:spcPct val="90000"/>
-              </a:lnSpc>
-              <a:spcBef>
-                <a:spcPts val="1000"/>
-              </a:spcBef>
-              <a:buFont typeface="Arial" panose="020B0604020202020204" pitchFamily="34" charset="0"/>
-              <a:buChar char="•"/>
-              <a:defRPr sz="2800" kern="1200">
-                <a:solidFill>
-                  <a:schemeClr val="tx1"/>
-                </a:solidFill>
-                <a:latin typeface="+mn-lt"/>
-                <a:ea typeface="+mn-ea"/>
-                <a:cs typeface="+mn-cs"/>
-              </a:defRPr>
-            </a:lvl1pPr>
-            <a:lvl2pPr marL="685800" indent="-228600" algn="l" defTabSz="914400" rtl="0" eaLnBrk="1" latinLnBrk="0" hangingPunct="1">
-              <a:lnSpc>
-                <a:spcPct val="90000"/>
-              </a:lnSpc>
-              <a:spcBef>
-                <a:spcPts val="500"/>
-              </a:spcBef>
-              <a:buFont typeface="Arial" panose="020B0604020202020204" pitchFamily="34" charset="0"/>
-              <a:buChar char="•"/>
-              <a:defRPr sz="2400" kern="1200">
-                <a:solidFill>
-                  <a:schemeClr val="tx1"/>
-                </a:solidFill>
-                <a:latin typeface="+mn-lt"/>
-                <a:ea typeface="+mn-ea"/>
-                <a:cs typeface="+mn-cs"/>
-              </a:defRPr>
-            </a:lvl2pPr>
-            <a:lvl3pPr marL="1143000" indent="-228600" algn="l" defTabSz="914400" rtl="0" eaLnBrk="1" latinLnBrk="0" hangingPunct="1">
-              <a:lnSpc>
-                <a:spcPct val="90000"/>
-              </a:lnSpc>
-              <a:spcBef>
-                <a:spcPts val="500"/>
-              </a:spcBef>
-              <a:buFont typeface="Arial" panose="020B0604020202020204" pitchFamily="34" charset="0"/>
-              <a:buChar char="•"/>
-              <a:defRPr sz="2000" kern="1200">
-                <a:solidFill>
-                  <a:schemeClr val="tx1"/>
-                </a:solidFill>
-                <a:latin typeface="+mn-lt"/>
-                <a:ea typeface="+mn-ea"/>
-                <a:cs typeface="+mn-cs"/>
-              </a:defRPr>
-            </a:lvl3pPr>
-            <a:lvl4pPr marL="1600200" indent="-228600" algn="l" defTabSz="914400" rtl="0" eaLnBrk="1" latinLnBrk="0" hangingPunct="1">
-              <a:lnSpc>
-                <a:spcPct val="90000"/>
-              </a:lnSpc>
-              <a:spcBef>
-                <a:spcPts val="500"/>
-              </a:spcBef>
-              <a:buFont typeface="Arial" panose="020B0604020202020204" pitchFamily="34" charset="0"/>
-              <a:buChar char="•"/>
-              <a:defRPr sz="1800" kern="1200">
-                <a:solidFill>
-                  <a:schemeClr val="tx1"/>
-                </a:solidFill>
-                <a:latin typeface="+mn-lt"/>
-                <a:ea typeface="+mn-ea"/>
-                <a:cs typeface="+mn-cs"/>
-              </a:defRPr>
-            </a:lvl4pPr>
-            <a:lvl5pPr marL="2057400" indent="-228600" algn="l" defTabSz="914400" rtl="0" eaLnBrk="1" latinLnBrk="0" hangingPunct="1">
-              <a:lnSpc>
-                <a:spcPct val="90000"/>
-              </a:lnSpc>
-              <a:spcBef>
-                <a:spcPts val="500"/>
-              </a:spcBef>
-              <a:buFont typeface="Arial" panose="020B0604020202020204" pitchFamily="34" charset="0"/>
-              <a:buChar char="•"/>
-              <a:defRPr sz="1800" kern="1200">
-                <a:solidFill>
-                  <a:schemeClr val="tx1"/>
-                </a:solidFill>
-                <a:latin typeface="+mn-lt"/>
-                <a:ea typeface="+mn-ea"/>
-                <a:cs typeface="+mn-cs"/>
-              </a:defRPr>
-            </a:lvl5pPr>
-            <a:lvl6pPr marL="2514600" indent="-228600" algn="l" defTabSz="914400" rtl="0" eaLnBrk="1" latinLnBrk="0" hangingPunct="1">
-              <a:lnSpc>
-                <a:spcPct val="90000"/>
-              </a:lnSpc>
-              <a:spcBef>
-                <a:spcPts val="500"/>
-              </a:spcBef>
-              <a:buFont typeface="Arial" panose="020B0604020202020204" pitchFamily="34" charset="0"/>
-              <a:buChar char="•"/>
-              <a:defRPr sz="1800" kern="1200">
-                <a:solidFill>
-                  <a:schemeClr val="tx1"/>
-                </a:solidFill>
-                <a:latin typeface="+mn-lt"/>
-                <a:ea typeface="+mn-ea"/>
-                <a:cs typeface="+mn-cs"/>
-              </a:defRPr>
-            </a:lvl6pPr>
-            <a:lvl7pPr marL="2971800" indent="-228600" algn="l" defTabSz="914400" rtl="0" eaLnBrk="1" latinLnBrk="0" hangingPunct="1">
-              <a:lnSpc>
-                <a:spcPct val="90000"/>
-              </a:lnSpc>
-              <a:spcBef>
-                <a:spcPts val="500"/>
-              </a:spcBef>
-              <a:buFont typeface="Arial" panose="020B0604020202020204" pitchFamily="34" charset="0"/>
-              <a:buChar char="•"/>
-              <a:defRPr sz="1800" kern="1200">
-                <a:solidFill>
-                  <a:schemeClr val="tx1"/>
-                </a:solidFill>
-                <a:latin typeface="+mn-lt"/>
-                <a:ea typeface="+mn-ea"/>
-                <a:cs typeface="+mn-cs"/>
-              </a:defRPr>
-            </a:lvl7pPr>
-            <a:lvl8pPr marL="3429000" indent="-228600" algn="l" defTabSz="914400" rtl="0" eaLnBrk="1" latinLnBrk="0" hangingPunct="1">
-              <a:lnSpc>
-                <a:spcPct val="90000"/>
-              </a:lnSpc>
-              <a:spcBef>
-                <a:spcPts val="500"/>
-              </a:spcBef>
-              <a:buFont typeface="Arial" panose="020B0604020202020204" pitchFamily="34" charset="0"/>
-              <a:buChar char="•"/>
-              <a:defRPr sz="1800" kern="1200">
-                <a:solidFill>
-                  <a:schemeClr val="tx1"/>
-                </a:solidFill>
-                <a:latin typeface="+mn-lt"/>
-                <a:ea typeface="+mn-ea"/>
-                <a:cs typeface="+mn-cs"/>
-              </a:defRPr>
-            </a:lvl8pPr>
-            <a:lvl9pPr marL="3886200" indent="-228600" algn="l" defTabSz="914400" rtl="0" eaLnBrk="1" latinLnBrk="0" hangingPunct="1">
-              <a:lnSpc>
-                <a:spcPct val="90000"/>
-              </a:lnSpc>
-              <a:spcBef>
-                <a:spcPts val="500"/>
-              </a:spcBef>
-              <a:buFont typeface="Arial" panose="020B0604020202020204" pitchFamily="34" charset="0"/>
-              <a:buChar char="•"/>
-              <a:defRPr sz="1800" kern="1200">
-                <a:solidFill>
-                  <a:schemeClr val="tx1"/>
-                </a:solidFill>
-                <a:latin typeface="+mn-lt"/>
-                <a:ea typeface="+mn-ea"/>
-                <a:cs typeface="+mn-cs"/>
-              </a:defRPr>
-            </a:lvl9pPr>
-          </a:lstStyle>
-          <a:p>
-            <a:pPr marL="0" indent="0">
-              <a:lnSpc>
-                <a:spcPct val="100000"/>
-              </a:lnSpc>
-              <a:spcBef>
-                <a:spcPts val="0"/>
-              </a:spcBef>
-              <a:buFont typeface="Arial" panose="020B0604020202020204" pitchFamily="34" charset="0"/>
-              <a:buNone/>
-            </a:pPr>
-            <a:r>
-              <a:rPr lang="nl-NL" sz="1600" dirty="0" err="1">
-                <a:latin typeface="Courier New" panose="02070309020205020404" pitchFamily="49" charset="0"/>
-                <a:cs typeface="Courier New" panose="02070309020205020404" pitchFamily="49" charset="0"/>
-              </a:rPr>
-              <a:t>qs</a:t>
-            </a:r>
-            <a:r>
-              <a:rPr lang="nl-NL" sz="1600" dirty="0">
-                <a:latin typeface="Courier New" panose="02070309020205020404" pitchFamily="49" charset="0"/>
-                <a:cs typeface="Courier New" panose="02070309020205020404" pitchFamily="49" charset="0"/>
-              </a:rPr>
-              <a:t> = [</a:t>
-            </a:r>
-          </a:p>
-          <a:p>
-            <a:pPr marL="0" indent="0">
-              <a:lnSpc>
-                <a:spcPct val="100000"/>
-              </a:lnSpc>
-              <a:spcBef>
-                <a:spcPts val="0"/>
-              </a:spcBef>
-              <a:buFont typeface="Arial" panose="020B0604020202020204" pitchFamily="34" charset="0"/>
-              <a:buNone/>
-            </a:pPr>
-            <a:r>
-              <a:rPr lang="nl-NL" sz="1600" dirty="0">
-                <a:latin typeface="Courier New" panose="02070309020205020404" pitchFamily="49" charset="0"/>
-                <a:cs typeface="Courier New" panose="02070309020205020404" pitchFamily="49" charset="0"/>
-              </a:rPr>
-              <a:t>    _ ** 2 </a:t>
-            </a:r>
-            <a:r>
-              <a:rPr lang="nl-NL" sz="1600" dirty="0" err="1">
-                <a:solidFill>
-                  <a:srgbClr val="7030A0"/>
-                </a:solidFill>
-                <a:latin typeface="Courier New" panose="02070309020205020404" pitchFamily="49" charset="0"/>
-                <a:cs typeface="Courier New" panose="02070309020205020404" pitchFamily="49" charset="0"/>
-              </a:rPr>
-              <a:t>for</a:t>
-            </a:r>
-            <a:r>
-              <a:rPr lang="nl-NL" sz="1600" dirty="0">
-                <a:latin typeface="Courier New" panose="02070309020205020404" pitchFamily="49" charset="0"/>
-                <a:cs typeface="Courier New" panose="02070309020205020404" pitchFamily="49" charset="0"/>
-              </a:rPr>
-              <a:t> _ </a:t>
-            </a:r>
-            <a:r>
-              <a:rPr lang="nl-NL" sz="1600" dirty="0">
-                <a:solidFill>
-                  <a:srgbClr val="7030A0"/>
-                </a:solidFill>
-                <a:latin typeface="Courier New" panose="02070309020205020404" pitchFamily="49" charset="0"/>
-                <a:cs typeface="Courier New" panose="02070309020205020404" pitchFamily="49" charset="0"/>
-              </a:rPr>
-              <a:t>in</a:t>
-            </a:r>
-            <a:r>
-              <a:rPr lang="nl-NL" sz="1600" dirty="0">
-                <a:latin typeface="Courier New" panose="02070309020205020404" pitchFamily="49" charset="0"/>
-                <a:cs typeface="Courier New" panose="02070309020205020404" pitchFamily="49" charset="0"/>
-              </a:rPr>
-              <a:t> </a:t>
-            </a:r>
-            <a:r>
-              <a:rPr lang="nl-NL" sz="1600" dirty="0" err="1">
-                <a:latin typeface="Courier New" panose="02070309020205020404" pitchFamily="49" charset="0"/>
-                <a:cs typeface="Courier New" panose="02070309020205020404" pitchFamily="49" charset="0"/>
-              </a:rPr>
-              <a:t>my_list</a:t>
-            </a:r>
-            <a:endParaRPr lang="nl-NL" sz="1600" dirty="0">
-              <a:latin typeface="Courier New" panose="02070309020205020404" pitchFamily="49" charset="0"/>
-              <a:cs typeface="Courier New" panose="02070309020205020404" pitchFamily="49" charset="0"/>
-            </a:endParaRPr>
-          </a:p>
-          <a:p>
-            <a:pPr marL="0" indent="0">
-              <a:lnSpc>
-                <a:spcPct val="100000"/>
-              </a:lnSpc>
-              <a:spcBef>
-                <a:spcPts val="0"/>
-              </a:spcBef>
-              <a:buFont typeface="Arial" panose="020B0604020202020204" pitchFamily="34" charset="0"/>
-              <a:buNone/>
-            </a:pPr>
-            <a:r>
-              <a:rPr lang="nl-NL" sz="1600" dirty="0">
-                <a:latin typeface="Courier New" panose="02070309020205020404" pitchFamily="49" charset="0"/>
-                <a:cs typeface="Courier New" panose="02070309020205020404" pitchFamily="49" charset="0"/>
-              </a:rPr>
-              <a:t>    </a:t>
-            </a:r>
-            <a:r>
-              <a:rPr lang="nl-NL" sz="1600" dirty="0" err="1">
-                <a:solidFill>
-                  <a:srgbClr val="7030A0"/>
-                </a:solidFill>
-                <a:latin typeface="Courier New" panose="02070309020205020404" pitchFamily="49" charset="0"/>
-                <a:cs typeface="Courier New" panose="02070309020205020404" pitchFamily="49" charset="0"/>
-              </a:rPr>
-              <a:t>if</a:t>
-            </a:r>
-            <a:r>
-              <a:rPr lang="nl-NL" sz="1600" dirty="0">
-                <a:latin typeface="Courier New" panose="02070309020205020404" pitchFamily="49" charset="0"/>
-                <a:cs typeface="Courier New" panose="02070309020205020404" pitchFamily="49" charset="0"/>
-              </a:rPr>
-              <a:t> (</a:t>
-            </a:r>
-          </a:p>
-          <a:p>
-            <a:pPr marL="0" indent="0">
-              <a:lnSpc>
-                <a:spcPct val="100000"/>
-              </a:lnSpc>
-              <a:spcBef>
-                <a:spcPts val="0"/>
-              </a:spcBef>
-              <a:buFont typeface="Arial" panose="020B0604020202020204" pitchFamily="34" charset="0"/>
-              <a:buNone/>
-            </a:pPr>
-            <a:r>
-              <a:rPr lang="nl-NL" sz="1600" dirty="0">
-                <a:latin typeface="Courier New" panose="02070309020205020404" pitchFamily="49" charset="0"/>
-                <a:cs typeface="Courier New" panose="02070309020205020404" pitchFamily="49" charset="0"/>
-              </a:rPr>
-              <a:t>        type(_) </a:t>
-            </a:r>
-            <a:r>
-              <a:rPr lang="nl-NL" sz="1600" dirty="0">
-                <a:solidFill>
-                  <a:srgbClr val="7030A0"/>
-                </a:solidFill>
-                <a:latin typeface="Courier New" panose="02070309020205020404" pitchFamily="49" charset="0"/>
-                <a:cs typeface="Courier New" panose="02070309020205020404" pitchFamily="49" charset="0"/>
-              </a:rPr>
-              <a:t>in</a:t>
-            </a:r>
-            <a:r>
-              <a:rPr lang="nl-NL" sz="1600" dirty="0">
-                <a:latin typeface="Courier New" panose="02070309020205020404" pitchFamily="49" charset="0"/>
-                <a:cs typeface="Courier New" panose="02070309020205020404" pitchFamily="49" charset="0"/>
-              </a:rPr>
-              <a:t> (</a:t>
-            </a:r>
-            <a:r>
-              <a:rPr lang="nl-NL" sz="1600" dirty="0" err="1">
-                <a:solidFill>
-                  <a:schemeClr val="accent5">
-                    <a:lumMod val="75000"/>
-                  </a:schemeClr>
-                </a:solidFill>
-                <a:latin typeface="Courier New" panose="02070309020205020404" pitchFamily="49" charset="0"/>
-                <a:cs typeface="Courier New" panose="02070309020205020404" pitchFamily="49" charset="0"/>
-              </a:rPr>
-              <a:t>float</a:t>
-            </a:r>
-            <a:r>
-              <a:rPr lang="nl-NL" sz="1600" dirty="0">
-                <a:latin typeface="Courier New" panose="02070309020205020404" pitchFamily="49" charset="0"/>
-                <a:cs typeface="Courier New" panose="02070309020205020404" pitchFamily="49" charset="0"/>
-              </a:rPr>
-              <a:t>, </a:t>
-            </a:r>
-            <a:r>
-              <a:rPr lang="nl-NL" sz="1600" dirty="0">
-                <a:solidFill>
-                  <a:schemeClr val="accent5">
-                    <a:lumMod val="75000"/>
-                  </a:schemeClr>
-                </a:solidFill>
-                <a:latin typeface="Courier New" panose="02070309020205020404" pitchFamily="49" charset="0"/>
-                <a:cs typeface="Courier New" panose="02070309020205020404" pitchFamily="49" charset="0"/>
-              </a:rPr>
-              <a:t>int</a:t>
-            </a:r>
-            <a:r>
-              <a:rPr lang="nl-NL" sz="1600" dirty="0">
-                <a:latin typeface="Courier New" panose="02070309020205020404" pitchFamily="49" charset="0"/>
-                <a:cs typeface="Courier New" panose="02070309020205020404" pitchFamily="49" charset="0"/>
-              </a:rPr>
-              <a:t>)</a:t>
-            </a:r>
-          </a:p>
-          <a:p>
-            <a:pPr marL="0" indent="0">
-              <a:lnSpc>
-                <a:spcPct val="100000"/>
-              </a:lnSpc>
-              <a:spcBef>
-                <a:spcPts val="0"/>
-              </a:spcBef>
-              <a:buFont typeface="Arial" panose="020B0604020202020204" pitchFamily="34" charset="0"/>
-              <a:buNone/>
-            </a:pPr>
-            <a:r>
-              <a:rPr lang="nl-NL" sz="1600" dirty="0">
-                <a:latin typeface="Courier New" panose="02070309020205020404" pitchFamily="49" charset="0"/>
-                <a:cs typeface="Courier New" panose="02070309020205020404" pitchFamily="49" charset="0"/>
-              </a:rPr>
-              <a:t>        </a:t>
-            </a:r>
-            <a:r>
-              <a:rPr lang="nl-NL" sz="1600" dirty="0" err="1">
-                <a:solidFill>
-                  <a:srgbClr val="7030A0"/>
-                </a:solidFill>
-                <a:latin typeface="Courier New" panose="02070309020205020404" pitchFamily="49" charset="0"/>
-                <a:cs typeface="Courier New" panose="02070309020205020404" pitchFamily="49" charset="0"/>
-              </a:rPr>
-              <a:t>and</a:t>
-            </a:r>
-            <a:r>
-              <a:rPr lang="nl-NL" sz="1600" dirty="0">
-                <a:latin typeface="Courier New" panose="02070309020205020404" pitchFamily="49" charset="0"/>
-                <a:cs typeface="Courier New" panose="02070309020205020404" pitchFamily="49" charset="0"/>
-              </a:rPr>
-              <a:t> _ </a:t>
-            </a:r>
-            <a:r>
-              <a:rPr lang="nl-NL" sz="1600" dirty="0">
-                <a:solidFill>
-                  <a:srgbClr val="7030A0"/>
-                </a:solidFill>
-                <a:latin typeface="Courier New" panose="02070309020205020404" pitchFamily="49" charset="0"/>
-                <a:cs typeface="Courier New" panose="02070309020205020404" pitchFamily="49" charset="0"/>
-              </a:rPr>
-              <a:t>is </a:t>
-            </a:r>
-            <a:r>
-              <a:rPr lang="nl-NL" sz="1600" dirty="0" err="1">
-                <a:solidFill>
-                  <a:srgbClr val="7030A0"/>
-                </a:solidFill>
-                <a:latin typeface="Courier New" panose="02070309020205020404" pitchFamily="49" charset="0"/>
-                <a:cs typeface="Courier New" panose="02070309020205020404" pitchFamily="49" charset="0"/>
-              </a:rPr>
-              <a:t>not</a:t>
-            </a:r>
-            <a:r>
-              <a:rPr lang="nl-NL" sz="1600" dirty="0">
-                <a:latin typeface="Courier New" panose="02070309020205020404" pitchFamily="49" charset="0"/>
-                <a:cs typeface="Courier New" panose="02070309020205020404" pitchFamily="49" charset="0"/>
-              </a:rPr>
-              <a:t> </a:t>
-            </a:r>
-            <a:r>
-              <a:rPr lang="nl-NL" sz="1600" dirty="0">
-                <a:solidFill>
-                  <a:schemeClr val="accent5">
-                    <a:lumMod val="75000"/>
-                  </a:schemeClr>
-                </a:solidFill>
-                <a:latin typeface="Courier New" panose="02070309020205020404" pitchFamily="49" charset="0"/>
-                <a:cs typeface="Courier New" panose="02070309020205020404" pitchFamily="49" charset="0"/>
-              </a:rPr>
-              <a:t>None</a:t>
-            </a:r>
-          </a:p>
-          <a:p>
-            <a:pPr marL="0" indent="0">
-              <a:lnSpc>
-                <a:spcPct val="100000"/>
-              </a:lnSpc>
-              <a:spcBef>
-                <a:spcPts val="0"/>
-              </a:spcBef>
-              <a:buFont typeface="Arial" panose="020B0604020202020204" pitchFamily="34" charset="0"/>
-              <a:buNone/>
-            </a:pPr>
-            <a:r>
-              <a:rPr lang="nl-NL" sz="1600" dirty="0">
-                <a:latin typeface="Courier New" panose="02070309020205020404" pitchFamily="49" charset="0"/>
-                <a:cs typeface="Courier New" panose="02070309020205020404" pitchFamily="49" charset="0"/>
-              </a:rPr>
-              <a:t>        </a:t>
-            </a:r>
-            <a:r>
-              <a:rPr lang="nl-NL" sz="1600" dirty="0" err="1">
-                <a:solidFill>
-                  <a:srgbClr val="7030A0"/>
-                </a:solidFill>
-                <a:latin typeface="Courier New" panose="02070309020205020404" pitchFamily="49" charset="0"/>
-                <a:cs typeface="Courier New" panose="02070309020205020404" pitchFamily="49" charset="0"/>
-              </a:rPr>
-              <a:t>and</a:t>
-            </a:r>
-            <a:r>
-              <a:rPr lang="nl-NL" sz="1600" dirty="0">
-                <a:latin typeface="Courier New" panose="02070309020205020404" pitchFamily="49" charset="0"/>
-                <a:cs typeface="Courier New" panose="02070309020205020404" pitchFamily="49" charset="0"/>
-              </a:rPr>
-              <a:t> _ != 0</a:t>
-            </a:r>
-          </a:p>
-          <a:p>
-            <a:pPr marL="0" indent="0">
-              <a:lnSpc>
-                <a:spcPct val="100000"/>
-              </a:lnSpc>
-              <a:spcBef>
-                <a:spcPts val="0"/>
-              </a:spcBef>
-              <a:buFont typeface="Arial" panose="020B0604020202020204" pitchFamily="34" charset="0"/>
-              <a:buNone/>
-            </a:pPr>
-            <a:r>
-              <a:rPr lang="nl-NL" sz="1600" dirty="0">
-                <a:latin typeface="Courier New" panose="02070309020205020404" pitchFamily="49" charset="0"/>
-                <a:cs typeface="Courier New" panose="02070309020205020404" pitchFamily="49" charset="0"/>
-              </a:rPr>
-              <a:t>    )</a:t>
-            </a:r>
-          </a:p>
-          <a:p>
-            <a:pPr marL="0" indent="0">
-              <a:lnSpc>
-                <a:spcPct val="100000"/>
-              </a:lnSpc>
-              <a:spcBef>
-                <a:spcPts val="0"/>
-              </a:spcBef>
-              <a:buFont typeface="Arial" panose="020B0604020202020204" pitchFamily="34" charset="0"/>
-              <a:buNone/>
-            </a:pPr>
-            <a:r>
-              <a:rPr lang="nl-NL" sz="1600" dirty="0">
-                <a:latin typeface="Courier New" panose="02070309020205020404" pitchFamily="49" charset="0"/>
-                <a:cs typeface="Courier New" panose="02070309020205020404" pitchFamily="49" charset="0"/>
-              </a:rPr>
-              <a:t>]</a:t>
-            </a:r>
-          </a:p>
-        </p:txBody>
-      </p:sp>
-      <p:cxnSp>
-        <p:nvCxnSpPr>
-          <p:cNvPr id="6" name="Straight Connector 5">
-            <a:extLst>
-              <a:ext uri="{FF2B5EF4-FFF2-40B4-BE49-F238E27FC236}">
-                <a16:creationId xmlns:a16="http://schemas.microsoft.com/office/drawing/2014/main" id="{4E630EC8-816A-E473-7194-8B2BB5384102}"/>
-              </a:ext>
-            </a:extLst>
-          </p:cNvPr>
-          <p:cNvCxnSpPr>
-            <a:cxnSpLocks/>
-          </p:cNvCxnSpPr>
-          <p:nvPr/>
-        </p:nvCxnSpPr>
-        <p:spPr>
-          <a:xfrm>
-            <a:off x="5960533" y="1388533"/>
-            <a:ext cx="0" cy="4788430"/>
-          </a:xfrm>
-          <a:prstGeom prst="line">
-            <a:avLst/>
-          </a:prstGeom>
-        </p:spPr>
-        <p:style>
-          <a:lnRef idx="3">
-            <a:schemeClr val="dk1"/>
-          </a:lnRef>
-          <a:fillRef idx="0">
-            <a:schemeClr val="dk1"/>
-          </a:fillRef>
-          <a:effectRef idx="2">
-            <a:schemeClr val="dk1"/>
-          </a:effectRef>
-          <a:fontRef idx="minor">
-            <a:schemeClr val="tx1"/>
-          </a:fontRef>
-        </p:style>
-      </p:cxnSp>
-    </p:spTree>
-    <p:extLst>
-      <p:ext uri="{BB962C8B-B14F-4D97-AF65-F5344CB8AC3E}">
-        <p14:creationId xmlns:p14="http://schemas.microsoft.com/office/powerpoint/2010/main" val="2370871397"/>
-      </p:ext>
-    </p:extLst>
-  </p:cSld>
-  <p:clrMapOvr>
-    <a:masterClrMapping/>
-  </p:clrMapOvr>
-</p:sld>
-</file>
-
-<file path=ppt/slides/slide50.xml><?xml version="1.0" encoding="utf-8"?>
+<file path=ppt/slides/slide52.xml><?xml version="1.0" encoding="utf-8"?>
 <p:sld xmlns:a="http://schemas.openxmlformats.org/drawingml/2006/main" xmlns:r="http://schemas.openxmlformats.org/officeDocument/2006/relationships" xmlns:p="http://schemas.openxmlformats.org/presentationml/2006/main">
   <p:cSld>
     <p:spTree>
@@ -29103,7 +30083,7 @@
 </p:sld>
 </file>
 
-<file path=ppt/slides/slide51.xml><?xml version="1.0" encoding="utf-8"?>
+<file path=ppt/slides/slide53.xml><?xml version="1.0" encoding="utf-8"?>
 <p:sld xmlns:a="http://schemas.openxmlformats.org/drawingml/2006/main" xmlns:r="http://schemas.openxmlformats.org/officeDocument/2006/relationships" xmlns:p="http://schemas.openxmlformats.org/presentationml/2006/main">
   <p:cSld>
     <p:spTree>
@@ -29306,7 +30286,7 @@
 </p:sld>
 </file>
 
-<file path=ppt/slides/slide52.xml><?xml version="1.0" encoding="utf-8"?>
+<file path=ppt/slides/slide54.xml><?xml version="1.0" encoding="utf-8"?>
 <p:sld xmlns:a="http://schemas.openxmlformats.org/drawingml/2006/main" xmlns:r="http://schemas.openxmlformats.org/officeDocument/2006/relationships" xmlns:p="http://schemas.openxmlformats.org/presentationml/2006/main">
   <p:cSld>
     <p:spTree>
@@ -30047,7 +31027,7 @@
 </p:sld>
 </file>
 
-<file path=ppt/slides/slide53.xml><?xml version="1.0" encoding="utf-8"?>
+<file path=ppt/slides/slide55.xml><?xml version="1.0" encoding="utf-8"?>
 <p:sld xmlns:a="http://schemas.openxmlformats.org/drawingml/2006/main" xmlns:r="http://schemas.openxmlformats.org/officeDocument/2006/relationships" xmlns:p="http://schemas.openxmlformats.org/presentationml/2006/main">
   <p:cSld>
     <p:spTree>
@@ -30137,7 +31117,7 @@
 </p:sld>
 </file>
 
-<file path=ppt/slides/slide54.xml><?xml version="1.0" encoding="utf-8"?>
+<file path=ppt/slides/slide56.xml><?xml version="1.0" encoding="utf-8"?>
 <p:sld xmlns:a="http://schemas.openxmlformats.org/drawingml/2006/main" xmlns:r="http://schemas.openxmlformats.org/officeDocument/2006/relationships" xmlns:p="http://schemas.openxmlformats.org/presentationml/2006/main">
   <p:cSld>
     <p:spTree>
@@ -30629,7 +31609,7 @@
 </p:sld>
 </file>
 
-<file path=ppt/slides/slide55.xml><?xml version="1.0" encoding="utf-8"?>
+<file path=ppt/slides/slide57.xml><?xml version="1.0" encoding="utf-8"?>
 <p:sld xmlns:a="http://schemas.openxmlformats.org/drawingml/2006/main" xmlns:r="http://schemas.openxmlformats.org/officeDocument/2006/relationships" xmlns:p="http://schemas.openxmlformats.org/presentationml/2006/main">
   <p:cSld>
     <p:spTree>
@@ -30724,7 +31704,7 @@
 </p:sld>
 </file>
 
-<file path=ppt/slides/slide56.xml><?xml version="1.0" encoding="utf-8"?>
+<file path=ppt/slides/slide58.xml><?xml version="1.0" encoding="utf-8"?>
 <p:sld xmlns:a="http://schemas.openxmlformats.org/drawingml/2006/main" xmlns:r="http://schemas.openxmlformats.org/officeDocument/2006/relationships" xmlns:p="http://schemas.openxmlformats.org/presentationml/2006/main">
   <p:cSld>
     <p:spTree>

</xml_diff>